<commit_message>
feat(academy): enrich course materials with icons and varied layouts
Replace plain-text PPTX/PDF course materials with visually enriched
versions featuring embedded react-icons illustrations, color-coded
module themes, varied slide layouts (two-column, icon grids, callout
boxes, key point cards), and professional typography. Add Module-02
(Sécurité et portefeuilles) materials. All 11 modules now have
significantly richer visual presentations.

Co-Authored-By: Claude Opus 4.6 <noreply@anthropic.com>
Claude-Session: https://claude.ai/code/session_01KvTqkFzwbnrsqrPMPCEyWj
</commit_message>
<xml_diff>
--- a/public/course-materials/pptx/Module-01-Les-fondamentaux-de-la-blockchain.pptx
+++ b/public/course-materials/pptx/Module-01-Les-fondamentaux-de-la-blockchain.pptx
@@ -1773,28 +1773,96 @@
         </p:nvSpPr>
         <p:spPr>
           <a:xfrm>
+            <a:off x="6400800" y="-457200"/>
+            <a:ext cx="3657600" cy="3657600"/>
+          </a:xfrm>
+          <a:prstGeom prst="ellipse">
+            <a:avLst/>
+          </a:prstGeom>
+          <a:solidFill>
+            <a:srgbClr val="3B82F6">
+              <a:alpha val="8000"/>
+            </a:srgbClr>
+          </a:solidFill>
+          <a:ln/>
+        </p:spPr>
+      </p:sp>
+      <p:sp>
+        <p:nvSpPr>
+          <p:cNvPr id="3" name="Shape 1"/>
+          <p:cNvSpPr/>
+          <p:nvPr/>
+        </p:nvSpPr>
+        <p:spPr>
+          <a:xfrm>
+            <a:off x="7315200" y="2286000"/>
+            <a:ext cx="2743200" cy="2743200"/>
+          </a:xfrm>
+          <a:prstGeom prst="ellipse">
+            <a:avLst/>
+          </a:prstGeom>
+          <a:solidFill>
+            <a:srgbClr val="3B82F6">
+              <a:alpha val="5000"/>
+            </a:srgbClr>
+          </a:solidFill>
+          <a:ln/>
+        </p:spPr>
+      </p:sp>
+      <p:sp>
+        <p:nvSpPr>
+          <p:cNvPr id="4" name="Shape 2"/>
+          <p:cNvSpPr/>
+          <p:nvPr/>
+        </p:nvSpPr>
+        <p:spPr>
+          <a:xfrm>
             <a:off x="0" y="0"/>
-            <a:ext cx="9144000" cy="54864"/>
+            <a:ext cx="9144000" cy="45720"/>
           </a:xfrm>
           <a:prstGeom prst="rect">
             <a:avLst/>
           </a:prstGeom>
           <a:solidFill>
-            <a:srgbClr val="00BFA6"/>
+            <a:srgbClr val="3B82F6"/>
           </a:solidFill>
           <a:ln/>
         </p:spPr>
       </p:sp>
-      <p:sp>
-        <p:nvSpPr>
-          <p:cNvPr id="3" name="Text 1"/>
+      <p:pic>
+        <p:nvPicPr>
+          <p:cNvPr id="5" name="Image 0" descr="preencoded.png">    </p:cNvPr>
+          <p:cNvPicPr>
+            <a:picLocks noChangeAspect="1"/>
+          </p:cNvPicPr>
+          <p:nvPr/>
+        </p:nvPicPr>
+        <p:blipFill>
+          <a:blip r:embed="rId1"/>
+          <a:stretch>
+            <a:fillRect/>
+          </a:stretch>
+        </p:blipFill>
+        <p:spPr>
+          <a:xfrm>
+            <a:off x="7132320" y="1097280"/>
+            <a:ext cx="1463040" cy="1463040"/>
+          </a:xfrm>
+          <a:prstGeom prst="rect">
+            <a:avLst/>
+          </a:prstGeom>
+        </p:spPr>
+      </p:pic>
+      <p:sp>
+        <p:nvSpPr>
+          <p:cNvPr id="6" name="Text 3"/>
           <p:cNvSpPr txBox="1"/>
           <p:nvPr/>
         </p:nvSpPr>
         <p:spPr>
           <a:xfrm>
-            <a:off x="731520" y="1097280"/>
-            <a:ext cx="2286000" cy="457200"/>
+            <a:off x="731520" y="914400"/>
+            <a:ext cx="2286000" cy="365760"/>
           </a:xfrm>
           <a:prstGeom prst="rect">
             <a:avLst/>
@@ -1810,9 +1878,9 @@
               <a:buNone/>
             </a:pPr>
             <a:r>
-              <a:rPr lang="en-US" sz="1400" b="1" spc="400" kern="0" dirty="0">
-                <a:solidFill>
-                  <a:srgbClr val="00BFA6"/>
+              <a:rPr lang="en-US" sz="1300" b="1" spc="400" kern="0" dirty="0">
+                <a:solidFill>
+                  <a:srgbClr val="3B82F6"/>
                 </a:solidFill>
                 <a:latin typeface="Calibri" pitchFamily="34" charset="0"/>
                 <a:ea typeface="Calibri" pitchFamily="34" charset="-122"/>
@@ -1820,20 +1888,20 @@
               </a:rPr>
               <a:t>MODULE 1</a:t>
             </a:r>
-            <a:endParaRPr lang="en-US" sz="1400" dirty="0"/>
-          </a:p>
-        </p:txBody>
-      </p:sp>
-      <p:sp>
-        <p:nvSpPr>
-          <p:cNvPr id="4" name="Text 2"/>
+            <a:endParaRPr lang="en-US" sz="1300" dirty="0"/>
+          </a:p>
+        </p:txBody>
+      </p:sp>
+      <p:sp>
+        <p:nvSpPr>
+          <p:cNvPr id="7" name="Text 4"/>
           <p:cNvSpPr txBox="1"/>
           <p:nvPr/>
         </p:nvSpPr>
         <p:spPr>
           <a:xfrm>
-            <a:off x="731520" y="1645920"/>
-            <a:ext cx="7680960" cy="1463040"/>
+            <a:off x="731520" y="1371600"/>
+            <a:ext cx="5943600" cy="1645920"/>
           </a:xfrm>
           <a:prstGeom prst="rect">
             <a:avLst/>
@@ -1865,14 +1933,34 @@
       </p:sp>
       <p:sp>
         <p:nvSpPr>
-          <p:cNvPr id="5" name="Text 3"/>
+          <p:cNvPr id="8" name="Shape 5"/>
+          <p:cNvSpPr/>
+          <p:nvPr/>
+        </p:nvSpPr>
+        <p:spPr>
+          <a:xfrm>
+            <a:off x="731520" y="3291840"/>
+            <a:ext cx="1828800" cy="36576"/>
+          </a:xfrm>
+          <a:prstGeom prst="rect">
+            <a:avLst/>
+          </a:prstGeom>
+          <a:solidFill>
+            <a:srgbClr val="3B82F6"/>
+          </a:solidFill>
+          <a:ln/>
+        </p:spPr>
+      </p:sp>
+      <p:sp>
+        <p:nvSpPr>
+          <p:cNvPr id="9" name="Text 6"/>
           <p:cNvSpPr txBox="1"/>
           <p:nvPr/>
         </p:nvSpPr>
         <p:spPr>
           <a:xfrm>
-            <a:off x="731520" y="4023360"/>
-            <a:ext cx="2743200" cy="365760"/>
+            <a:off x="731520" y="3566160"/>
+            <a:ext cx="2743200" cy="320040"/>
           </a:xfrm>
           <a:prstGeom prst="rect">
             <a:avLst/>
@@ -1888,7 +1976,7 @@
               <a:buNone/>
             </a:pPr>
             <a:r>
-              <a:rPr lang="en-US" sz="1200" spc="300" kern="0" dirty="0">
+              <a:rPr lang="en-US" sz="1100" spc="300" kern="0" dirty="0">
                 <a:solidFill>
                   <a:srgbClr val="64748B"/>
                 </a:solidFill>
@@ -1898,20 +1986,20 @@
               </a:rPr>
               <a:t>TEREX ACADEMY</a:t>
             </a:r>
-            <a:endParaRPr lang="en-US" sz="1200" dirty="0"/>
-          </a:p>
-        </p:txBody>
-      </p:sp>
-      <p:sp>
-        <p:nvSpPr>
-          <p:cNvPr id="6" name="Text 4"/>
+            <a:endParaRPr lang="en-US" sz="1100" dirty="0"/>
+          </a:p>
+        </p:txBody>
+      </p:sp>
+      <p:sp>
+        <p:nvSpPr>
+          <p:cNvPr id="10" name="Text 7"/>
           <p:cNvSpPr txBox="1"/>
           <p:nvPr/>
         </p:nvSpPr>
         <p:spPr>
           <a:xfrm>
-            <a:off x="731520" y="4389120"/>
-            <a:ext cx="3657600" cy="320040"/>
+            <a:off x="731520" y="3931920"/>
+            <a:ext cx="3657600" cy="274320"/>
           </a:xfrm>
           <a:prstGeom prst="rect">
             <a:avLst/>
@@ -1973,16 +2061,40 @@
           <a:chExt cx="0" cy="0"/>
         </a:xfrm>
       </p:grpSpPr>
-      <p:sp>
-        <p:nvSpPr>
-          <p:cNvPr id="2" name="Text 0"/>
+      <p:pic>
+        <p:nvPicPr>
+          <p:cNvPr id="2" name="Image 0" descr="preencoded.png">    </p:cNvPr>
+          <p:cNvPicPr>
+            <a:picLocks noChangeAspect="1"/>
+          </p:cNvPicPr>
+          <p:nvPr/>
+        </p:nvPicPr>
+        <p:blipFill>
+          <a:blip r:embed="rId1"/>
+          <a:stretch>
+            <a:fillRect/>
+          </a:stretch>
+        </p:blipFill>
+        <p:spPr>
+          <a:xfrm>
+            <a:off x="731520" y="320040"/>
+            <a:ext cx="457200" cy="457200"/>
+          </a:xfrm>
+          <a:prstGeom prst="rect">
+            <a:avLst/>
+          </a:prstGeom>
+        </p:spPr>
+      </p:pic>
+      <p:sp>
+        <p:nvSpPr>
+          <p:cNvPr id="3" name="Text 0"/>
           <p:cNvSpPr txBox="1"/>
           <p:nvPr/>
         </p:nvSpPr>
         <p:spPr>
           <a:xfrm>
-            <a:off x="731520" y="457200"/>
-            <a:ext cx="2743200" cy="365760"/>
+            <a:off x="1280160" y="365760"/>
+            <a:ext cx="2743200" cy="320040"/>
           </a:xfrm>
           <a:prstGeom prst="rect">
             <a:avLst/>
@@ -2014,14 +2126,14 @@
       </p:sp>
       <p:sp>
         <p:nvSpPr>
-          <p:cNvPr id="3" name="Text 1"/>
+          <p:cNvPr id="4" name="Text 1"/>
           <p:cNvSpPr txBox="1"/>
           <p:nvPr/>
         </p:nvSpPr>
         <p:spPr>
           <a:xfrm>
-            <a:off x="731520" y="868680"/>
-            <a:ext cx="7680960" cy="502920"/>
+            <a:off x="731520" y="822960"/>
+            <a:ext cx="7680960" cy="457200"/>
           </a:xfrm>
           <a:prstGeom prst="rect">
             <a:avLst/>
@@ -2037,7 +2149,7 @@
               <a:buNone/>
             </a:pPr>
             <a:r>
-              <a:rPr lang="en-US" sz="2200" b="1" dirty="0">
+              <a:rPr lang="en-US" sz="2000" b="1" dirty="0">
                 <a:solidFill>
                   <a:srgbClr val="FFFFFF"/>
                 </a:solidFill>
@@ -2047,28 +2159,50 @@
               </a:rPr>
               <a:t>L'histoire du Bitcoin</a:t>
             </a:r>
-            <a:endParaRPr lang="en-US" sz="2200" dirty="0"/>
-          </a:p>
-        </p:txBody>
-      </p:sp>
-      <p:sp>
-        <p:nvSpPr>
-          <p:cNvPr id="4" name="Text 2"/>
-          <p:cNvSpPr txBox="1"/>
-          <p:nvPr/>
-        </p:nvSpPr>
-        <p:spPr>
-          <a:xfrm>
-            <a:off x="731520" y="1554480"/>
-            <a:ext cx="457200" cy="548640"/>
+            <a:endParaRPr lang="en-US" sz="2000" dirty="0"/>
+          </a:p>
+        </p:txBody>
+      </p:sp>
+      <p:sp>
+        <p:nvSpPr>
+          <p:cNvPr id="5" name="Shape 2"/>
+          <p:cNvSpPr/>
+          <p:nvPr/>
+        </p:nvSpPr>
+        <p:spPr>
+          <a:xfrm>
+            <a:off x="731520" y="1463040"/>
+            <a:ext cx="7680960" cy="548640"/>
           </a:xfrm>
           <a:prstGeom prst="roundRect">
             <a:avLst>
-              <a:gd name="adj" fmla="val 50000"/>
+              <a:gd name="adj" fmla="val 13333"/>
             </a:avLst>
           </a:prstGeom>
           <a:solidFill>
-            <a:srgbClr val="00BFA6"/>
+            <a:srgbClr val="0F1419"/>
+          </a:solidFill>
+          <a:ln/>
+        </p:spPr>
+      </p:sp>
+      <p:sp>
+        <p:nvSpPr>
+          <p:cNvPr id="6" name="Text 3"/>
+          <p:cNvSpPr txBox="1"/>
+          <p:nvPr/>
+        </p:nvSpPr>
+        <p:spPr>
+          <a:xfrm>
+            <a:off x="914400" y="1463040"/>
+            <a:ext cx="411480" cy="548640"/>
+          </a:xfrm>
+          <a:prstGeom prst="roundRect">
+            <a:avLst>
+              <a:gd name="adj" fmla="val 48889"/>
+            </a:avLst>
+          </a:prstGeom>
+          <a:solidFill>
+            <a:srgbClr val="3B82F6"/>
           </a:solidFill>
           <a:ln/>
         </p:spPr>
@@ -2080,7 +2214,7 @@
               <a:buNone/>
             </a:pPr>
             <a:r>
-              <a:rPr lang="en-US" sz="1600" b="1" dirty="0">
+              <a:rPr lang="en-US" sz="1500" b="1" dirty="0">
                 <a:solidFill>
                   <a:srgbClr val="0F1419"/>
                 </a:solidFill>
@@ -2090,20 +2224,20 @@
               </a:rPr>
               <a:t>1</a:t>
             </a:r>
-            <a:endParaRPr lang="en-US" sz="1600" dirty="0"/>
-          </a:p>
-        </p:txBody>
-      </p:sp>
-      <p:sp>
-        <p:nvSpPr>
-          <p:cNvPr id="5" name="Text 3"/>
+            <a:endParaRPr lang="en-US" sz="1500" dirty="0"/>
+          </a:p>
+        </p:txBody>
+      </p:sp>
+      <p:sp>
+        <p:nvSpPr>
+          <p:cNvPr id="7" name="Text 4"/>
           <p:cNvSpPr txBox="1"/>
           <p:nvPr/>
         </p:nvSpPr>
         <p:spPr>
           <a:xfrm>
-            <a:off x="1371600" y="1554480"/>
-            <a:ext cx="7040880" cy="548640"/>
+            <a:off x="1508760" y="1463040"/>
+            <a:ext cx="6766560" cy="548640"/>
           </a:xfrm>
           <a:prstGeom prst="rect">
             <a:avLst/>
@@ -2119,7 +2253,7 @@
               <a:buNone/>
             </a:pPr>
             <a:r>
-              <a:rPr lang="en-US" sz="1400" dirty="0">
+              <a:rPr lang="en-US" sz="1300" dirty="0">
                 <a:solidFill>
                   <a:srgbClr val="FFFFFF"/>
                 </a:solidFill>
@@ -2129,28 +2263,50 @@
               </a:rPr>
               <a:t>2008 — Satoshi Nakamoto publie le white paper "Bitcoin: A Peer-to-Peer Electronic Cash System"</a:t>
             </a:r>
-            <a:endParaRPr lang="en-US" sz="1400" dirty="0"/>
-          </a:p>
-        </p:txBody>
-      </p:sp>
-      <p:sp>
-        <p:nvSpPr>
-          <p:cNvPr id="6" name="Text 4"/>
-          <p:cNvSpPr txBox="1"/>
-          <p:nvPr/>
-        </p:nvSpPr>
-        <p:spPr>
-          <a:xfrm>
-            <a:off x="731520" y="2212848"/>
-            <a:ext cx="457200" cy="548640"/>
+            <a:endParaRPr lang="en-US" sz="1300" dirty="0"/>
+          </a:p>
+        </p:txBody>
+      </p:sp>
+      <p:sp>
+        <p:nvSpPr>
+          <p:cNvPr id="8" name="Shape 5"/>
+          <p:cNvSpPr/>
+          <p:nvPr/>
+        </p:nvSpPr>
+        <p:spPr>
+          <a:xfrm>
+            <a:off x="731520" y="2103120"/>
+            <a:ext cx="7680960" cy="548640"/>
           </a:xfrm>
           <a:prstGeom prst="roundRect">
             <a:avLst>
-              <a:gd name="adj" fmla="val 50000"/>
+              <a:gd name="adj" fmla="val 13333"/>
             </a:avLst>
           </a:prstGeom>
           <a:solidFill>
-            <a:srgbClr val="00BFA6"/>
+            <a:srgbClr val="0F1419"/>
+          </a:solidFill>
+          <a:ln/>
+        </p:spPr>
+      </p:sp>
+      <p:sp>
+        <p:nvSpPr>
+          <p:cNvPr id="9" name="Text 6"/>
+          <p:cNvSpPr txBox="1"/>
+          <p:nvPr/>
+        </p:nvSpPr>
+        <p:spPr>
+          <a:xfrm>
+            <a:off x="914400" y="2103120"/>
+            <a:ext cx="411480" cy="548640"/>
+          </a:xfrm>
+          <a:prstGeom prst="roundRect">
+            <a:avLst>
+              <a:gd name="adj" fmla="val 48889"/>
+            </a:avLst>
+          </a:prstGeom>
+          <a:solidFill>
+            <a:srgbClr val="3B82F6"/>
           </a:solidFill>
           <a:ln/>
         </p:spPr>
@@ -2162,7 +2318,7 @@
               <a:buNone/>
             </a:pPr>
             <a:r>
-              <a:rPr lang="en-US" sz="1600" b="1" dirty="0">
+              <a:rPr lang="en-US" sz="1500" b="1" dirty="0">
                 <a:solidFill>
                   <a:srgbClr val="0F1419"/>
                 </a:solidFill>
@@ -2172,20 +2328,20 @@
               </a:rPr>
               <a:t>2</a:t>
             </a:r>
-            <a:endParaRPr lang="en-US" sz="1600" dirty="0"/>
-          </a:p>
-        </p:txBody>
-      </p:sp>
-      <p:sp>
-        <p:nvSpPr>
-          <p:cNvPr id="7" name="Text 5"/>
+            <a:endParaRPr lang="en-US" sz="1500" dirty="0"/>
+          </a:p>
+        </p:txBody>
+      </p:sp>
+      <p:sp>
+        <p:nvSpPr>
+          <p:cNvPr id="10" name="Text 7"/>
           <p:cNvSpPr txBox="1"/>
           <p:nvPr/>
         </p:nvSpPr>
         <p:spPr>
           <a:xfrm>
-            <a:off x="1371600" y="2212848"/>
-            <a:ext cx="7040880" cy="548640"/>
+            <a:off x="1508760" y="2103120"/>
+            <a:ext cx="6766560" cy="548640"/>
           </a:xfrm>
           <a:prstGeom prst="rect">
             <a:avLst/>
@@ -2201,7 +2357,7 @@
               <a:buNone/>
             </a:pPr>
             <a:r>
-              <a:rPr lang="en-US" sz="1400" dirty="0">
+              <a:rPr lang="en-US" sz="1300" dirty="0">
                 <a:solidFill>
                   <a:srgbClr val="FFFFFF"/>
                 </a:solidFill>
@@ -2211,28 +2367,50 @@
               </a:rPr>
               <a:t>2009 — Le premier bloc Bitcoin (bloc Genesis) est miné le 3 janvier</a:t>
             </a:r>
-            <a:endParaRPr lang="en-US" sz="1400" dirty="0"/>
-          </a:p>
-        </p:txBody>
-      </p:sp>
-      <p:sp>
-        <p:nvSpPr>
-          <p:cNvPr id="8" name="Text 6"/>
-          <p:cNvSpPr txBox="1"/>
-          <p:nvPr/>
-        </p:nvSpPr>
-        <p:spPr>
-          <a:xfrm>
-            <a:off x="731520" y="2871216"/>
-            <a:ext cx="457200" cy="548640"/>
+            <a:endParaRPr lang="en-US" sz="1300" dirty="0"/>
+          </a:p>
+        </p:txBody>
+      </p:sp>
+      <p:sp>
+        <p:nvSpPr>
+          <p:cNvPr id="11" name="Shape 8"/>
+          <p:cNvSpPr/>
+          <p:nvPr/>
+        </p:nvSpPr>
+        <p:spPr>
+          <a:xfrm>
+            <a:off x="731520" y="2743200"/>
+            <a:ext cx="7680960" cy="548640"/>
           </a:xfrm>
           <a:prstGeom prst="roundRect">
             <a:avLst>
-              <a:gd name="adj" fmla="val 50000"/>
+              <a:gd name="adj" fmla="val 13333"/>
             </a:avLst>
           </a:prstGeom>
           <a:solidFill>
-            <a:srgbClr val="00BFA6"/>
+            <a:srgbClr val="0F1419"/>
+          </a:solidFill>
+          <a:ln/>
+        </p:spPr>
+      </p:sp>
+      <p:sp>
+        <p:nvSpPr>
+          <p:cNvPr id="12" name="Text 9"/>
+          <p:cNvSpPr txBox="1"/>
+          <p:nvPr/>
+        </p:nvSpPr>
+        <p:spPr>
+          <a:xfrm>
+            <a:off x="914400" y="2743200"/>
+            <a:ext cx="411480" cy="548640"/>
+          </a:xfrm>
+          <a:prstGeom prst="roundRect">
+            <a:avLst>
+              <a:gd name="adj" fmla="val 48889"/>
+            </a:avLst>
+          </a:prstGeom>
+          <a:solidFill>
+            <a:srgbClr val="3B82F6"/>
           </a:solidFill>
           <a:ln/>
         </p:spPr>
@@ -2244,7 +2422,7 @@
               <a:buNone/>
             </a:pPr>
             <a:r>
-              <a:rPr lang="en-US" sz="1600" b="1" dirty="0">
+              <a:rPr lang="en-US" sz="1500" b="1" dirty="0">
                 <a:solidFill>
                   <a:srgbClr val="0F1419"/>
                 </a:solidFill>
@@ -2254,20 +2432,20 @@
               </a:rPr>
               <a:t>3</a:t>
             </a:r>
-            <a:endParaRPr lang="en-US" sz="1600" dirty="0"/>
-          </a:p>
-        </p:txBody>
-      </p:sp>
-      <p:sp>
-        <p:nvSpPr>
-          <p:cNvPr id="9" name="Text 7"/>
+            <a:endParaRPr lang="en-US" sz="1500" dirty="0"/>
+          </a:p>
+        </p:txBody>
+      </p:sp>
+      <p:sp>
+        <p:nvSpPr>
+          <p:cNvPr id="13" name="Text 10"/>
           <p:cNvSpPr txBox="1"/>
           <p:nvPr/>
         </p:nvSpPr>
         <p:spPr>
           <a:xfrm>
-            <a:off x="1371600" y="2871216"/>
-            <a:ext cx="7040880" cy="548640"/>
+            <a:off x="1508760" y="2743200"/>
+            <a:ext cx="6766560" cy="548640"/>
           </a:xfrm>
           <a:prstGeom prst="rect">
             <a:avLst/>
@@ -2283,7 +2461,7 @@
               <a:buNone/>
             </a:pPr>
             <a:r>
-              <a:rPr lang="en-US" sz="1400" dirty="0">
+              <a:rPr lang="en-US" sz="1300" dirty="0">
                 <a:solidFill>
                   <a:srgbClr val="FFFFFF"/>
                 </a:solidFill>
@@ -2293,28 +2471,50 @@
               </a:rPr>
               <a:t>2010 — Première transaction réelle : 10 000 BTC pour 2 pizzas (aujourd'hui plusieurs centaines de millions de dollars)</a:t>
             </a:r>
-            <a:endParaRPr lang="en-US" sz="1400" dirty="0"/>
-          </a:p>
-        </p:txBody>
-      </p:sp>
-      <p:sp>
-        <p:nvSpPr>
-          <p:cNvPr id="10" name="Text 8"/>
-          <p:cNvSpPr txBox="1"/>
-          <p:nvPr/>
-        </p:nvSpPr>
-        <p:spPr>
-          <a:xfrm>
-            <a:off x="731520" y="3529584"/>
-            <a:ext cx="457200" cy="548640"/>
+            <a:endParaRPr lang="en-US" sz="1300" dirty="0"/>
+          </a:p>
+        </p:txBody>
+      </p:sp>
+      <p:sp>
+        <p:nvSpPr>
+          <p:cNvPr id="14" name="Shape 11"/>
+          <p:cNvSpPr/>
+          <p:nvPr/>
+        </p:nvSpPr>
+        <p:spPr>
+          <a:xfrm>
+            <a:off x="731520" y="3383280"/>
+            <a:ext cx="7680960" cy="548640"/>
           </a:xfrm>
           <a:prstGeom prst="roundRect">
             <a:avLst>
-              <a:gd name="adj" fmla="val 50000"/>
+              <a:gd name="adj" fmla="val 13333"/>
             </a:avLst>
           </a:prstGeom>
           <a:solidFill>
-            <a:srgbClr val="00BFA6"/>
+            <a:srgbClr val="0F1419"/>
+          </a:solidFill>
+          <a:ln/>
+        </p:spPr>
+      </p:sp>
+      <p:sp>
+        <p:nvSpPr>
+          <p:cNvPr id="15" name="Text 12"/>
+          <p:cNvSpPr txBox="1"/>
+          <p:nvPr/>
+        </p:nvSpPr>
+        <p:spPr>
+          <a:xfrm>
+            <a:off x="914400" y="3383280"/>
+            <a:ext cx="411480" cy="548640"/>
+          </a:xfrm>
+          <a:prstGeom prst="roundRect">
+            <a:avLst>
+              <a:gd name="adj" fmla="val 48889"/>
+            </a:avLst>
+          </a:prstGeom>
+          <a:solidFill>
+            <a:srgbClr val="3B82F6"/>
           </a:solidFill>
           <a:ln/>
         </p:spPr>
@@ -2326,7 +2526,7 @@
               <a:buNone/>
             </a:pPr>
             <a:r>
-              <a:rPr lang="en-US" sz="1600" b="1" dirty="0">
+              <a:rPr lang="en-US" sz="1500" b="1" dirty="0">
                 <a:solidFill>
                   <a:srgbClr val="0F1419"/>
                 </a:solidFill>
@@ -2336,20 +2536,20 @@
               </a:rPr>
               <a:t>4</a:t>
             </a:r>
-            <a:endParaRPr lang="en-US" sz="1600" dirty="0"/>
-          </a:p>
-        </p:txBody>
-      </p:sp>
-      <p:sp>
-        <p:nvSpPr>
-          <p:cNvPr id="11" name="Text 9"/>
+            <a:endParaRPr lang="en-US" sz="1500" dirty="0"/>
+          </a:p>
+        </p:txBody>
+      </p:sp>
+      <p:sp>
+        <p:nvSpPr>
+          <p:cNvPr id="16" name="Text 13"/>
           <p:cNvSpPr txBox="1"/>
           <p:nvPr/>
         </p:nvSpPr>
         <p:spPr>
           <a:xfrm>
-            <a:off x="1371600" y="3529584"/>
-            <a:ext cx="7040880" cy="548640"/>
+            <a:off x="1508760" y="3383280"/>
+            <a:ext cx="6766560" cy="548640"/>
           </a:xfrm>
           <a:prstGeom prst="rect">
             <a:avLst/>
@@ -2365,7 +2565,7 @@
               <a:buNone/>
             </a:pPr>
             <a:r>
-              <a:rPr lang="en-US" sz="1400" dirty="0">
+              <a:rPr lang="en-US" sz="1300" dirty="0">
                 <a:solidFill>
                   <a:srgbClr val="FFFFFF"/>
                 </a:solidFill>
@@ -2375,28 +2575,50 @@
               </a:rPr>
               <a:t>2013 — Le Bitcoin atteint 1 000 $ pour la première fois</a:t>
             </a:r>
-            <a:endParaRPr lang="en-US" sz="1400" dirty="0"/>
-          </a:p>
-        </p:txBody>
-      </p:sp>
-      <p:sp>
-        <p:nvSpPr>
-          <p:cNvPr id="12" name="Text 10"/>
-          <p:cNvSpPr txBox="1"/>
-          <p:nvPr/>
-        </p:nvSpPr>
-        <p:spPr>
-          <a:xfrm>
-            <a:off x="731520" y="4187952"/>
-            <a:ext cx="457200" cy="548640"/>
+            <a:endParaRPr lang="en-US" sz="1300" dirty="0"/>
+          </a:p>
+        </p:txBody>
+      </p:sp>
+      <p:sp>
+        <p:nvSpPr>
+          <p:cNvPr id="17" name="Shape 14"/>
+          <p:cNvSpPr/>
+          <p:nvPr/>
+        </p:nvSpPr>
+        <p:spPr>
+          <a:xfrm>
+            <a:off x="731520" y="4023360"/>
+            <a:ext cx="7680960" cy="548640"/>
           </a:xfrm>
           <a:prstGeom prst="roundRect">
             <a:avLst>
-              <a:gd name="adj" fmla="val 50000"/>
+              <a:gd name="adj" fmla="val 13333"/>
             </a:avLst>
           </a:prstGeom>
           <a:solidFill>
-            <a:srgbClr val="00BFA6"/>
+            <a:srgbClr val="0F1419"/>
+          </a:solidFill>
+          <a:ln/>
+        </p:spPr>
+      </p:sp>
+      <p:sp>
+        <p:nvSpPr>
+          <p:cNvPr id="18" name="Text 15"/>
+          <p:cNvSpPr txBox="1"/>
+          <p:nvPr/>
+        </p:nvSpPr>
+        <p:spPr>
+          <a:xfrm>
+            <a:off x="914400" y="4023360"/>
+            <a:ext cx="411480" cy="548640"/>
+          </a:xfrm>
+          <a:prstGeom prst="roundRect">
+            <a:avLst>
+              <a:gd name="adj" fmla="val 48889"/>
+            </a:avLst>
+          </a:prstGeom>
+          <a:solidFill>
+            <a:srgbClr val="3B82F6"/>
           </a:solidFill>
           <a:ln/>
         </p:spPr>
@@ -2408,7 +2630,7 @@
               <a:buNone/>
             </a:pPr>
             <a:r>
-              <a:rPr lang="en-US" sz="1600" b="1" dirty="0">
+              <a:rPr lang="en-US" sz="1500" b="1" dirty="0">
                 <a:solidFill>
                   <a:srgbClr val="0F1419"/>
                 </a:solidFill>
@@ -2418,20 +2640,20 @@
               </a:rPr>
               <a:t>5</a:t>
             </a:r>
-            <a:endParaRPr lang="en-US" sz="1600" dirty="0"/>
-          </a:p>
-        </p:txBody>
-      </p:sp>
-      <p:sp>
-        <p:nvSpPr>
-          <p:cNvPr id="13" name="Text 11"/>
+            <a:endParaRPr lang="en-US" sz="1500" dirty="0"/>
+          </a:p>
+        </p:txBody>
+      </p:sp>
+      <p:sp>
+        <p:nvSpPr>
+          <p:cNvPr id="19" name="Text 16"/>
           <p:cNvSpPr txBox="1"/>
           <p:nvPr/>
         </p:nvSpPr>
         <p:spPr>
           <a:xfrm>
-            <a:off x="1371600" y="4187952"/>
-            <a:ext cx="7040880" cy="548640"/>
+            <a:off x="1508760" y="4023360"/>
+            <a:ext cx="6766560" cy="548640"/>
           </a:xfrm>
           <a:prstGeom prst="rect">
             <a:avLst/>
@@ -2447,7 +2669,7 @@
               <a:buNone/>
             </a:pPr>
             <a:r>
-              <a:rPr lang="en-US" sz="1400" dirty="0">
+              <a:rPr lang="en-US" sz="1300" dirty="0">
                 <a:solidFill>
                   <a:srgbClr val="FFFFFF"/>
                 </a:solidFill>
@@ -2457,7 +2679,7 @@
               </a:rPr>
               <a:t>2017 — Bull run historique, le BTC atteint 20 000 $</a:t>
             </a:r>
-            <a:endParaRPr lang="en-US" sz="1400" dirty="0"/>
+            <a:endParaRPr lang="en-US" sz="1300" dirty="0"/>
           </a:p>
         </p:txBody>
       </p:sp>
@@ -2495,14 +2717,60 @@
       </p:grpSpPr>
       <p:sp>
         <p:nvSpPr>
-          <p:cNvPr id="2" name="Text 0"/>
+          <p:cNvPr id="2" name="Shape 0"/>
+          <p:cNvSpPr/>
+          <p:nvPr/>
+        </p:nvSpPr>
+        <p:spPr>
+          <a:xfrm>
+            <a:off x="2743200" y="457200"/>
+            <a:ext cx="3657600" cy="3657600"/>
+          </a:xfrm>
+          <a:prstGeom prst="ellipse">
+            <a:avLst/>
+          </a:prstGeom>
+          <a:solidFill>
+            <a:srgbClr val="3B82F6">
+              <a:alpha val="6000"/>
+            </a:srgbClr>
+          </a:solidFill>
+          <a:ln/>
+        </p:spPr>
+      </p:sp>
+      <p:pic>
+        <p:nvPicPr>
+          <p:cNvPr id="3" name="Image 0" descr="preencoded.png">    </p:cNvPr>
+          <p:cNvPicPr>
+            <a:picLocks noChangeAspect="1"/>
+          </p:cNvPicPr>
+          <p:nvPr/>
+        </p:nvPicPr>
+        <p:blipFill>
+          <a:blip r:embed="rId1"/>
+          <a:stretch>
+            <a:fillRect/>
+          </a:stretch>
+        </p:blipFill>
+        <p:spPr>
+          <a:xfrm>
+            <a:off x="3931920" y="914400"/>
+            <a:ext cx="1280160" cy="1280160"/>
+          </a:xfrm>
+          <a:prstGeom prst="rect">
+            <a:avLst/>
+          </a:prstGeom>
+        </p:spPr>
+      </p:pic>
+      <p:sp>
+        <p:nvSpPr>
+          <p:cNvPr id="4" name="Text 1"/>
           <p:cNvSpPr txBox="1"/>
           <p:nvPr/>
         </p:nvSpPr>
         <p:spPr>
           <a:xfrm>
-            <a:off x="731520" y="1371600"/>
-            <a:ext cx="7680960" cy="640080"/>
+            <a:off x="731520" y="2377440"/>
+            <a:ext cx="7680960" cy="548640"/>
           </a:xfrm>
           <a:prstGeom prst="rect">
             <a:avLst/>
@@ -2518,7 +2786,7 @@
               <a:buNone/>
             </a:pPr>
             <a:r>
-              <a:rPr lang="en-US" sz="3000" b="1" dirty="0">
+              <a:rPr lang="en-US" sz="2800" b="1" dirty="0">
                 <a:solidFill>
                   <a:srgbClr val="FFFFFF"/>
                 </a:solidFill>
@@ -2528,20 +2796,20 @@
               </a:rPr>
               <a:t>Module 1 termine</a:t>
             </a:r>
-            <a:endParaRPr lang="en-US" sz="3000" dirty="0"/>
-          </a:p>
-        </p:txBody>
-      </p:sp>
-      <p:sp>
-        <p:nvSpPr>
-          <p:cNvPr id="3" name="Text 1"/>
+            <a:endParaRPr lang="en-US" sz="2800" dirty="0"/>
+          </a:p>
+        </p:txBody>
+      </p:sp>
+      <p:sp>
+        <p:nvSpPr>
+          <p:cNvPr id="5" name="Text 2"/>
           <p:cNvSpPr txBox="1"/>
           <p:nvPr/>
         </p:nvSpPr>
         <p:spPr>
           <a:xfrm>
-            <a:off x="1371600" y="2194560"/>
-            <a:ext cx="6400800" cy="457200"/>
+            <a:off x="1371600" y="3017520"/>
+            <a:ext cx="6400800" cy="365760"/>
           </a:xfrm>
           <a:prstGeom prst="rect">
             <a:avLst/>
@@ -2557,7 +2825,7 @@
               <a:buNone/>
             </a:pPr>
             <a:r>
-              <a:rPr lang="en-US" sz="1400" dirty="0">
+              <a:rPr lang="en-US" sz="1300" dirty="0">
                 <a:solidFill>
                   <a:srgbClr val="94A3B8"/>
                 </a:solidFill>
@@ -2567,40 +2835,40 @@
               </a:rPr>
               <a:t>Passez au module suivant pour continuer votre apprentissage.</a:t>
             </a:r>
-            <a:endParaRPr lang="en-US" sz="1400" dirty="0"/>
-          </a:p>
-        </p:txBody>
-      </p:sp>
-      <p:sp>
-        <p:nvSpPr>
-          <p:cNvPr id="4" name="Shape 2"/>
+            <a:endParaRPr lang="en-US" sz="1300" dirty="0"/>
+          </a:p>
+        </p:txBody>
+      </p:sp>
+      <p:sp>
+        <p:nvSpPr>
+          <p:cNvPr id="6" name="Shape 3"/>
           <p:cNvSpPr/>
           <p:nvPr/>
         </p:nvSpPr>
         <p:spPr>
           <a:xfrm>
-            <a:off x="3200400" y="2926080"/>
-            <a:ext cx="2743200" cy="54864"/>
+            <a:off x="3200400" y="3657600"/>
+            <a:ext cx="2743200" cy="36576"/>
           </a:xfrm>
           <a:prstGeom prst="rect">
             <a:avLst/>
           </a:prstGeom>
           <a:solidFill>
-            <a:srgbClr val="00BFA6"/>
+            <a:srgbClr val="3B82F6"/>
           </a:solidFill>
           <a:ln/>
         </p:spPr>
       </p:sp>
       <p:sp>
         <p:nvSpPr>
-          <p:cNvPr id="5" name="Text 3"/>
+          <p:cNvPr id="7" name="Text 4"/>
           <p:cNvSpPr txBox="1"/>
           <p:nvPr/>
         </p:nvSpPr>
         <p:spPr>
           <a:xfrm>
-            <a:off x="2286000" y="3291840"/>
-            <a:ext cx="4572000" cy="365760"/>
+            <a:off x="2286000" y="3931920"/>
+            <a:ext cx="4572000" cy="320040"/>
           </a:xfrm>
           <a:prstGeom prst="rect">
             <a:avLst/>
@@ -2616,7 +2884,7 @@
               <a:buNone/>
             </a:pPr>
             <a:r>
-              <a:rPr lang="en-US" sz="1200" spc="300" kern="0" dirty="0">
+              <a:rPr lang="en-US" sz="1100" spc="300" kern="0" dirty="0">
                 <a:solidFill>
                   <a:srgbClr val="64748B"/>
                 </a:solidFill>
@@ -2626,20 +2894,20 @@
               </a:rPr>
               <a:t>TEREX ACADEMY</a:t>
             </a:r>
-            <a:endParaRPr lang="en-US" sz="1200" dirty="0"/>
-          </a:p>
-        </p:txBody>
-      </p:sp>
-      <p:sp>
-        <p:nvSpPr>
-          <p:cNvPr id="6" name="Text 4"/>
+            <a:endParaRPr lang="en-US" sz="1100" dirty="0"/>
+          </a:p>
+        </p:txBody>
+      </p:sp>
+      <p:sp>
+        <p:nvSpPr>
+          <p:cNvPr id="8" name="Text 5"/>
           <p:cNvSpPr txBox="1"/>
           <p:nvPr/>
         </p:nvSpPr>
         <p:spPr>
           <a:xfrm>
-            <a:off x="2286000" y="3657600"/>
-            <a:ext cx="4572000" cy="320040"/>
+            <a:off x="2286000" y="4251960"/>
+            <a:ext cx="4572000" cy="274320"/>
           </a:xfrm>
           <a:prstGeom prst="rect">
             <a:avLst/>
@@ -2709,8 +2977,8 @@
         </p:nvSpPr>
         <p:spPr>
           <a:xfrm>
-            <a:off x="731520" y="457200"/>
-            <a:ext cx="2743200" cy="365760"/>
+            <a:off x="731520" y="365760"/>
+            <a:ext cx="2743200" cy="320040"/>
           </a:xfrm>
           <a:prstGeom prst="rect">
             <a:avLst/>
@@ -2728,7 +2996,7 @@
             <a:r>
               <a:rPr lang="en-US" sz="1200" b="1" spc="300" kern="0" dirty="0">
                 <a:solidFill>
-                  <a:srgbClr val="00BFA6"/>
+                  <a:srgbClr val="3B82F6"/>
                 </a:solidFill>
                 <a:latin typeface="Calibri" pitchFamily="34" charset="0"/>
                 <a:ea typeface="Calibri" pitchFamily="34" charset="-122"/>
@@ -2748,7 +3016,7 @@
         </p:nvSpPr>
         <p:spPr>
           <a:xfrm>
-            <a:off x="731520" y="868680"/>
+            <a:off x="731520" y="731520"/>
             <a:ext cx="4572000" cy="457200"/>
           </a:xfrm>
           <a:prstGeom prst="rect">
@@ -2781,14 +3049,36 @@
       </p:sp>
       <p:sp>
         <p:nvSpPr>
-          <p:cNvPr id="4" name="Text 2"/>
+          <p:cNvPr id="4" name="Shape 2"/>
+          <p:cNvSpPr/>
+          <p:nvPr/>
+        </p:nvSpPr>
+        <p:spPr>
+          <a:xfrm>
+            <a:off x="731520" y="1371600"/>
+            <a:ext cx="7680960" cy="475488"/>
+          </a:xfrm>
+          <a:prstGeom prst="roundRect">
+            <a:avLst>
+              <a:gd name="adj" fmla="val 15385"/>
+            </a:avLst>
+          </a:prstGeom>
+          <a:solidFill>
+            <a:srgbClr val="1A2332"/>
+          </a:solidFill>
+          <a:ln/>
+        </p:spPr>
+      </p:sp>
+      <p:sp>
+        <p:nvSpPr>
+          <p:cNvPr id="5" name="Text 3"/>
           <p:cNvSpPr txBox="1"/>
           <p:nvPr/>
         </p:nvSpPr>
         <p:spPr>
           <a:xfrm>
-            <a:off x="731520" y="1554480"/>
-            <a:ext cx="7680960" cy="3200400"/>
+            <a:off x="868680" y="1371600"/>
+            <a:ext cx="320040" cy="475488"/>
           </a:xfrm>
           <a:prstGeom prst="rect">
             <a:avLst/>
@@ -2797,17 +3087,77 @@
           <a:ln/>
         </p:spPr>
         <p:txBody>
-          <a:bodyPr wrap="square" lIns="0" tIns="0" rIns="0" bIns="0" rtlCol="0" anchor="t"/>
+          <a:bodyPr wrap="square" lIns="0" tIns="0" rIns="0" bIns="0" rtlCol="0" anchor="ctr"/>
+          <a:lstStyle/>
+          <a:p>
+            <a:pPr algn="ctr" indent="0" marL="0">
+              <a:buNone/>
+            </a:pPr>
+            <a:r>
+              <a:rPr lang="en-US" sz="1300" b="1" dirty="0">
+                <a:solidFill>
+                  <a:srgbClr val="3B82F6"/>
+                </a:solidFill>
+                <a:latin typeface="Calibri" pitchFamily="34" charset="0"/>
+                <a:ea typeface="Calibri" pitchFamily="34" charset="-122"/>
+                <a:cs typeface="Calibri" pitchFamily="34" charset="-120"/>
+              </a:rPr>
+              <a:t>1</a:t>
+            </a:r>
+            <a:endParaRPr lang="en-US" sz="1300" dirty="0"/>
+          </a:p>
+        </p:txBody>
+      </p:sp>
+      <p:pic>
+        <p:nvPicPr>
+          <p:cNvPr id="6" name="Image 0" descr="preencoded.png">    </p:cNvPr>
+          <p:cNvPicPr>
+            <a:picLocks noChangeAspect="1"/>
+          </p:cNvPicPr>
+          <p:nvPr/>
+        </p:nvPicPr>
+        <p:blipFill>
+          <a:blip r:embed="rId1"/>
+          <a:stretch>
+            <a:fillRect/>
+          </a:stretch>
+        </p:blipFill>
+        <p:spPr>
+          <a:xfrm>
+            <a:off x="1280160" y="1444752"/>
+            <a:ext cx="329184" cy="329184"/>
+          </a:xfrm>
+          <a:prstGeom prst="rect">
+            <a:avLst/>
+          </a:prstGeom>
+        </p:spPr>
+      </p:pic>
+      <p:sp>
+        <p:nvSpPr>
+          <p:cNvPr id="7" name="Text 4"/>
+          <p:cNvSpPr txBox="1"/>
+          <p:nvPr/>
+        </p:nvSpPr>
+        <p:spPr>
+          <a:xfrm>
+            <a:off x="1737360" y="1371600"/>
+            <a:ext cx="6492240" cy="475488"/>
+          </a:xfrm>
+          <a:prstGeom prst="rect">
+            <a:avLst/>
+          </a:prstGeom>
+          <a:noFill/>
+          <a:ln/>
+        </p:spPr>
+        <p:txBody>
+          <a:bodyPr wrap="square" lIns="0" tIns="0" rIns="0" bIns="0" rtlCol="0" anchor="ctr"/>
           <a:lstStyle/>
           <a:p>
             <a:pPr indent="0" marL="0">
-              <a:spcAft>
-                <a:spcPts val="1000"/>
-              </a:spcAft>
               <a:buNone/>
             </a:pPr>
             <a:r>
-              <a:rPr lang="en-US" sz="1500" dirty="0">
+              <a:rPr lang="en-US" sz="1300" dirty="0">
                 <a:solidFill>
                   <a:srgbClr val="FFFFFF"/>
                 </a:solidFill>
@@ -2815,19 +3165,123 @@
                 <a:ea typeface="Calibri" pitchFamily="34" charset="-122"/>
                 <a:cs typeface="Calibri" pitchFamily="34" charset="-120"/>
               </a:rPr>
-              <a:t>1.  Qu'est-ce que la blockchain ?</a:t>
-            </a:r>
-            <a:endParaRPr lang="en-US" sz="1500" dirty="0"/>
-          </a:p>
+              <a:t>Qu'est-ce que la blockchain ?</a:t>
+            </a:r>
+            <a:endParaRPr lang="en-US" sz="1300" dirty="0"/>
+          </a:p>
+        </p:txBody>
+      </p:sp>
+      <p:sp>
+        <p:nvSpPr>
+          <p:cNvPr id="8" name="Shape 5"/>
+          <p:cNvSpPr/>
+          <p:nvPr/>
+        </p:nvSpPr>
+        <p:spPr>
+          <a:xfrm>
+            <a:off x="731520" y="1920240"/>
+            <a:ext cx="7680960" cy="475488"/>
+          </a:xfrm>
+          <a:prstGeom prst="roundRect">
+            <a:avLst>
+              <a:gd name="adj" fmla="val 15385"/>
+            </a:avLst>
+          </a:prstGeom>
+          <a:solidFill>
+            <a:srgbClr val="1A2332"/>
+          </a:solidFill>
+          <a:ln/>
+        </p:spPr>
+      </p:sp>
+      <p:sp>
+        <p:nvSpPr>
+          <p:cNvPr id="9" name="Text 6"/>
+          <p:cNvSpPr txBox="1"/>
+          <p:nvPr/>
+        </p:nvSpPr>
+        <p:spPr>
+          <a:xfrm>
+            <a:off x="868680" y="1920240"/>
+            <a:ext cx="320040" cy="475488"/>
+          </a:xfrm>
+          <a:prstGeom prst="rect">
+            <a:avLst/>
+          </a:prstGeom>
+          <a:noFill/>
+          <a:ln/>
+        </p:spPr>
+        <p:txBody>
+          <a:bodyPr wrap="square" lIns="0" tIns="0" rIns="0" bIns="0" rtlCol="0" anchor="ctr"/>
+          <a:lstStyle/>
+          <a:p>
+            <a:pPr algn="ctr" indent="0" marL="0">
+              <a:buNone/>
+            </a:pPr>
+            <a:r>
+              <a:rPr lang="en-US" sz="1300" b="1" dirty="0">
+                <a:solidFill>
+                  <a:srgbClr val="3B82F6"/>
+                </a:solidFill>
+                <a:latin typeface="Calibri" pitchFamily="34" charset="0"/>
+                <a:ea typeface="Calibri" pitchFamily="34" charset="-122"/>
+                <a:cs typeface="Calibri" pitchFamily="34" charset="-120"/>
+              </a:rPr>
+              <a:t>2</a:t>
+            </a:r>
+            <a:endParaRPr lang="en-US" sz="1300" dirty="0"/>
+          </a:p>
+        </p:txBody>
+      </p:sp>
+      <p:pic>
+        <p:nvPicPr>
+          <p:cNvPr id="10" name="Image 1" descr="preencoded.png">    </p:cNvPr>
+          <p:cNvPicPr>
+            <a:picLocks noChangeAspect="1"/>
+          </p:cNvPicPr>
+          <p:nvPr/>
+        </p:nvPicPr>
+        <p:blipFill>
+          <a:blip r:embed="rId2"/>
+          <a:stretch>
+            <a:fillRect/>
+          </a:stretch>
+        </p:blipFill>
+        <p:spPr>
+          <a:xfrm>
+            <a:off x="1280160" y="1993392"/>
+            <a:ext cx="329184" cy="329184"/>
+          </a:xfrm>
+          <a:prstGeom prst="rect">
+            <a:avLst/>
+          </a:prstGeom>
+        </p:spPr>
+      </p:pic>
+      <p:sp>
+        <p:nvSpPr>
+          <p:cNvPr id="11" name="Text 7"/>
+          <p:cNvSpPr txBox="1"/>
+          <p:nvPr/>
+        </p:nvSpPr>
+        <p:spPr>
+          <a:xfrm>
+            <a:off x="1737360" y="1920240"/>
+            <a:ext cx="6492240" cy="475488"/>
+          </a:xfrm>
+          <a:prstGeom prst="rect">
+            <a:avLst/>
+          </a:prstGeom>
+          <a:noFill/>
+          <a:ln/>
+        </p:spPr>
+        <p:txBody>
+          <a:bodyPr wrap="square" lIns="0" tIns="0" rIns="0" bIns="0" rtlCol="0" anchor="ctr"/>
+          <a:lstStyle/>
           <a:p>
             <a:pPr indent="0" marL="0">
-              <a:spcAft>
-                <a:spcPts val="1000"/>
-              </a:spcAft>
               <a:buNone/>
             </a:pPr>
             <a:r>
-              <a:rPr lang="en-US" sz="1500" dirty="0">
+              <a:rPr lang="en-US" sz="1300" dirty="0">
                 <a:solidFill>
                   <a:srgbClr val="FFFFFF"/>
                 </a:solidFill>
@@ -2835,9 +3289,9 @@
                 <a:ea typeface="Calibri" pitchFamily="34" charset="-122"/>
                 <a:cs typeface="Calibri" pitchFamily="34" charset="-120"/>
               </a:rPr>
-              <a:t>2.  L'histoire du Bitcoin</a:t>
-            </a:r>
-            <a:endParaRPr lang="en-US" sz="1500" dirty="0"/>
+              <a:t>L'histoire du Bitcoin</a:t>
+            </a:r>
+            <a:endParaRPr lang="en-US" sz="1300" dirty="0"/>
           </a:p>
         </p:txBody>
       </p:sp>
@@ -2873,35 +3327,105 @@
           <a:chExt cx="0" cy="0"/>
         </a:xfrm>
       </p:grpSpPr>
-      <p:sp>
-        <p:nvSpPr>
-          <p:cNvPr id="2" name="Shape 0"/>
+      <p:pic>
+        <p:nvPicPr>
+          <p:cNvPr id="2" name="Image 0" descr="preencoded.png">    </p:cNvPr>
+          <p:cNvPicPr>
+            <a:picLocks noChangeAspect="1"/>
+          </p:cNvPicPr>
+          <p:nvPr/>
+        </p:nvPicPr>
+        <p:blipFill>
+          <a:blip r:embed="rId1"/>
+          <a:stretch>
+            <a:fillRect/>
+          </a:stretch>
+        </p:blipFill>
+        <p:spPr>
+          <a:xfrm>
+            <a:off x="7315200" y="548640"/>
+            <a:ext cx="1280160" cy="1280160"/>
+          </a:xfrm>
+          <a:prstGeom prst="rect">
+            <a:avLst/>
+          </a:prstGeom>
+        </p:spPr>
+      </p:pic>
+      <p:pic>
+        <p:nvPicPr>
+          <p:cNvPr id="3" name="Image 1" descr="preencoded.png">    </p:cNvPr>
+          <p:cNvPicPr>
+            <a:picLocks noChangeAspect="1"/>
+          </p:cNvPicPr>
+          <p:nvPr/>
+        </p:nvPicPr>
+        <p:blipFill>
+          <a:blip r:embed="rId2"/>
+          <a:stretch>
+            <a:fillRect/>
+          </a:stretch>
+        </p:blipFill>
+        <p:spPr>
+          <a:xfrm>
+            <a:off x="7772400" y="2011680"/>
+            <a:ext cx="822960" cy="822960"/>
+          </a:xfrm>
+          <a:prstGeom prst="rect">
+            <a:avLst/>
+          </a:prstGeom>
+        </p:spPr>
+      </p:pic>
+      <p:sp>
+        <p:nvSpPr>
+          <p:cNvPr id="4" name="Shape 0"/>
           <p:cNvSpPr/>
           <p:nvPr/>
         </p:nvSpPr>
         <p:spPr>
           <a:xfrm>
-            <a:off x="548640" y="914400"/>
-            <a:ext cx="45720" cy="2560320"/>
-          </a:xfrm>
-          <a:prstGeom prst="rect">
+            <a:off x="6583680" y="-274320"/>
+            <a:ext cx="3200400" cy="3200400"/>
+          </a:xfrm>
+          <a:prstGeom prst="ellipse">
             <a:avLst/>
           </a:prstGeom>
           <a:solidFill>
-            <a:srgbClr val="00BFA6"/>
+            <a:srgbClr val="3B82F6">
+              <a:alpha val="6000"/>
+            </a:srgbClr>
           </a:solidFill>
           <a:ln/>
         </p:spPr>
       </p:sp>
       <p:sp>
         <p:nvSpPr>
-          <p:cNvPr id="3" name="Text 1"/>
+          <p:cNvPr id="5" name="Shape 1"/>
+          <p:cNvSpPr/>
+          <p:nvPr/>
+        </p:nvSpPr>
+        <p:spPr>
+          <a:xfrm>
+            <a:off x="731520" y="914400"/>
+            <a:ext cx="45720" cy="2194560"/>
+          </a:xfrm>
+          <a:prstGeom prst="rect">
+            <a:avLst/>
+          </a:prstGeom>
+          <a:solidFill>
+            <a:srgbClr val="3B82F6"/>
+          </a:solidFill>
+          <a:ln/>
+        </p:spPr>
+      </p:sp>
+      <p:sp>
+        <p:nvSpPr>
+          <p:cNvPr id="6" name="Text 2"/>
           <p:cNvSpPr txBox="1"/>
           <p:nvPr/>
         </p:nvSpPr>
         <p:spPr>
           <a:xfrm>
-            <a:off x="822960" y="1097280"/>
+            <a:off x="960120" y="914400"/>
             <a:ext cx="2743200" cy="365760"/>
           </a:xfrm>
           <a:prstGeom prst="rect">
@@ -2920,13 +3444,13 @@
             <a:r>
               <a:rPr lang="en-US" sz="1200" b="1" spc="200" kern="0" dirty="0">
                 <a:solidFill>
-                  <a:srgbClr val="00BFA6"/>
-                </a:solidFill>
-                <a:latin typeface="Calibri" pitchFamily="34" charset="0"/>
-                <a:ea typeface="Calibri" pitchFamily="34" charset="-122"/>
-                <a:cs typeface="Calibri" pitchFamily="34" charset="-120"/>
-              </a:rPr>
-              <a:t>Lecon 1 / 2</a:t>
+                  <a:srgbClr val="3B82F6"/>
+                </a:solidFill>
+                <a:latin typeface="Calibri" pitchFamily="34" charset="0"/>
+                <a:ea typeface="Calibri" pitchFamily="34" charset="-122"/>
+                <a:cs typeface="Calibri" pitchFamily="34" charset="-120"/>
+              </a:rPr>
+              <a:t>Leçon 1 / 2</a:t>
             </a:r>
             <a:endParaRPr lang="en-US" sz="1200" dirty="0"/>
           </a:p>
@@ -2934,14 +3458,14 @@
       </p:sp>
       <p:sp>
         <p:nvSpPr>
-          <p:cNvPr id="4" name="Text 2"/>
+          <p:cNvPr id="7" name="Text 3"/>
           <p:cNvSpPr txBox="1"/>
           <p:nvPr/>
         </p:nvSpPr>
         <p:spPr>
           <a:xfrm>
-            <a:off x="822960" y="1645920"/>
-            <a:ext cx="7498080" cy="1280160"/>
+            <a:off x="960120" y="1371600"/>
+            <a:ext cx="6217920" cy="1463040"/>
           </a:xfrm>
           <a:prstGeom prst="rect">
             <a:avLst/>
@@ -2957,7 +3481,7 @@
               <a:buNone/>
             </a:pPr>
             <a:r>
-              <a:rPr lang="en-US" sz="3000" b="1" dirty="0">
+              <a:rPr lang="en-US" sz="2800" b="1" dirty="0">
                 <a:solidFill>
                   <a:srgbClr val="FFFFFF"/>
                 </a:solidFill>
@@ -2967,19 +3491,19 @@
               </a:rPr>
               <a:t>Qu'est-ce que la blockchain ?</a:t>
             </a:r>
-            <a:endParaRPr lang="en-US" sz="3000" dirty="0"/>
-          </a:p>
-        </p:txBody>
-      </p:sp>
-      <p:sp>
-        <p:nvSpPr>
-          <p:cNvPr id="5" name="Text 3"/>
+            <a:endParaRPr lang="en-US" sz="2800" dirty="0"/>
+          </a:p>
+        </p:txBody>
+      </p:sp>
+      <p:sp>
+        <p:nvSpPr>
+          <p:cNvPr id="8" name="Text 4"/>
           <p:cNvSpPr txBox="1"/>
           <p:nvPr/>
         </p:nvSpPr>
         <p:spPr>
           <a:xfrm>
-            <a:off x="822960" y="4206240"/>
+            <a:off x="960120" y="4114800"/>
             <a:ext cx="5486400" cy="320040"/>
           </a:xfrm>
           <a:prstGeom prst="rect">
@@ -3044,7 +3568,53 @@
       </p:grpSpPr>
       <p:sp>
         <p:nvSpPr>
-          <p:cNvPr id="2" name="Text 0"/>
+          <p:cNvPr id="2" name="Shape 0"/>
+          <p:cNvSpPr/>
+          <p:nvPr/>
+        </p:nvSpPr>
+        <p:spPr>
+          <a:xfrm>
+            <a:off x="7955280" y="182880"/>
+            <a:ext cx="640080" cy="640080"/>
+          </a:xfrm>
+          <a:prstGeom prst="ellipse">
+            <a:avLst/>
+          </a:prstGeom>
+          <a:solidFill>
+            <a:srgbClr val="3B82F6">
+              <a:alpha val="12000"/>
+            </a:srgbClr>
+          </a:solidFill>
+          <a:ln/>
+        </p:spPr>
+      </p:sp>
+      <p:pic>
+        <p:nvPicPr>
+          <p:cNvPr id="3" name="Image 0" descr="preencoded.png">    </p:cNvPr>
+          <p:cNvPicPr>
+            <a:picLocks noChangeAspect="1"/>
+          </p:cNvPicPr>
+          <p:nvPr/>
+        </p:nvPicPr>
+        <p:blipFill>
+          <a:blip r:embed="rId1"/>
+          <a:stretch>
+            <a:fillRect/>
+          </a:stretch>
+        </p:blipFill>
+        <p:spPr>
+          <a:xfrm>
+            <a:off x="8028432" y="256032"/>
+            <a:ext cx="493776" cy="493776"/>
+          </a:xfrm>
+          <a:prstGeom prst="rect">
+            <a:avLst/>
+          </a:prstGeom>
+        </p:spPr>
+      </p:pic>
+      <p:sp>
+        <p:nvSpPr>
+          <p:cNvPr id="4" name="Text 1"/>
           <p:cNvSpPr txBox="1"/>
           <p:nvPr/>
         </p:nvSpPr>
@@ -3213,7 +3783,7 @@
       </p:sp>
       <p:sp>
         <p:nvSpPr>
-          <p:cNvPr id="3" name="Text 1"/>
+          <p:cNvPr id="5" name="Text 2"/>
           <p:cNvSpPr txBox="1"/>
           <p:nvPr/>
         </p:nvSpPr>
@@ -3244,7 +3814,7 @@
                 <a:ea typeface="Calibri" pitchFamily="34" charset="-122"/>
                 <a:cs typeface="Calibri" pitchFamily="34" charset="-120"/>
               </a:rPr>
-              <a:t>Module 1 — Lecon 1</a:t>
+              <a:t>Module 1 — Leçon 1</a:t>
             </a:r>
             <a:endParaRPr lang="en-US" sz="900" dirty="0"/>
           </a:p>
@@ -3284,7 +3854,53 @@
       </p:grpSpPr>
       <p:sp>
         <p:nvSpPr>
-          <p:cNvPr id="2" name="Text 0"/>
+          <p:cNvPr id="2" name="Shape 0"/>
+          <p:cNvSpPr/>
+          <p:nvPr/>
+        </p:nvSpPr>
+        <p:spPr>
+          <a:xfrm>
+            <a:off x="7955280" y="182880"/>
+            <a:ext cx="640080" cy="640080"/>
+          </a:xfrm>
+          <a:prstGeom prst="ellipse">
+            <a:avLst/>
+          </a:prstGeom>
+          <a:solidFill>
+            <a:srgbClr val="3B82F6">
+              <a:alpha val="12000"/>
+            </a:srgbClr>
+          </a:solidFill>
+          <a:ln/>
+        </p:spPr>
+      </p:sp>
+      <p:pic>
+        <p:nvPicPr>
+          <p:cNvPr id="3" name="Image 0" descr="preencoded.png">    </p:cNvPr>
+          <p:cNvPicPr>
+            <a:picLocks noChangeAspect="1"/>
+          </p:cNvPicPr>
+          <p:nvPr/>
+        </p:nvPicPr>
+        <p:blipFill>
+          <a:blip r:embed="rId1"/>
+          <a:stretch>
+            <a:fillRect/>
+          </a:stretch>
+        </p:blipFill>
+        <p:spPr>
+          <a:xfrm>
+            <a:off x="8028432" y="256032"/>
+            <a:ext cx="493776" cy="493776"/>
+          </a:xfrm>
+          <a:prstGeom prst="rect">
+            <a:avLst/>
+          </a:prstGeom>
+        </p:spPr>
+      </p:pic>
+      <p:sp>
+        <p:nvSpPr>
+          <p:cNvPr id="4" name="Text 1"/>
           <p:cNvSpPr txBox="1"/>
           <p:nvPr/>
         </p:nvSpPr>
@@ -3327,7 +3943,7 @@
       </p:sp>
       <p:sp>
         <p:nvSpPr>
-          <p:cNvPr id="3" name="Text 1"/>
+          <p:cNvPr id="5" name="Text 2"/>
           <p:cNvSpPr txBox="1"/>
           <p:nvPr/>
         </p:nvSpPr>
@@ -3358,7 +3974,7 @@
                 <a:ea typeface="Calibri" pitchFamily="34" charset="-122"/>
                 <a:cs typeface="Calibri" pitchFamily="34" charset="-120"/>
               </a:rPr>
-              <a:t>Module 1 — Lecon 1</a:t>
+              <a:t>Module 1 — Leçon 1</a:t>
             </a:r>
             <a:endParaRPr lang="en-US" sz="900" dirty="0"/>
           </a:p>
@@ -3396,16 +4012,40 @@
           <a:chExt cx="0" cy="0"/>
         </a:xfrm>
       </p:grpSpPr>
-      <p:sp>
-        <p:nvSpPr>
-          <p:cNvPr id="2" name="Text 0"/>
+      <p:pic>
+        <p:nvPicPr>
+          <p:cNvPr id="2" name="Image 0" descr="preencoded.png">    </p:cNvPr>
+          <p:cNvPicPr>
+            <a:picLocks noChangeAspect="1"/>
+          </p:cNvPicPr>
+          <p:nvPr/>
+        </p:nvPicPr>
+        <p:blipFill>
+          <a:blip r:embed="rId1"/>
+          <a:stretch>
+            <a:fillRect/>
+          </a:stretch>
+        </p:blipFill>
+        <p:spPr>
+          <a:xfrm>
+            <a:off x="731520" y="320040"/>
+            <a:ext cx="457200" cy="457200"/>
+          </a:xfrm>
+          <a:prstGeom prst="rect">
+            <a:avLst/>
+          </a:prstGeom>
+        </p:spPr>
+      </p:pic>
+      <p:sp>
+        <p:nvSpPr>
+          <p:cNvPr id="3" name="Text 0"/>
           <p:cNvSpPr txBox="1"/>
           <p:nvPr/>
         </p:nvSpPr>
         <p:spPr>
           <a:xfrm>
-            <a:off x="731520" y="457200"/>
-            <a:ext cx="2743200" cy="365760"/>
+            <a:off x="1280160" y="365760"/>
+            <a:ext cx="2743200" cy="320040"/>
           </a:xfrm>
           <a:prstGeom prst="rect">
             <a:avLst/>
@@ -3437,14 +4077,14 @@
       </p:sp>
       <p:sp>
         <p:nvSpPr>
-          <p:cNvPr id="3" name="Text 1"/>
+          <p:cNvPr id="4" name="Text 1"/>
           <p:cNvSpPr txBox="1"/>
           <p:nvPr/>
         </p:nvSpPr>
         <p:spPr>
           <a:xfrm>
-            <a:off x="731520" y="868680"/>
-            <a:ext cx="7680960" cy="502920"/>
+            <a:off x="731520" y="822960"/>
+            <a:ext cx="7680960" cy="457200"/>
           </a:xfrm>
           <a:prstGeom prst="rect">
             <a:avLst/>
@@ -3460,7 +4100,7 @@
               <a:buNone/>
             </a:pPr>
             <a:r>
-              <a:rPr lang="en-US" sz="2200" b="1" dirty="0">
+              <a:rPr lang="en-US" sz="2000" b="1" dirty="0">
                 <a:solidFill>
                   <a:srgbClr val="FFFFFF"/>
                 </a:solidFill>
@@ -3470,28 +4110,50 @@
               </a:rPr>
               <a:t>Qu'est-ce que la blockchain ?</a:t>
             </a:r>
-            <a:endParaRPr lang="en-US" sz="2200" dirty="0"/>
-          </a:p>
-        </p:txBody>
-      </p:sp>
-      <p:sp>
-        <p:nvSpPr>
-          <p:cNvPr id="4" name="Text 2"/>
-          <p:cNvSpPr txBox="1"/>
-          <p:nvPr/>
-        </p:nvSpPr>
-        <p:spPr>
-          <a:xfrm>
-            <a:off x="731520" y="1554480"/>
-            <a:ext cx="457200" cy="548640"/>
+            <a:endParaRPr lang="en-US" sz="2000" dirty="0"/>
+          </a:p>
+        </p:txBody>
+      </p:sp>
+      <p:sp>
+        <p:nvSpPr>
+          <p:cNvPr id="5" name="Shape 2"/>
+          <p:cNvSpPr/>
+          <p:nvPr/>
+        </p:nvSpPr>
+        <p:spPr>
+          <a:xfrm>
+            <a:off x="731520" y="1463040"/>
+            <a:ext cx="7680960" cy="548640"/>
           </a:xfrm>
           <a:prstGeom prst="roundRect">
             <a:avLst>
-              <a:gd name="adj" fmla="val 50000"/>
+              <a:gd name="adj" fmla="val 13333"/>
             </a:avLst>
           </a:prstGeom>
           <a:solidFill>
-            <a:srgbClr val="00BFA6"/>
+            <a:srgbClr val="0F1419"/>
+          </a:solidFill>
+          <a:ln/>
+        </p:spPr>
+      </p:sp>
+      <p:sp>
+        <p:nvSpPr>
+          <p:cNvPr id="6" name="Text 3"/>
+          <p:cNvSpPr txBox="1"/>
+          <p:nvPr/>
+        </p:nvSpPr>
+        <p:spPr>
+          <a:xfrm>
+            <a:off x="914400" y="1463040"/>
+            <a:ext cx="411480" cy="548640"/>
+          </a:xfrm>
+          <a:prstGeom prst="roundRect">
+            <a:avLst>
+              <a:gd name="adj" fmla="val 48889"/>
+            </a:avLst>
+          </a:prstGeom>
+          <a:solidFill>
+            <a:srgbClr val="3B82F6"/>
           </a:solidFill>
           <a:ln/>
         </p:spPr>
@@ -3503,7 +4165,7 @@
               <a:buNone/>
             </a:pPr>
             <a:r>
-              <a:rPr lang="en-US" sz="1600" b="1" dirty="0">
+              <a:rPr lang="en-US" sz="1500" b="1" dirty="0">
                 <a:solidFill>
                   <a:srgbClr val="0F1419"/>
                 </a:solidFill>
@@ -3513,20 +4175,20 @@
               </a:rPr>
               <a:t>1</a:t>
             </a:r>
-            <a:endParaRPr lang="en-US" sz="1600" dirty="0"/>
-          </a:p>
-        </p:txBody>
-      </p:sp>
-      <p:sp>
-        <p:nvSpPr>
-          <p:cNvPr id="5" name="Text 3"/>
+            <a:endParaRPr lang="en-US" sz="1500" dirty="0"/>
+          </a:p>
+        </p:txBody>
+      </p:sp>
+      <p:sp>
+        <p:nvSpPr>
+          <p:cNvPr id="7" name="Text 4"/>
           <p:cNvSpPr txBox="1"/>
           <p:nvPr/>
         </p:nvSpPr>
         <p:spPr>
           <a:xfrm>
-            <a:off x="1371600" y="1554480"/>
-            <a:ext cx="7040880" cy="548640"/>
+            <a:off x="1508760" y="1463040"/>
+            <a:ext cx="6766560" cy="548640"/>
           </a:xfrm>
           <a:prstGeom prst="rect">
             <a:avLst/>
@@ -3542,7 +4204,7 @@
               <a:buNone/>
             </a:pPr>
             <a:r>
-              <a:rPr lang="en-US" sz="1400" dirty="0">
+              <a:rPr lang="en-US" sz="1300" dirty="0">
                 <a:solidFill>
                   <a:srgbClr val="FFFFFF"/>
                 </a:solidFill>
@@ -3552,28 +4214,50 @@
               </a:rPr>
               <a:t>DÉCENTRALISATION — Aucune banque, aucun gouvernement ne contrôle la blockchain. Le réseau est maintenu par des milliers d'ordinateurs (nœuds) répar...</a:t>
             </a:r>
-            <a:endParaRPr lang="en-US" sz="1400" dirty="0"/>
-          </a:p>
-        </p:txBody>
-      </p:sp>
-      <p:sp>
-        <p:nvSpPr>
-          <p:cNvPr id="6" name="Text 4"/>
-          <p:cNvSpPr txBox="1"/>
-          <p:nvPr/>
-        </p:nvSpPr>
-        <p:spPr>
-          <a:xfrm>
-            <a:off x="731520" y="2212848"/>
-            <a:ext cx="457200" cy="548640"/>
+            <a:endParaRPr lang="en-US" sz="1300" dirty="0"/>
+          </a:p>
+        </p:txBody>
+      </p:sp>
+      <p:sp>
+        <p:nvSpPr>
+          <p:cNvPr id="8" name="Shape 5"/>
+          <p:cNvSpPr/>
+          <p:nvPr/>
+        </p:nvSpPr>
+        <p:spPr>
+          <a:xfrm>
+            <a:off x="731520" y="2103120"/>
+            <a:ext cx="7680960" cy="548640"/>
           </a:xfrm>
           <a:prstGeom prst="roundRect">
             <a:avLst>
-              <a:gd name="adj" fmla="val 50000"/>
+              <a:gd name="adj" fmla="val 13333"/>
             </a:avLst>
           </a:prstGeom>
           <a:solidFill>
-            <a:srgbClr val="00BFA6"/>
+            <a:srgbClr val="0F1419"/>
+          </a:solidFill>
+          <a:ln/>
+        </p:spPr>
+      </p:sp>
+      <p:sp>
+        <p:nvSpPr>
+          <p:cNvPr id="9" name="Text 6"/>
+          <p:cNvSpPr txBox="1"/>
+          <p:nvPr/>
+        </p:nvSpPr>
+        <p:spPr>
+          <a:xfrm>
+            <a:off x="914400" y="2103120"/>
+            <a:ext cx="411480" cy="548640"/>
+          </a:xfrm>
+          <a:prstGeom prst="roundRect">
+            <a:avLst>
+              <a:gd name="adj" fmla="val 48889"/>
+            </a:avLst>
+          </a:prstGeom>
+          <a:solidFill>
+            <a:srgbClr val="3B82F6"/>
           </a:solidFill>
           <a:ln/>
         </p:spPr>
@@ -3585,7 +4269,7 @@
               <a:buNone/>
             </a:pPr>
             <a:r>
-              <a:rPr lang="en-US" sz="1600" b="1" dirty="0">
+              <a:rPr lang="en-US" sz="1500" b="1" dirty="0">
                 <a:solidFill>
                   <a:srgbClr val="0F1419"/>
                 </a:solidFill>
@@ -3595,20 +4279,20 @@
               </a:rPr>
               <a:t>2</a:t>
             </a:r>
-            <a:endParaRPr lang="en-US" sz="1600" dirty="0"/>
-          </a:p>
-        </p:txBody>
-      </p:sp>
-      <p:sp>
-        <p:nvSpPr>
-          <p:cNvPr id="7" name="Text 5"/>
+            <a:endParaRPr lang="en-US" sz="1500" dirty="0"/>
+          </a:p>
+        </p:txBody>
+      </p:sp>
+      <p:sp>
+        <p:nvSpPr>
+          <p:cNvPr id="10" name="Text 7"/>
           <p:cNvSpPr txBox="1"/>
           <p:nvPr/>
         </p:nvSpPr>
         <p:spPr>
           <a:xfrm>
-            <a:off x="1371600" y="2212848"/>
-            <a:ext cx="7040880" cy="548640"/>
+            <a:off x="1508760" y="2103120"/>
+            <a:ext cx="6766560" cy="548640"/>
           </a:xfrm>
           <a:prstGeom prst="rect">
             <a:avLst/>
@@ -3624,7 +4308,7 @@
               <a:buNone/>
             </a:pPr>
             <a:r>
-              <a:rPr lang="en-US" sz="1400" dirty="0">
+              <a:rPr lang="en-US" sz="1300" dirty="0">
                 <a:solidFill>
                   <a:srgbClr val="FFFFFF"/>
                 </a:solidFill>
@@ -3634,28 +4318,50 @@
               </a:rPr>
               <a:t>TRANSPARENCE — Toutes les transactions sont visibles par tous les participants. Chaque personne peut vérifier l'historique complet.</a:t>
             </a:r>
-            <a:endParaRPr lang="en-US" sz="1400" dirty="0"/>
-          </a:p>
-        </p:txBody>
-      </p:sp>
-      <p:sp>
-        <p:nvSpPr>
-          <p:cNvPr id="8" name="Text 6"/>
-          <p:cNvSpPr txBox="1"/>
-          <p:nvPr/>
-        </p:nvSpPr>
-        <p:spPr>
-          <a:xfrm>
-            <a:off x="731520" y="2871216"/>
-            <a:ext cx="457200" cy="548640"/>
+            <a:endParaRPr lang="en-US" sz="1300" dirty="0"/>
+          </a:p>
+        </p:txBody>
+      </p:sp>
+      <p:sp>
+        <p:nvSpPr>
+          <p:cNvPr id="11" name="Shape 8"/>
+          <p:cNvSpPr/>
+          <p:nvPr/>
+        </p:nvSpPr>
+        <p:spPr>
+          <a:xfrm>
+            <a:off x="731520" y="2743200"/>
+            <a:ext cx="7680960" cy="548640"/>
           </a:xfrm>
           <a:prstGeom prst="roundRect">
             <a:avLst>
-              <a:gd name="adj" fmla="val 50000"/>
+              <a:gd name="adj" fmla="val 13333"/>
             </a:avLst>
           </a:prstGeom>
           <a:solidFill>
-            <a:srgbClr val="00BFA6"/>
+            <a:srgbClr val="0F1419"/>
+          </a:solidFill>
+          <a:ln/>
+        </p:spPr>
+      </p:sp>
+      <p:sp>
+        <p:nvSpPr>
+          <p:cNvPr id="12" name="Text 9"/>
+          <p:cNvSpPr txBox="1"/>
+          <p:nvPr/>
+        </p:nvSpPr>
+        <p:spPr>
+          <a:xfrm>
+            <a:off x="914400" y="2743200"/>
+            <a:ext cx="411480" cy="548640"/>
+          </a:xfrm>
+          <a:prstGeom prst="roundRect">
+            <a:avLst>
+              <a:gd name="adj" fmla="val 48889"/>
+            </a:avLst>
+          </a:prstGeom>
+          <a:solidFill>
+            <a:srgbClr val="3B82F6"/>
           </a:solidFill>
           <a:ln/>
         </p:spPr>
@@ -3667,7 +4373,7 @@
               <a:buNone/>
             </a:pPr>
             <a:r>
-              <a:rPr lang="en-US" sz="1600" b="1" dirty="0">
+              <a:rPr lang="en-US" sz="1500" b="1" dirty="0">
                 <a:solidFill>
                   <a:srgbClr val="0F1419"/>
                 </a:solidFill>
@@ -3677,20 +4383,20 @@
               </a:rPr>
               <a:t>3</a:t>
             </a:r>
-            <a:endParaRPr lang="en-US" sz="1600" dirty="0"/>
-          </a:p>
-        </p:txBody>
-      </p:sp>
-      <p:sp>
-        <p:nvSpPr>
-          <p:cNvPr id="9" name="Text 7"/>
+            <a:endParaRPr lang="en-US" sz="1500" dirty="0"/>
+          </a:p>
+        </p:txBody>
+      </p:sp>
+      <p:sp>
+        <p:nvSpPr>
+          <p:cNvPr id="13" name="Text 10"/>
           <p:cNvSpPr txBox="1"/>
           <p:nvPr/>
         </p:nvSpPr>
         <p:spPr>
           <a:xfrm>
-            <a:off x="1371600" y="2871216"/>
-            <a:ext cx="7040880" cy="548640"/>
+            <a:off x="1508760" y="2743200"/>
+            <a:ext cx="6766560" cy="548640"/>
           </a:xfrm>
           <a:prstGeom prst="rect">
             <a:avLst/>
@@ -3706,7 +4412,7 @@
               <a:buNone/>
             </a:pPr>
             <a:r>
-              <a:rPr lang="en-US" sz="1400" dirty="0">
+              <a:rPr lang="en-US" sz="1300" dirty="0">
                 <a:solidFill>
                   <a:srgbClr val="FFFFFF"/>
                 </a:solidFill>
@@ -3716,28 +4422,50 @@
               </a:rPr>
               <a:t>IMMUTABILITÉ — Une fois qu'une transaction est confirmée et ajoutée à la blockchain, il est pratiquement impossible de la modifier.</a:t>
             </a:r>
-            <a:endParaRPr lang="en-US" sz="1400" dirty="0"/>
-          </a:p>
-        </p:txBody>
-      </p:sp>
-      <p:sp>
-        <p:nvSpPr>
-          <p:cNvPr id="10" name="Text 8"/>
-          <p:cNvSpPr txBox="1"/>
-          <p:nvPr/>
-        </p:nvSpPr>
-        <p:spPr>
-          <a:xfrm>
-            <a:off x="731520" y="3529584"/>
-            <a:ext cx="457200" cy="548640"/>
+            <a:endParaRPr lang="en-US" sz="1300" dirty="0"/>
+          </a:p>
+        </p:txBody>
+      </p:sp>
+      <p:sp>
+        <p:nvSpPr>
+          <p:cNvPr id="14" name="Shape 11"/>
+          <p:cNvSpPr/>
+          <p:nvPr/>
+        </p:nvSpPr>
+        <p:spPr>
+          <a:xfrm>
+            <a:off x="731520" y="3383280"/>
+            <a:ext cx="7680960" cy="548640"/>
           </a:xfrm>
           <a:prstGeom prst="roundRect">
             <a:avLst>
-              <a:gd name="adj" fmla="val 50000"/>
+              <a:gd name="adj" fmla="val 13333"/>
             </a:avLst>
           </a:prstGeom>
           <a:solidFill>
-            <a:srgbClr val="00BFA6"/>
+            <a:srgbClr val="0F1419"/>
+          </a:solidFill>
+          <a:ln/>
+        </p:spPr>
+      </p:sp>
+      <p:sp>
+        <p:nvSpPr>
+          <p:cNvPr id="15" name="Text 12"/>
+          <p:cNvSpPr txBox="1"/>
+          <p:nvPr/>
+        </p:nvSpPr>
+        <p:spPr>
+          <a:xfrm>
+            <a:off x="914400" y="3383280"/>
+            <a:ext cx="411480" cy="548640"/>
+          </a:xfrm>
+          <a:prstGeom prst="roundRect">
+            <a:avLst>
+              <a:gd name="adj" fmla="val 48889"/>
+            </a:avLst>
+          </a:prstGeom>
+          <a:solidFill>
+            <a:srgbClr val="3B82F6"/>
           </a:solidFill>
           <a:ln/>
         </p:spPr>
@@ -3749,7 +4477,7 @@
               <a:buNone/>
             </a:pPr>
             <a:r>
-              <a:rPr lang="en-US" sz="1600" b="1" dirty="0">
+              <a:rPr lang="en-US" sz="1500" b="1" dirty="0">
                 <a:solidFill>
                   <a:srgbClr val="0F1419"/>
                 </a:solidFill>
@@ -3759,20 +4487,20 @@
               </a:rPr>
               <a:t>4</a:t>
             </a:r>
-            <a:endParaRPr lang="en-US" sz="1600" dirty="0"/>
-          </a:p>
-        </p:txBody>
-      </p:sp>
-      <p:sp>
-        <p:nvSpPr>
-          <p:cNvPr id="11" name="Text 9"/>
+            <a:endParaRPr lang="en-US" sz="1500" dirty="0"/>
+          </a:p>
+        </p:txBody>
+      </p:sp>
+      <p:sp>
+        <p:nvSpPr>
+          <p:cNvPr id="16" name="Text 13"/>
           <p:cNvSpPr txBox="1"/>
           <p:nvPr/>
         </p:nvSpPr>
         <p:spPr>
           <a:xfrm>
-            <a:off x="1371600" y="3529584"/>
-            <a:ext cx="7040880" cy="548640"/>
+            <a:off x="1508760" y="3383280"/>
+            <a:ext cx="6766560" cy="548640"/>
           </a:xfrm>
           <a:prstGeom prst="rect">
             <a:avLst/>
@@ -3788,7 +4516,7 @@
               <a:buNone/>
             </a:pPr>
             <a:r>
-              <a:rPr lang="en-US" sz="1400" dirty="0">
+              <a:rPr lang="en-US" sz="1300" dirty="0">
                 <a:solidFill>
                   <a:srgbClr val="FFFFFF"/>
                 </a:solidFill>
@@ -3798,7 +4526,7 @@
               </a:rPr>
               <a:t>SÉCURITÉ — La blockchain utilise la cryptographie avancée pour sécuriser les données. Chaque bloc est lié au précédent par un hash cryptographique.</a:t>
             </a:r>
-            <a:endParaRPr lang="en-US" sz="1400" dirty="0"/>
+            <a:endParaRPr lang="en-US" sz="1300" dirty="0"/>
           </a:p>
         </p:txBody>
       </p:sp>
@@ -3834,35 +4562,105 @@
           <a:chExt cx="0" cy="0"/>
         </a:xfrm>
       </p:grpSpPr>
-      <p:sp>
-        <p:nvSpPr>
-          <p:cNvPr id="2" name="Shape 0"/>
+      <p:pic>
+        <p:nvPicPr>
+          <p:cNvPr id="2" name="Image 0" descr="preencoded.png">    </p:cNvPr>
+          <p:cNvPicPr>
+            <a:picLocks noChangeAspect="1"/>
+          </p:cNvPicPr>
+          <p:nvPr/>
+        </p:nvPicPr>
+        <p:blipFill>
+          <a:blip r:embed="rId1"/>
+          <a:stretch>
+            <a:fillRect/>
+          </a:stretch>
+        </p:blipFill>
+        <p:spPr>
+          <a:xfrm>
+            <a:off x="7315200" y="548640"/>
+            <a:ext cx="1280160" cy="1280160"/>
+          </a:xfrm>
+          <a:prstGeom prst="rect">
+            <a:avLst/>
+          </a:prstGeom>
+        </p:spPr>
+      </p:pic>
+      <p:pic>
+        <p:nvPicPr>
+          <p:cNvPr id="3" name="Image 1" descr="preencoded.png">    </p:cNvPr>
+          <p:cNvPicPr>
+            <a:picLocks noChangeAspect="1"/>
+          </p:cNvPicPr>
+          <p:nvPr/>
+        </p:nvPicPr>
+        <p:blipFill>
+          <a:blip r:embed="rId2"/>
+          <a:stretch>
+            <a:fillRect/>
+          </a:stretch>
+        </p:blipFill>
+        <p:spPr>
+          <a:xfrm>
+            <a:off x="7772400" y="2011680"/>
+            <a:ext cx="822960" cy="822960"/>
+          </a:xfrm>
+          <a:prstGeom prst="rect">
+            <a:avLst/>
+          </a:prstGeom>
+        </p:spPr>
+      </p:pic>
+      <p:sp>
+        <p:nvSpPr>
+          <p:cNvPr id="4" name="Shape 0"/>
           <p:cNvSpPr/>
           <p:nvPr/>
         </p:nvSpPr>
         <p:spPr>
           <a:xfrm>
-            <a:off x="548640" y="914400"/>
-            <a:ext cx="45720" cy="2560320"/>
-          </a:xfrm>
-          <a:prstGeom prst="rect">
+            <a:off x="6583680" y="-274320"/>
+            <a:ext cx="3200400" cy="3200400"/>
+          </a:xfrm>
+          <a:prstGeom prst="ellipse">
             <a:avLst/>
           </a:prstGeom>
           <a:solidFill>
-            <a:srgbClr val="00BFA6"/>
+            <a:srgbClr val="3B82F6">
+              <a:alpha val="6000"/>
+            </a:srgbClr>
           </a:solidFill>
           <a:ln/>
         </p:spPr>
       </p:sp>
       <p:sp>
         <p:nvSpPr>
-          <p:cNvPr id="3" name="Text 1"/>
+          <p:cNvPr id="5" name="Shape 1"/>
+          <p:cNvSpPr/>
+          <p:nvPr/>
+        </p:nvSpPr>
+        <p:spPr>
+          <a:xfrm>
+            <a:off x="731520" y="914400"/>
+            <a:ext cx="45720" cy="2194560"/>
+          </a:xfrm>
+          <a:prstGeom prst="rect">
+            <a:avLst/>
+          </a:prstGeom>
+          <a:solidFill>
+            <a:srgbClr val="3B82F6"/>
+          </a:solidFill>
+          <a:ln/>
+        </p:spPr>
+      </p:sp>
+      <p:sp>
+        <p:nvSpPr>
+          <p:cNvPr id="6" name="Text 2"/>
           <p:cNvSpPr txBox="1"/>
           <p:nvPr/>
         </p:nvSpPr>
         <p:spPr>
           <a:xfrm>
-            <a:off x="822960" y="1097280"/>
+            <a:off x="960120" y="914400"/>
             <a:ext cx="2743200" cy="365760"/>
           </a:xfrm>
           <a:prstGeom prst="rect">
@@ -3881,13 +4679,13 @@
             <a:r>
               <a:rPr lang="en-US" sz="1200" b="1" spc="200" kern="0" dirty="0">
                 <a:solidFill>
-                  <a:srgbClr val="00BFA6"/>
-                </a:solidFill>
-                <a:latin typeface="Calibri" pitchFamily="34" charset="0"/>
-                <a:ea typeface="Calibri" pitchFamily="34" charset="-122"/>
-                <a:cs typeface="Calibri" pitchFamily="34" charset="-120"/>
-              </a:rPr>
-              <a:t>Lecon 2 / 2</a:t>
+                  <a:srgbClr val="3B82F6"/>
+                </a:solidFill>
+                <a:latin typeface="Calibri" pitchFamily="34" charset="0"/>
+                <a:ea typeface="Calibri" pitchFamily="34" charset="-122"/>
+                <a:cs typeface="Calibri" pitchFamily="34" charset="-120"/>
+              </a:rPr>
+              <a:t>Leçon 2 / 2</a:t>
             </a:r>
             <a:endParaRPr lang="en-US" sz="1200" dirty="0"/>
           </a:p>
@@ -3895,14 +4693,14 @@
       </p:sp>
       <p:sp>
         <p:nvSpPr>
-          <p:cNvPr id="4" name="Text 2"/>
+          <p:cNvPr id="7" name="Text 3"/>
           <p:cNvSpPr txBox="1"/>
           <p:nvPr/>
         </p:nvSpPr>
         <p:spPr>
           <a:xfrm>
-            <a:off x="822960" y="1645920"/>
-            <a:ext cx="7498080" cy="1280160"/>
+            <a:off x="960120" y="1371600"/>
+            <a:ext cx="6217920" cy="1463040"/>
           </a:xfrm>
           <a:prstGeom prst="rect">
             <a:avLst/>
@@ -3918,7 +4716,7 @@
               <a:buNone/>
             </a:pPr>
             <a:r>
-              <a:rPr lang="en-US" sz="3000" b="1" dirty="0">
+              <a:rPr lang="en-US" sz="2800" b="1" dirty="0">
                 <a:solidFill>
                   <a:srgbClr val="FFFFFF"/>
                 </a:solidFill>
@@ -3928,19 +4726,19 @@
               </a:rPr>
               <a:t>L'histoire du Bitcoin</a:t>
             </a:r>
-            <a:endParaRPr lang="en-US" sz="3000" dirty="0"/>
-          </a:p>
-        </p:txBody>
-      </p:sp>
-      <p:sp>
-        <p:nvSpPr>
-          <p:cNvPr id="5" name="Text 3"/>
+            <a:endParaRPr lang="en-US" sz="2800" dirty="0"/>
+          </a:p>
+        </p:txBody>
+      </p:sp>
+      <p:sp>
+        <p:nvSpPr>
+          <p:cNvPr id="8" name="Text 4"/>
           <p:cNvSpPr txBox="1"/>
           <p:nvPr/>
         </p:nvSpPr>
         <p:spPr>
           <a:xfrm>
-            <a:off x="822960" y="4206240"/>
+            <a:off x="960120" y="4114800"/>
             <a:ext cx="5486400" cy="320040"/>
           </a:xfrm>
           <a:prstGeom prst="rect">
@@ -4005,7 +4803,53 @@
       </p:grpSpPr>
       <p:sp>
         <p:nvSpPr>
-          <p:cNvPr id="2" name="Text 0"/>
+          <p:cNvPr id="2" name="Shape 0"/>
+          <p:cNvSpPr/>
+          <p:nvPr/>
+        </p:nvSpPr>
+        <p:spPr>
+          <a:xfrm>
+            <a:off x="7955280" y="182880"/>
+            <a:ext cx="640080" cy="640080"/>
+          </a:xfrm>
+          <a:prstGeom prst="ellipse">
+            <a:avLst/>
+          </a:prstGeom>
+          <a:solidFill>
+            <a:srgbClr val="3B82F6">
+              <a:alpha val="12000"/>
+            </a:srgbClr>
+          </a:solidFill>
+          <a:ln/>
+        </p:spPr>
+      </p:sp>
+      <p:pic>
+        <p:nvPicPr>
+          <p:cNvPr id="3" name="Image 0" descr="preencoded.png">    </p:cNvPr>
+          <p:cNvPicPr>
+            <a:picLocks noChangeAspect="1"/>
+          </p:cNvPicPr>
+          <p:nvPr/>
+        </p:nvPicPr>
+        <p:blipFill>
+          <a:blip r:embed="rId1"/>
+          <a:stretch>
+            <a:fillRect/>
+          </a:stretch>
+        </p:blipFill>
+        <p:spPr>
+          <a:xfrm>
+            <a:off x="8028432" y="256032"/>
+            <a:ext cx="493776" cy="493776"/>
+          </a:xfrm>
+          <a:prstGeom prst="rect">
+            <a:avLst/>
+          </a:prstGeom>
+        </p:spPr>
+      </p:pic>
+      <p:sp>
+        <p:nvSpPr>
+          <p:cNvPr id="4" name="Text 1"/>
           <p:cNvSpPr txBox="1"/>
           <p:nvPr/>
         </p:nvSpPr>
@@ -4174,7 +5018,7 @@
       </p:sp>
       <p:sp>
         <p:nvSpPr>
-          <p:cNvPr id="3" name="Text 1"/>
+          <p:cNvPr id="5" name="Text 2"/>
           <p:cNvSpPr txBox="1"/>
           <p:nvPr/>
         </p:nvSpPr>
@@ -4205,7 +5049,7 @@
                 <a:ea typeface="Calibri" pitchFamily="34" charset="-122"/>
                 <a:cs typeface="Calibri" pitchFamily="34" charset="-120"/>
               </a:rPr>
-              <a:t>Module 1 — Lecon 2</a:t>
+              <a:t>Module 1 — Leçon 2</a:t>
             </a:r>
             <a:endParaRPr lang="en-US" sz="900" dirty="0"/>
           </a:p>
@@ -4245,7 +5089,53 @@
       </p:grpSpPr>
       <p:sp>
         <p:nvSpPr>
-          <p:cNvPr id="2" name="Text 0"/>
+          <p:cNvPr id="2" name="Shape 0"/>
+          <p:cNvSpPr/>
+          <p:nvPr/>
+        </p:nvSpPr>
+        <p:spPr>
+          <a:xfrm>
+            <a:off x="7955280" y="182880"/>
+            <a:ext cx="640080" cy="640080"/>
+          </a:xfrm>
+          <a:prstGeom prst="ellipse">
+            <a:avLst/>
+          </a:prstGeom>
+          <a:solidFill>
+            <a:srgbClr val="3B82F6">
+              <a:alpha val="12000"/>
+            </a:srgbClr>
+          </a:solidFill>
+          <a:ln/>
+        </p:spPr>
+      </p:sp>
+      <p:pic>
+        <p:nvPicPr>
+          <p:cNvPr id="3" name="Image 0" descr="preencoded.png">    </p:cNvPr>
+          <p:cNvPicPr>
+            <a:picLocks noChangeAspect="1"/>
+          </p:cNvPicPr>
+          <p:nvPr/>
+        </p:nvPicPr>
+        <p:blipFill>
+          <a:blip r:embed="rId1"/>
+          <a:stretch>
+            <a:fillRect/>
+          </a:stretch>
+        </p:blipFill>
+        <p:spPr>
+          <a:xfrm>
+            <a:off x="8028432" y="256032"/>
+            <a:ext cx="493776" cy="493776"/>
+          </a:xfrm>
+          <a:prstGeom prst="rect">
+            <a:avLst/>
+          </a:prstGeom>
+        </p:spPr>
+      </p:pic>
+      <p:sp>
+        <p:nvSpPr>
+          <p:cNvPr id="4" name="Text 1"/>
           <p:cNvSpPr txBox="1"/>
           <p:nvPr/>
         </p:nvSpPr>
@@ -4309,7 +5199,7 @@
       </p:sp>
       <p:sp>
         <p:nvSpPr>
-          <p:cNvPr id="3" name="Text 1"/>
+          <p:cNvPr id="5" name="Text 2"/>
           <p:cNvSpPr txBox="1"/>
           <p:nvPr/>
         </p:nvSpPr>
@@ -4340,7 +5230,7 @@
                 <a:ea typeface="Calibri" pitchFamily="34" charset="-122"/>
                 <a:cs typeface="Calibri" pitchFamily="34" charset="-120"/>
               </a:rPr>
-              <a:t>Module 1 — Lecon 2</a:t>
+              <a:t>Module 1 — Leçon 2</a:t>
             </a:r>
             <a:endParaRPr lang="en-US" sz="900" dirty="0"/>
           </a:p>

</xml_diff>

<commit_message>
feat(academy): redesign UX + enrich course materials with illustrations (#42)
- 4-view navigation (catalog → course → module → lesson) replacing accordion layout
- Color-coded module cards grid with progress rings and download buttons
- All 11 modules now have visually rich PPTX/PDF with embedded icons, varied layouts
- Added Module-02 (Sécurité et portefeuilles) materials
</commit_message>
<xml_diff>
--- a/public/course-materials/pptx/Module-01-Les-fondamentaux-de-la-blockchain.pptx
+++ b/public/course-materials/pptx/Module-01-Les-fondamentaux-de-la-blockchain.pptx
@@ -1773,28 +1773,96 @@
         </p:nvSpPr>
         <p:spPr>
           <a:xfrm>
+            <a:off x="6400800" y="-457200"/>
+            <a:ext cx="3657600" cy="3657600"/>
+          </a:xfrm>
+          <a:prstGeom prst="ellipse">
+            <a:avLst/>
+          </a:prstGeom>
+          <a:solidFill>
+            <a:srgbClr val="3B82F6">
+              <a:alpha val="8000"/>
+            </a:srgbClr>
+          </a:solidFill>
+          <a:ln/>
+        </p:spPr>
+      </p:sp>
+      <p:sp>
+        <p:nvSpPr>
+          <p:cNvPr id="3" name="Shape 1"/>
+          <p:cNvSpPr/>
+          <p:nvPr/>
+        </p:nvSpPr>
+        <p:spPr>
+          <a:xfrm>
+            <a:off x="7315200" y="2286000"/>
+            <a:ext cx="2743200" cy="2743200"/>
+          </a:xfrm>
+          <a:prstGeom prst="ellipse">
+            <a:avLst/>
+          </a:prstGeom>
+          <a:solidFill>
+            <a:srgbClr val="3B82F6">
+              <a:alpha val="5000"/>
+            </a:srgbClr>
+          </a:solidFill>
+          <a:ln/>
+        </p:spPr>
+      </p:sp>
+      <p:sp>
+        <p:nvSpPr>
+          <p:cNvPr id="4" name="Shape 2"/>
+          <p:cNvSpPr/>
+          <p:nvPr/>
+        </p:nvSpPr>
+        <p:spPr>
+          <a:xfrm>
             <a:off x="0" y="0"/>
-            <a:ext cx="9144000" cy="54864"/>
+            <a:ext cx="9144000" cy="45720"/>
           </a:xfrm>
           <a:prstGeom prst="rect">
             <a:avLst/>
           </a:prstGeom>
           <a:solidFill>
-            <a:srgbClr val="00BFA6"/>
+            <a:srgbClr val="3B82F6"/>
           </a:solidFill>
           <a:ln/>
         </p:spPr>
       </p:sp>
-      <p:sp>
-        <p:nvSpPr>
-          <p:cNvPr id="3" name="Text 1"/>
+      <p:pic>
+        <p:nvPicPr>
+          <p:cNvPr id="5" name="Image 0" descr="preencoded.png">    </p:cNvPr>
+          <p:cNvPicPr>
+            <a:picLocks noChangeAspect="1"/>
+          </p:cNvPicPr>
+          <p:nvPr/>
+        </p:nvPicPr>
+        <p:blipFill>
+          <a:blip r:embed="rId1"/>
+          <a:stretch>
+            <a:fillRect/>
+          </a:stretch>
+        </p:blipFill>
+        <p:spPr>
+          <a:xfrm>
+            <a:off x="7132320" y="1097280"/>
+            <a:ext cx="1463040" cy="1463040"/>
+          </a:xfrm>
+          <a:prstGeom prst="rect">
+            <a:avLst/>
+          </a:prstGeom>
+        </p:spPr>
+      </p:pic>
+      <p:sp>
+        <p:nvSpPr>
+          <p:cNvPr id="6" name="Text 3"/>
           <p:cNvSpPr txBox="1"/>
           <p:nvPr/>
         </p:nvSpPr>
         <p:spPr>
           <a:xfrm>
-            <a:off x="731520" y="1097280"/>
-            <a:ext cx="2286000" cy="457200"/>
+            <a:off x="731520" y="914400"/>
+            <a:ext cx="2286000" cy="365760"/>
           </a:xfrm>
           <a:prstGeom prst="rect">
             <a:avLst/>
@@ -1810,9 +1878,9 @@
               <a:buNone/>
             </a:pPr>
             <a:r>
-              <a:rPr lang="en-US" sz="1400" b="1" spc="400" kern="0" dirty="0">
-                <a:solidFill>
-                  <a:srgbClr val="00BFA6"/>
+              <a:rPr lang="en-US" sz="1300" b="1" spc="400" kern="0" dirty="0">
+                <a:solidFill>
+                  <a:srgbClr val="3B82F6"/>
                 </a:solidFill>
                 <a:latin typeface="Calibri" pitchFamily="34" charset="0"/>
                 <a:ea typeface="Calibri" pitchFamily="34" charset="-122"/>
@@ -1820,20 +1888,20 @@
               </a:rPr>
               <a:t>MODULE 1</a:t>
             </a:r>
-            <a:endParaRPr lang="en-US" sz="1400" dirty="0"/>
-          </a:p>
-        </p:txBody>
-      </p:sp>
-      <p:sp>
-        <p:nvSpPr>
-          <p:cNvPr id="4" name="Text 2"/>
+            <a:endParaRPr lang="en-US" sz="1300" dirty="0"/>
+          </a:p>
+        </p:txBody>
+      </p:sp>
+      <p:sp>
+        <p:nvSpPr>
+          <p:cNvPr id="7" name="Text 4"/>
           <p:cNvSpPr txBox="1"/>
           <p:nvPr/>
         </p:nvSpPr>
         <p:spPr>
           <a:xfrm>
-            <a:off x="731520" y="1645920"/>
-            <a:ext cx="7680960" cy="1463040"/>
+            <a:off x="731520" y="1371600"/>
+            <a:ext cx="5943600" cy="1645920"/>
           </a:xfrm>
           <a:prstGeom prst="rect">
             <a:avLst/>
@@ -1865,14 +1933,34 @@
       </p:sp>
       <p:sp>
         <p:nvSpPr>
-          <p:cNvPr id="5" name="Text 3"/>
+          <p:cNvPr id="8" name="Shape 5"/>
+          <p:cNvSpPr/>
+          <p:nvPr/>
+        </p:nvSpPr>
+        <p:spPr>
+          <a:xfrm>
+            <a:off x="731520" y="3291840"/>
+            <a:ext cx="1828800" cy="36576"/>
+          </a:xfrm>
+          <a:prstGeom prst="rect">
+            <a:avLst/>
+          </a:prstGeom>
+          <a:solidFill>
+            <a:srgbClr val="3B82F6"/>
+          </a:solidFill>
+          <a:ln/>
+        </p:spPr>
+      </p:sp>
+      <p:sp>
+        <p:nvSpPr>
+          <p:cNvPr id="9" name="Text 6"/>
           <p:cNvSpPr txBox="1"/>
           <p:nvPr/>
         </p:nvSpPr>
         <p:spPr>
           <a:xfrm>
-            <a:off x="731520" y="4023360"/>
-            <a:ext cx="2743200" cy="365760"/>
+            <a:off x="731520" y="3566160"/>
+            <a:ext cx="2743200" cy="320040"/>
           </a:xfrm>
           <a:prstGeom prst="rect">
             <a:avLst/>
@@ -1888,7 +1976,7 @@
               <a:buNone/>
             </a:pPr>
             <a:r>
-              <a:rPr lang="en-US" sz="1200" spc="300" kern="0" dirty="0">
+              <a:rPr lang="en-US" sz="1100" spc="300" kern="0" dirty="0">
                 <a:solidFill>
                   <a:srgbClr val="64748B"/>
                 </a:solidFill>
@@ -1898,20 +1986,20 @@
               </a:rPr>
               <a:t>TEREX ACADEMY</a:t>
             </a:r>
-            <a:endParaRPr lang="en-US" sz="1200" dirty="0"/>
-          </a:p>
-        </p:txBody>
-      </p:sp>
-      <p:sp>
-        <p:nvSpPr>
-          <p:cNvPr id="6" name="Text 4"/>
+            <a:endParaRPr lang="en-US" sz="1100" dirty="0"/>
+          </a:p>
+        </p:txBody>
+      </p:sp>
+      <p:sp>
+        <p:nvSpPr>
+          <p:cNvPr id="10" name="Text 7"/>
           <p:cNvSpPr txBox="1"/>
           <p:nvPr/>
         </p:nvSpPr>
         <p:spPr>
           <a:xfrm>
-            <a:off x="731520" y="4389120"/>
-            <a:ext cx="3657600" cy="320040"/>
+            <a:off x="731520" y="3931920"/>
+            <a:ext cx="3657600" cy="274320"/>
           </a:xfrm>
           <a:prstGeom prst="rect">
             <a:avLst/>
@@ -1973,16 +2061,40 @@
           <a:chExt cx="0" cy="0"/>
         </a:xfrm>
       </p:grpSpPr>
-      <p:sp>
-        <p:nvSpPr>
-          <p:cNvPr id="2" name="Text 0"/>
+      <p:pic>
+        <p:nvPicPr>
+          <p:cNvPr id="2" name="Image 0" descr="preencoded.png">    </p:cNvPr>
+          <p:cNvPicPr>
+            <a:picLocks noChangeAspect="1"/>
+          </p:cNvPicPr>
+          <p:nvPr/>
+        </p:nvPicPr>
+        <p:blipFill>
+          <a:blip r:embed="rId1"/>
+          <a:stretch>
+            <a:fillRect/>
+          </a:stretch>
+        </p:blipFill>
+        <p:spPr>
+          <a:xfrm>
+            <a:off x="731520" y="320040"/>
+            <a:ext cx="457200" cy="457200"/>
+          </a:xfrm>
+          <a:prstGeom prst="rect">
+            <a:avLst/>
+          </a:prstGeom>
+        </p:spPr>
+      </p:pic>
+      <p:sp>
+        <p:nvSpPr>
+          <p:cNvPr id="3" name="Text 0"/>
           <p:cNvSpPr txBox="1"/>
           <p:nvPr/>
         </p:nvSpPr>
         <p:spPr>
           <a:xfrm>
-            <a:off x="731520" y="457200"/>
-            <a:ext cx="2743200" cy="365760"/>
+            <a:off x="1280160" y="365760"/>
+            <a:ext cx="2743200" cy="320040"/>
           </a:xfrm>
           <a:prstGeom prst="rect">
             <a:avLst/>
@@ -2014,14 +2126,14 @@
       </p:sp>
       <p:sp>
         <p:nvSpPr>
-          <p:cNvPr id="3" name="Text 1"/>
+          <p:cNvPr id="4" name="Text 1"/>
           <p:cNvSpPr txBox="1"/>
           <p:nvPr/>
         </p:nvSpPr>
         <p:spPr>
           <a:xfrm>
-            <a:off x="731520" y="868680"/>
-            <a:ext cx="7680960" cy="502920"/>
+            <a:off x="731520" y="822960"/>
+            <a:ext cx="7680960" cy="457200"/>
           </a:xfrm>
           <a:prstGeom prst="rect">
             <a:avLst/>
@@ -2037,7 +2149,7 @@
               <a:buNone/>
             </a:pPr>
             <a:r>
-              <a:rPr lang="en-US" sz="2200" b="1" dirty="0">
+              <a:rPr lang="en-US" sz="2000" b="1" dirty="0">
                 <a:solidFill>
                   <a:srgbClr val="FFFFFF"/>
                 </a:solidFill>
@@ -2047,28 +2159,50 @@
               </a:rPr>
               <a:t>L'histoire du Bitcoin</a:t>
             </a:r>
-            <a:endParaRPr lang="en-US" sz="2200" dirty="0"/>
-          </a:p>
-        </p:txBody>
-      </p:sp>
-      <p:sp>
-        <p:nvSpPr>
-          <p:cNvPr id="4" name="Text 2"/>
-          <p:cNvSpPr txBox="1"/>
-          <p:nvPr/>
-        </p:nvSpPr>
-        <p:spPr>
-          <a:xfrm>
-            <a:off x="731520" y="1554480"/>
-            <a:ext cx="457200" cy="548640"/>
+            <a:endParaRPr lang="en-US" sz="2000" dirty="0"/>
+          </a:p>
+        </p:txBody>
+      </p:sp>
+      <p:sp>
+        <p:nvSpPr>
+          <p:cNvPr id="5" name="Shape 2"/>
+          <p:cNvSpPr/>
+          <p:nvPr/>
+        </p:nvSpPr>
+        <p:spPr>
+          <a:xfrm>
+            <a:off x="731520" y="1463040"/>
+            <a:ext cx="7680960" cy="548640"/>
           </a:xfrm>
           <a:prstGeom prst="roundRect">
             <a:avLst>
-              <a:gd name="adj" fmla="val 50000"/>
+              <a:gd name="adj" fmla="val 13333"/>
             </a:avLst>
           </a:prstGeom>
           <a:solidFill>
-            <a:srgbClr val="00BFA6"/>
+            <a:srgbClr val="0F1419"/>
+          </a:solidFill>
+          <a:ln/>
+        </p:spPr>
+      </p:sp>
+      <p:sp>
+        <p:nvSpPr>
+          <p:cNvPr id="6" name="Text 3"/>
+          <p:cNvSpPr txBox="1"/>
+          <p:nvPr/>
+        </p:nvSpPr>
+        <p:spPr>
+          <a:xfrm>
+            <a:off x="914400" y="1463040"/>
+            <a:ext cx="411480" cy="548640"/>
+          </a:xfrm>
+          <a:prstGeom prst="roundRect">
+            <a:avLst>
+              <a:gd name="adj" fmla="val 48889"/>
+            </a:avLst>
+          </a:prstGeom>
+          <a:solidFill>
+            <a:srgbClr val="3B82F6"/>
           </a:solidFill>
           <a:ln/>
         </p:spPr>
@@ -2080,7 +2214,7 @@
               <a:buNone/>
             </a:pPr>
             <a:r>
-              <a:rPr lang="en-US" sz="1600" b="1" dirty="0">
+              <a:rPr lang="en-US" sz="1500" b="1" dirty="0">
                 <a:solidFill>
                   <a:srgbClr val="0F1419"/>
                 </a:solidFill>
@@ -2090,20 +2224,20 @@
               </a:rPr>
               <a:t>1</a:t>
             </a:r>
-            <a:endParaRPr lang="en-US" sz="1600" dirty="0"/>
-          </a:p>
-        </p:txBody>
-      </p:sp>
-      <p:sp>
-        <p:nvSpPr>
-          <p:cNvPr id="5" name="Text 3"/>
+            <a:endParaRPr lang="en-US" sz="1500" dirty="0"/>
+          </a:p>
+        </p:txBody>
+      </p:sp>
+      <p:sp>
+        <p:nvSpPr>
+          <p:cNvPr id="7" name="Text 4"/>
           <p:cNvSpPr txBox="1"/>
           <p:nvPr/>
         </p:nvSpPr>
         <p:spPr>
           <a:xfrm>
-            <a:off x="1371600" y="1554480"/>
-            <a:ext cx="7040880" cy="548640"/>
+            <a:off x="1508760" y="1463040"/>
+            <a:ext cx="6766560" cy="548640"/>
           </a:xfrm>
           <a:prstGeom prst="rect">
             <a:avLst/>
@@ -2119,7 +2253,7 @@
               <a:buNone/>
             </a:pPr>
             <a:r>
-              <a:rPr lang="en-US" sz="1400" dirty="0">
+              <a:rPr lang="en-US" sz="1300" dirty="0">
                 <a:solidFill>
                   <a:srgbClr val="FFFFFF"/>
                 </a:solidFill>
@@ -2129,28 +2263,50 @@
               </a:rPr>
               <a:t>2008 — Satoshi Nakamoto publie le white paper "Bitcoin: A Peer-to-Peer Electronic Cash System"</a:t>
             </a:r>
-            <a:endParaRPr lang="en-US" sz="1400" dirty="0"/>
-          </a:p>
-        </p:txBody>
-      </p:sp>
-      <p:sp>
-        <p:nvSpPr>
-          <p:cNvPr id="6" name="Text 4"/>
-          <p:cNvSpPr txBox="1"/>
-          <p:nvPr/>
-        </p:nvSpPr>
-        <p:spPr>
-          <a:xfrm>
-            <a:off x="731520" y="2212848"/>
-            <a:ext cx="457200" cy="548640"/>
+            <a:endParaRPr lang="en-US" sz="1300" dirty="0"/>
+          </a:p>
+        </p:txBody>
+      </p:sp>
+      <p:sp>
+        <p:nvSpPr>
+          <p:cNvPr id="8" name="Shape 5"/>
+          <p:cNvSpPr/>
+          <p:nvPr/>
+        </p:nvSpPr>
+        <p:spPr>
+          <a:xfrm>
+            <a:off x="731520" y="2103120"/>
+            <a:ext cx="7680960" cy="548640"/>
           </a:xfrm>
           <a:prstGeom prst="roundRect">
             <a:avLst>
-              <a:gd name="adj" fmla="val 50000"/>
+              <a:gd name="adj" fmla="val 13333"/>
             </a:avLst>
           </a:prstGeom>
           <a:solidFill>
-            <a:srgbClr val="00BFA6"/>
+            <a:srgbClr val="0F1419"/>
+          </a:solidFill>
+          <a:ln/>
+        </p:spPr>
+      </p:sp>
+      <p:sp>
+        <p:nvSpPr>
+          <p:cNvPr id="9" name="Text 6"/>
+          <p:cNvSpPr txBox="1"/>
+          <p:nvPr/>
+        </p:nvSpPr>
+        <p:spPr>
+          <a:xfrm>
+            <a:off x="914400" y="2103120"/>
+            <a:ext cx="411480" cy="548640"/>
+          </a:xfrm>
+          <a:prstGeom prst="roundRect">
+            <a:avLst>
+              <a:gd name="adj" fmla="val 48889"/>
+            </a:avLst>
+          </a:prstGeom>
+          <a:solidFill>
+            <a:srgbClr val="3B82F6"/>
           </a:solidFill>
           <a:ln/>
         </p:spPr>
@@ -2162,7 +2318,7 @@
               <a:buNone/>
             </a:pPr>
             <a:r>
-              <a:rPr lang="en-US" sz="1600" b="1" dirty="0">
+              <a:rPr lang="en-US" sz="1500" b="1" dirty="0">
                 <a:solidFill>
                   <a:srgbClr val="0F1419"/>
                 </a:solidFill>
@@ -2172,20 +2328,20 @@
               </a:rPr>
               <a:t>2</a:t>
             </a:r>
-            <a:endParaRPr lang="en-US" sz="1600" dirty="0"/>
-          </a:p>
-        </p:txBody>
-      </p:sp>
-      <p:sp>
-        <p:nvSpPr>
-          <p:cNvPr id="7" name="Text 5"/>
+            <a:endParaRPr lang="en-US" sz="1500" dirty="0"/>
+          </a:p>
+        </p:txBody>
+      </p:sp>
+      <p:sp>
+        <p:nvSpPr>
+          <p:cNvPr id="10" name="Text 7"/>
           <p:cNvSpPr txBox="1"/>
           <p:nvPr/>
         </p:nvSpPr>
         <p:spPr>
           <a:xfrm>
-            <a:off x="1371600" y="2212848"/>
-            <a:ext cx="7040880" cy="548640"/>
+            <a:off x="1508760" y="2103120"/>
+            <a:ext cx="6766560" cy="548640"/>
           </a:xfrm>
           <a:prstGeom prst="rect">
             <a:avLst/>
@@ -2201,7 +2357,7 @@
               <a:buNone/>
             </a:pPr>
             <a:r>
-              <a:rPr lang="en-US" sz="1400" dirty="0">
+              <a:rPr lang="en-US" sz="1300" dirty="0">
                 <a:solidFill>
                   <a:srgbClr val="FFFFFF"/>
                 </a:solidFill>
@@ -2211,28 +2367,50 @@
               </a:rPr>
               <a:t>2009 — Le premier bloc Bitcoin (bloc Genesis) est miné le 3 janvier</a:t>
             </a:r>
-            <a:endParaRPr lang="en-US" sz="1400" dirty="0"/>
-          </a:p>
-        </p:txBody>
-      </p:sp>
-      <p:sp>
-        <p:nvSpPr>
-          <p:cNvPr id="8" name="Text 6"/>
-          <p:cNvSpPr txBox="1"/>
-          <p:nvPr/>
-        </p:nvSpPr>
-        <p:spPr>
-          <a:xfrm>
-            <a:off x="731520" y="2871216"/>
-            <a:ext cx="457200" cy="548640"/>
+            <a:endParaRPr lang="en-US" sz="1300" dirty="0"/>
+          </a:p>
+        </p:txBody>
+      </p:sp>
+      <p:sp>
+        <p:nvSpPr>
+          <p:cNvPr id="11" name="Shape 8"/>
+          <p:cNvSpPr/>
+          <p:nvPr/>
+        </p:nvSpPr>
+        <p:spPr>
+          <a:xfrm>
+            <a:off x="731520" y="2743200"/>
+            <a:ext cx="7680960" cy="548640"/>
           </a:xfrm>
           <a:prstGeom prst="roundRect">
             <a:avLst>
-              <a:gd name="adj" fmla="val 50000"/>
+              <a:gd name="adj" fmla="val 13333"/>
             </a:avLst>
           </a:prstGeom>
           <a:solidFill>
-            <a:srgbClr val="00BFA6"/>
+            <a:srgbClr val="0F1419"/>
+          </a:solidFill>
+          <a:ln/>
+        </p:spPr>
+      </p:sp>
+      <p:sp>
+        <p:nvSpPr>
+          <p:cNvPr id="12" name="Text 9"/>
+          <p:cNvSpPr txBox="1"/>
+          <p:nvPr/>
+        </p:nvSpPr>
+        <p:spPr>
+          <a:xfrm>
+            <a:off x="914400" y="2743200"/>
+            <a:ext cx="411480" cy="548640"/>
+          </a:xfrm>
+          <a:prstGeom prst="roundRect">
+            <a:avLst>
+              <a:gd name="adj" fmla="val 48889"/>
+            </a:avLst>
+          </a:prstGeom>
+          <a:solidFill>
+            <a:srgbClr val="3B82F6"/>
           </a:solidFill>
           <a:ln/>
         </p:spPr>
@@ -2244,7 +2422,7 @@
               <a:buNone/>
             </a:pPr>
             <a:r>
-              <a:rPr lang="en-US" sz="1600" b="1" dirty="0">
+              <a:rPr lang="en-US" sz="1500" b="1" dirty="0">
                 <a:solidFill>
                   <a:srgbClr val="0F1419"/>
                 </a:solidFill>
@@ -2254,20 +2432,20 @@
               </a:rPr>
               <a:t>3</a:t>
             </a:r>
-            <a:endParaRPr lang="en-US" sz="1600" dirty="0"/>
-          </a:p>
-        </p:txBody>
-      </p:sp>
-      <p:sp>
-        <p:nvSpPr>
-          <p:cNvPr id="9" name="Text 7"/>
+            <a:endParaRPr lang="en-US" sz="1500" dirty="0"/>
+          </a:p>
+        </p:txBody>
+      </p:sp>
+      <p:sp>
+        <p:nvSpPr>
+          <p:cNvPr id="13" name="Text 10"/>
           <p:cNvSpPr txBox="1"/>
           <p:nvPr/>
         </p:nvSpPr>
         <p:spPr>
           <a:xfrm>
-            <a:off x="1371600" y="2871216"/>
-            <a:ext cx="7040880" cy="548640"/>
+            <a:off x="1508760" y="2743200"/>
+            <a:ext cx="6766560" cy="548640"/>
           </a:xfrm>
           <a:prstGeom prst="rect">
             <a:avLst/>
@@ -2283,7 +2461,7 @@
               <a:buNone/>
             </a:pPr>
             <a:r>
-              <a:rPr lang="en-US" sz="1400" dirty="0">
+              <a:rPr lang="en-US" sz="1300" dirty="0">
                 <a:solidFill>
                   <a:srgbClr val="FFFFFF"/>
                 </a:solidFill>
@@ -2293,28 +2471,50 @@
               </a:rPr>
               <a:t>2010 — Première transaction réelle : 10 000 BTC pour 2 pizzas (aujourd'hui plusieurs centaines de millions de dollars)</a:t>
             </a:r>
-            <a:endParaRPr lang="en-US" sz="1400" dirty="0"/>
-          </a:p>
-        </p:txBody>
-      </p:sp>
-      <p:sp>
-        <p:nvSpPr>
-          <p:cNvPr id="10" name="Text 8"/>
-          <p:cNvSpPr txBox="1"/>
-          <p:nvPr/>
-        </p:nvSpPr>
-        <p:spPr>
-          <a:xfrm>
-            <a:off x="731520" y="3529584"/>
-            <a:ext cx="457200" cy="548640"/>
+            <a:endParaRPr lang="en-US" sz="1300" dirty="0"/>
+          </a:p>
+        </p:txBody>
+      </p:sp>
+      <p:sp>
+        <p:nvSpPr>
+          <p:cNvPr id="14" name="Shape 11"/>
+          <p:cNvSpPr/>
+          <p:nvPr/>
+        </p:nvSpPr>
+        <p:spPr>
+          <a:xfrm>
+            <a:off x="731520" y="3383280"/>
+            <a:ext cx="7680960" cy="548640"/>
           </a:xfrm>
           <a:prstGeom prst="roundRect">
             <a:avLst>
-              <a:gd name="adj" fmla="val 50000"/>
+              <a:gd name="adj" fmla="val 13333"/>
             </a:avLst>
           </a:prstGeom>
           <a:solidFill>
-            <a:srgbClr val="00BFA6"/>
+            <a:srgbClr val="0F1419"/>
+          </a:solidFill>
+          <a:ln/>
+        </p:spPr>
+      </p:sp>
+      <p:sp>
+        <p:nvSpPr>
+          <p:cNvPr id="15" name="Text 12"/>
+          <p:cNvSpPr txBox="1"/>
+          <p:nvPr/>
+        </p:nvSpPr>
+        <p:spPr>
+          <a:xfrm>
+            <a:off x="914400" y="3383280"/>
+            <a:ext cx="411480" cy="548640"/>
+          </a:xfrm>
+          <a:prstGeom prst="roundRect">
+            <a:avLst>
+              <a:gd name="adj" fmla="val 48889"/>
+            </a:avLst>
+          </a:prstGeom>
+          <a:solidFill>
+            <a:srgbClr val="3B82F6"/>
           </a:solidFill>
           <a:ln/>
         </p:spPr>
@@ -2326,7 +2526,7 @@
               <a:buNone/>
             </a:pPr>
             <a:r>
-              <a:rPr lang="en-US" sz="1600" b="1" dirty="0">
+              <a:rPr lang="en-US" sz="1500" b="1" dirty="0">
                 <a:solidFill>
                   <a:srgbClr val="0F1419"/>
                 </a:solidFill>
@@ -2336,20 +2536,20 @@
               </a:rPr>
               <a:t>4</a:t>
             </a:r>
-            <a:endParaRPr lang="en-US" sz="1600" dirty="0"/>
-          </a:p>
-        </p:txBody>
-      </p:sp>
-      <p:sp>
-        <p:nvSpPr>
-          <p:cNvPr id="11" name="Text 9"/>
+            <a:endParaRPr lang="en-US" sz="1500" dirty="0"/>
+          </a:p>
+        </p:txBody>
+      </p:sp>
+      <p:sp>
+        <p:nvSpPr>
+          <p:cNvPr id="16" name="Text 13"/>
           <p:cNvSpPr txBox="1"/>
           <p:nvPr/>
         </p:nvSpPr>
         <p:spPr>
           <a:xfrm>
-            <a:off x="1371600" y="3529584"/>
-            <a:ext cx="7040880" cy="548640"/>
+            <a:off x="1508760" y="3383280"/>
+            <a:ext cx="6766560" cy="548640"/>
           </a:xfrm>
           <a:prstGeom prst="rect">
             <a:avLst/>
@@ -2365,7 +2565,7 @@
               <a:buNone/>
             </a:pPr>
             <a:r>
-              <a:rPr lang="en-US" sz="1400" dirty="0">
+              <a:rPr lang="en-US" sz="1300" dirty="0">
                 <a:solidFill>
                   <a:srgbClr val="FFFFFF"/>
                 </a:solidFill>
@@ -2375,28 +2575,50 @@
               </a:rPr>
               <a:t>2013 — Le Bitcoin atteint 1 000 $ pour la première fois</a:t>
             </a:r>
-            <a:endParaRPr lang="en-US" sz="1400" dirty="0"/>
-          </a:p>
-        </p:txBody>
-      </p:sp>
-      <p:sp>
-        <p:nvSpPr>
-          <p:cNvPr id="12" name="Text 10"/>
-          <p:cNvSpPr txBox="1"/>
-          <p:nvPr/>
-        </p:nvSpPr>
-        <p:spPr>
-          <a:xfrm>
-            <a:off x="731520" y="4187952"/>
-            <a:ext cx="457200" cy="548640"/>
+            <a:endParaRPr lang="en-US" sz="1300" dirty="0"/>
+          </a:p>
+        </p:txBody>
+      </p:sp>
+      <p:sp>
+        <p:nvSpPr>
+          <p:cNvPr id="17" name="Shape 14"/>
+          <p:cNvSpPr/>
+          <p:nvPr/>
+        </p:nvSpPr>
+        <p:spPr>
+          <a:xfrm>
+            <a:off x="731520" y="4023360"/>
+            <a:ext cx="7680960" cy="548640"/>
           </a:xfrm>
           <a:prstGeom prst="roundRect">
             <a:avLst>
-              <a:gd name="adj" fmla="val 50000"/>
+              <a:gd name="adj" fmla="val 13333"/>
             </a:avLst>
           </a:prstGeom>
           <a:solidFill>
-            <a:srgbClr val="00BFA6"/>
+            <a:srgbClr val="0F1419"/>
+          </a:solidFill>
+          <a:ln/>
+        </p:spPr>
+      </p:sp>
+      <p:sp>
+        <p:nvSpPr>
+          <p:cNvPr id="18" name="Text 15"/>
+          <p:cNvSpPr txBox="1"/>
+          <p:nvPr/>
+        </p:nvSpPr>
+        <p:spPr>
+          <a:xfrm>
+            <a:off x="914400" y="4023360"/>
+            <a:ext cx="411480" cy="548640"/>
+          </a:xfrm>
+          <a:prstGeom prst="roundRect">
+            <a:avLst>
+              <a:gd name="adj" fmla="val 48889"/>
+            </a:avLst>
+          </a:prstGeom>
+          <a:solidFill>
+            <a:srgbClr val="3B82F6"/>
           </a:solidFill>
           <a:ln/>
         </p:spPr>
@@ -2408,7 +2630,7 @@
               <a:buNone/>
             </a:pPr>
             <a:r>
-              <a:rPr lang="en-US" sz="1600" b="1" dirty="0">
+              <a:rPr lang="en-US" sz="1500" b="1" dirty="0">
                 <a:solidFill>
                   <a:srgbClr val="0F1419"/>
                 </a:solidFill>
@@ -2418,20 +2640,20 @@
               </a:rPr>
               <a:t>5</a:t>
             </a:r>
-            <a:endParaRPr lang="en-US" sz="1600" dirty="0"/>
-          </a:p>
-        </p:txBody>
-      </p:sp>
-      <p:sp>
-        <p:nvSpPr>
-          <p:cNvPr id="13" name="Text 11"/>
+            <a:endParaRPr lang="en-US" sz="1500" dirty="0"/>
+          </a:p>
+        </p:txBody>
+      </p:sp>
+      <p:sp>
+        <p:nvSpPr>
+          <p:cNvPr id="19" name="Text 16"/>
           <p:cNvSpPr txBox="1"/>
           <p:nvPr/>
         </p:nvSpPr>
         <p:spPr>
           <a:xfrm>
-            <a:off x="1371600" y="4187952"/>
-            <a:ext cx="7040880" cy="548640"/>
+            <a:off x="1508760" y="4023360"/>
+            <a:ext cx="6766560" cy="548640"/>
           </a:xfrm>
           <a:prstGeom prst="rect">
             <a:avLst/>
@@ -2447,7 +2669,7 @@
               <a:buNone/>
             </a:pPr>
             <a:r>
-              <a:rPr lang="en-US" sz="1400" dirty="0">
+              <a:rPr lang="en-US" sz="1300" dirty="0">
                 <a:solidFill>
                   <a:srgbClr val="FFFFFF"/>
                 </a:solidFill>
@@ -2457,7 +2679,7 @@
               </a:rPr>
               <a:t>2017 — Bull run historique, le BTC atteint 20 000 $</a:t>
             </a:r>
-            <a:endParaRPr lang="en-US" sz="1400" dirty="0"/>
+            <a:endParaRPr lang="en-US" sz="1300" dirty="0"/>
           </a:p>
         </p:txBody>
       </p:sp>
@@ -2495,14 +2717,60 @@
       </p:grpSpPr>
       <p:sp>
         <p:nvSpPr>
-          <p:cNvPr id="2" name="Text 0"/>
+          <p:cNvPr id="2" name="Shape 0"/>
+          <p:cNvSpPr/>
+          <p:nvPr/>
+        </p:nvSpPr>
+        <p:spPr>
+          <a:xfrm>
+            <a:off x="2743200" y="457200"/>
+            <a:ext cx="3657600" cy="3657600"/>
+          </a:xfrm>
+          <a:prstGeom prst="ellipse">
+            <a:avLst/>
+          </a:prstGeom>
+          <a:solidFill>
+            <a:srgbClr val="3B82F6">
+              <a:alpha val="6000"/>
+            </a:srgbClr>
+          </a:solidFill>
+          <a:ln/>
+        </p:spPr>
+      </p:sp>
+      <p:pic>
+        <p:nvPicPr>
+          <p:cNvPr id="3" name="Image 0" descr="preencoded.png">    </p:cNvPr>
+          <p:cNvPicPr>
+            <a:picLocks noChangeAspect="1"/>
+          </p:cNvPicPr>
+          <p:nvPr/>
+        </p:nvPicPr>
+        <p:blipFill>
+          <a:blip r:embed="rId1"/>
+          <a:stretch>
+            <a:fillRect/>
+          </a:stretch>
+        </p:blipFill>
+        <p:spPr>
+          <a:xfrm>
+            <a:off x="3931920" y="914400"/>
+            <a:ext cx="1280160" cy="1280160"/>
+          </a:xfrm>
+          <a:prstGeom prst="rect">
+            <a:avLst/>
+          </a:prstGeom>
+        </p:spPr>
+      </p:pic>
+      <p:sp>
+        <p:nvSpPr>
+          <p:cNvPr id="4" name="Text 1"/>
           <p:cNvSpPr txBox="1"/>
           <p:nvPr/>
         </p:nvSpPr>
         <p:spPr>
           <a:xfrm>
-            <a:off x="731520" y="1371600"/>
-            <a:ext cx="7680960" cy="640080"/>
+            <a:off x="731520" y="2377440"/>
+            <a:ext cx="7680960" cy="548640"/>
           </a:xfrm>
           <a:prstGeom prst="rect">
             <a:avLst/>
@@ -2518,7 +2786,7 @@
               <a:buNone/>
             </a:pPr>
             <a:r>
-              <a:rPr lang="en-US" sz="3000" b="1" dirty="0">
+              <a:rPr lang="en-US" sz="2800" b="1" dirty="0">
                 <a:solidFill>
                   <a:srgbClr val="FFFFFF"/>
                 </a:solidFill>
@@ -2528,20 +2796,20 @@
               </a:rPr>
               <a:t>Module 1 termine</a:t>
             </a:r>
-            <a:endParaRPr lang="en-US" sz="3000" dirty="0"/>
-          </a:p>
-        </p:txBody>
-      </p:sp>
-      <p:sp>
-        <p:nvSpPr>
-          <p:cNvPr id="3" name="Text 1"/>
+            <a:endParaRPr lang="en-US" sz="2800" dirty="0"/>
+          </a:p>
+        </p:txBody>
+      </p:sp>
+      <p:sp>
+        <p:nvSpPr>
+          <p:cNvPr id="5" name="Text 2"/>
           <p:cNvSpPr txBox="1"/>
           <p:nvPr/>
         </p:nvSpPr>
         <p:spPr>
           <a:xfrm>
-            <a:off x="1371600" y="2194560"/>
-            <a:ext cx="6400800" cy="457200"/>
+            <a:off x="1371600" y="3017520"/>
+            <a:ext cx="6400800" cy="365760"/>
           </a:xfrm>
           <a:prstGeom prst="rect">
             <a:avLst/>
@@ -2557,7 +2825,7 @@
               <a:buNone/>
             </a:pPr>
             <a:r>
-              <a:rPr lang="en-US" sz="1400" dirty="0">
+              <a:rPr lang="en-US" sz="1300" dirty="0">
                 <a:solidFill>
                   <a:srgbClr val="94A3B8"/>
                 </a:solidFill>
@@ -2567,40 +2835,40 @@
               </a:rPr>
               <a:t>Passez au module suivant pour continuer votre apprentissage.</a:t>
             </a:r>
-            <a:endParaRPr lang="en-US" sz="1400" dirty="0"/>
-          </a:p>
-        </p:txBody>
-      </p:sp>
-      <p:sp>
-        <p:nvSpPr>
-          <p:cNvPr id="4" name="Shape 2"/>
+            <a:endParaRPr lang="en-US" sz="1300" dirty="0"/>
+          </a:p>
+        </p:txBody>
+      </p:sp>
+      <p:sp>
+        <p:nvSpPr>
+          <p:cNvPr id="6" name="Shape 3"/>
           <p:cNvSpPr/>
           <p:nvPr/>
         </p:nvSpPr>
         <p:spPr>
           <a:xfrm>
-            <a:off x="3200400" y="2926080"/>
-            <a:ext cx="2743200" cy="54864"/>
+            <a:off x="3200400" y="3657600"/>
+            <a:ext cx="2743200" cy="36576"/>
           </a:xfrm>
           <a:prstGeom prst="rect">
             <a:avLst/>
           </a:prstGeom>
           <a:solidFill>
-            <a:srgbClr val="00BFA6"/>
+            <a:srgbClr val="3B82F6"/>
           </a:solidFill>
           <a:ln/>
         </p:spPr>
       </p:sp>
       <p:sp>
         <p:nvSpPr>
-          <p:cNvPr id="5" name="Text 3"/>
+          <p:cNvPr id="7" name="Text 4"/>
           <p:cNvSpPr txBox="1"/>
           <p:nvPr/>
         </p:nvSpPr>
         <p:spPr>
           <a:xfrm>
-            <a:off x="2286000" y="3291840"/>
-            <a:ext cx="4572000" cy="365760"/>
+            <a:off x="2286000" y="3931920"/>
+            <a:ext cx="4572000" cy="320040"/>
           </a:xfrm>
           <a:prstGeom prst="rect">
             <a:avLst/>
@@ -2616,7 +2884,7 @@
               <a:buNone/>
             </a:pPr>
             <a:r>
-              <a:rPr lang="en-US" sz="1200" spc="300" kern="0" dirty="0">
+              <a:rPr lang="en-US" sz="1100" spc="300" kern="0" dirty="0">
                 <a:solidFill>
                   <a:srgbClr val="64748B"/>
                 </a:solidFill>
@@ -2626,20 +2894,20 @@
               </a:rPr>
               <a:t>TEREX ACADEMY</a:t>
             </a:r>
-            <a:endParaRPr lang="en-US" sz="1200" dirty="0"/>
-          </a:p>
-        </p:txBody>
-      </p:sp>
-      <p:sp>
-        <p:nvSpPr>
-          <p:cNvPr id="6" name="Text 4"/>
+            <a:endParaRPr lang="en-US" sz="1100" dirty="0"/>
+          </a:p>
+        </p:txBody>
+      </p:sp>
+      <p:sp>
+        <p:nvSpPr>
+          <p:cNvPr id="8" name="Text 5"/>
           <p:cNvSpPr txBox="1"/>
           <p:nvPr/>
         </p:nvSpPr>
         <p:spPr>
           <a:xfrm>
-            <a:off x="2286000" y="3657600"/>
-            <a:ext cx="4572000" cy="320040"/>
+            <a:off x="2286000" y="4251960"/>
+            <a:ext cx="4572000" cy="274320"/>
           </a:xfrm>
           <a:prstGeom prst="rect">
             <a:avLst/>
@@ -2709,8 +2977,8 @@
         </p:nvSpPr>
         <p:spPr>
           <a:xfrm>
-            <a:off x="731520" y="457200"/>
-            <a:ext cx="2743200" cy="365760"/>
+            <a:off x="731520" y="365760"/>
+            <a:ext cx="2743200" cy="320040"/>
           </a:xfrm>
           <a:prstGeom prst="rect">
             <a:avLst/>
@@ -2728,7 +2996,7 @@
             <a:r>
               <a:rPr lang="en-US" sz="1200" b="1" spc="300" kern="0" dirty="0">
                 <a:solidFill>
-                  <a:srgbClr val="00BFA6"/>
+                  <a:srgbClr val="3B82F6"/>
                 </a:solidFill>
                 <a:latin typeface="Calibri" pitchFamily="34" charset="0"/>
                 <a:ea typeface="Calibri" pitchFamily="34" charset="-122"/>
@@ -2748,7 +3016,7 @@
         </p:nvSpPr>
         <p:spPr>
           <a:xfrm>
-            <a:off x="731520" y="868680"/>
+            <a:off x="731520" y="731520"/>
             <a:ext cx="4572000" cy="457200"/>
           </a:xfrm>
           <a:prstGeom prst="rect">
@@ -2781,14 +3049,36 @@
       </p:sp>
       <p:sp>
         <p:nvSpPr>
-          <p:cNvPr id="4" name="Text 2"/>
+          <p:cNvPr id="4" name="Shape 2"/>
+          <p:cNvSpPr/>
+          <p:nvPr/>
+        </p:nvSpPr>
+        <p:spPr>
+          <a:xfrm>
+            <a:off x="731520" y="1371600"/>
+            <a:ext cx="7680960" cy="475488"/>
+          </a:xfrm>
+          <a:prstGeom prst="roundRect">
+            <a:avLst>
+              <a:gd name="adj" fmla="val 15385"/>
+            </a:avLst>
+          </a:prstGeom>
+          <a:solidFill>
+            <a:srgbClr val="1A2332"/>
+          </a:solidFill>
+          <a:ln/>
+        </p:spPr>
+      </p:sp>
+      <p:sp>
+        <p:nvSpPr>
+          <p:cNvPr id="5" name="Text 3"/>
           <p:cNvSpPr txBox="1"/>
           <p:nvPr/>
         </p:nvSpPr>
         <p:spPr>
           <a:xfrm>
-            <a:off x="731520" y="1554480"/>
-            <a:ext cx="7680960" cy="3200400"/>
+            <a:off x="868680" y="1371600"/>
+            <a:ext cx="320040" cy="475488"/>
           </a:xfrm>
           <a:prstGeom prst="rect">
             <a:avLst/>
@@ -2797,17 +3087,77 @@
           <a:ln/>
         </p:spPr>
         <p:txBody>
-          <a:bodyPr wrap="square" lIns="0" tIns="0" rIns="0" bIns="0" rtlCol="0" anchor="t"/>
+          <a:bodyPr wrap="square" lIns="0" tIns="0" rIns="0" bIns="0" rtlCol="0" anchor="ctr"/>
+          <a:lstStyle/>
+          <a:p>
+            <a:pPr algn="ctr" indent="0" marL="0">
+              <a:buNone/>
+            </a:pPr>
+            <a:r>
+              <a:rPr lang="en-US" sz="1300" b="1" dirty="0">
+                <a:solidFill>
+                  <a:srgbClr val="3B82F6"/>
+                </a:solidFill>
+                <a:latin typeface="Calibri" pitchFamily="34" charset="0"/>
+                <a:ea typeface="Calibri" pitchFamily="34" charset="-122"/>
+                <a:cs typeface="Calibri" pitchFamily="34" charset="-120"/>
+              </a:rPr>
+              <a:t>1</a:t>
+            </a:r>
+            <a:endParaRPr lang="en-US" sz="1300" dirty="0"/>
+          </a:p>
+        </p:txBody>
+      </p:sp>
+      <p:pic>
+        <p:nvPicPr>
+          <p:cNvPr id="6" name="Image 0" descr="preencoded.png">    </p:cNvPr>
+          <p:cNvPicPr>
+            <a:picLocks noChangeAspect="1"/>
+          </p:cNvPicPr>
+          <p:nvPr/>
+        </p:nvPicPr>
+        <p:blipFill>
+          <a:blip r:embed="rId1"/>
+          <a:stretch>
+            <a:fillRect/>
+          </a:stretch>
+        </p:blipFill>
+        <p:spPr>
+          <a:xfrm>
+            <a:off x="1280160" y="1444752"/>
+            <a:ext cx="329184" cy="329184"/>
+          </a:xfrm>
+          <a:prstGeom prst="rect">
+            <a:avLst/>
+          </a:prstGeom>
+        </p:spPr>
+      </p:pic>
+      <p:sp>
+        <p:nvSpPr>
+          <p:cNvPr id="7" name="Text 4"/>
+          <p:cNvSpPr txBox="1"/>
+          <p:nvPr/>
+        </p:nvSpPr>
+        <p:spPr>
+          <a:xfrm>
+            <a:off x="1737360" y="1371600"/>
+            <a:ext cx="6492240" cy="475488"/>
+          </a:xfrm>
+          <a:prstGeom prst="rect">
+            <a:avLst/>
+          </a:prstGeom>
+          <a:noFill/>
+          <a:ln/>
+        </p:spPr>
+        <p:txBody>
+          <a:bodyPr wrap="square" lIns="0" tIns="0" rIns="0" bIns="0" rtlCol="0" anchor="ctr"/>
           <a:lstStyle/>
           <a:p>
             <a:pPr indent="0" marL="0">
-              <a:spcAft>
-                <a:spcPts val="1000"/>
-              </a:spcAft>
               <a:buNone/>
             </a:pPr>
             <a:r>
-              <a:rPr lang="en-US" sz="1500" dirty="0">
+              <a:rPr lang="en-US" sz="1300" dirty="0">
                 <a:solidFill>
                   <a:srgbClr val="FFFFFF"/>
                 </a:solidFill>
@@ -2815,19 +3165,123 @@
                 <a:ea typeface="Calibri" pitchFamily="34" charset="-122"/>
                 <a:cs typeface="Calibri" pitchFamily="34" charset="-120"/>
               </a:rPr>
-              <a:t>1.  Qu'est-ce que la blockchain ?</a:t>
-            </a:r>
-            <a:endParaRPr lang="en-US" sz="1500" dirty="0"/>
-          </a:p>
+              <a:t>Qu'est-ce que la blockchain ?</a:t>
+            </a:r>
+            <a:endParaRPr lang="en-US" sz="1300" dirty="0"/>
+          </a:p>
+        </p:txBody>
+      </p:sp>
+      <p:sp>
+        <p:nvSpPr>
+          <p:cNvPr id="8" name="Shape 5"/>
+          <p:cNvSpPr/>
+          <p:nvPr/>
+        </p:nvSpPr>
+        <p:spPr>
+          <a:xfrm>
+            <a:off x="731520" y="1920240"/>
+            <a:ext cx="7680960" cy="475488"/>
+          </a:xfrm>
+          <a:prstGeom prst="roundRect">
+            <a:avLst>
+              <a:gd name="adj" fmla="val 15385"/>
+            </a:avLst>
+          </a:prstGeom>
+          <a:solidFill>
+            <a:srgbClr val="1A2332"/>
+          </a:solidFill>
+          <a:ln/>
+        </p:spPr>
+      </p:sp>
+      <p:sp>
+        <p:nvSpPr>
+          <p:cNvPr id="9" name="Text 6"/>
+          <p:cNvSpPr txBox="1"/>
+          <p:nvPr/>
+        </p:nvSpPr>
+        <p:spPr>
+          <a:xfrm>
+            <a:off x="868680" y="1920240"/>
+            <a:ext cx="320040" cy="475488"/>
+          </a:xfrm>
+          <a:prstGeom prst="rect">
+            <a:avLst/>
+          </a:prstGeom>
+          <a:noFill/>
+          <a:ln/>
+        </p:spPr>
+        <p:txBody>
+          <a:bodyPr wrap="square" lIns="0" tIns="0" rIns="0" bIns="0" rtlCol="0" anchor="ctr"/>
+          <a:lstStyle/>
+          <a:p>
+            <a:pPr algn="ctr" indent="0" marL="0">
+              <a:buNone/>
+            </a:pPr>
+            <a:r>
+              <a:rPr lang="en-US" sz="1300" b="1" dirty="0">
+                <a:solidFill>
+                  <a:srgbClr val="3B82F6"/>
+                </a:solidFill>
+                <a:latin typeface="Calibri" pitchFamily="34" charset="0"/>
+                <a:ea typeface="Calibri" pitchFamily="34" charset="-122"/>
+                <a:cs typeface="Calibri" pitchFamily="34" charset="-120"/>
+              </a:rPr>
+              <a:t>2</a:t>
+            </a:r>
+            <a:endParaRPr lang="en-US" sz="1300" dirty="0"/>
+          </a:p>
+        </p:txBody>
+      </p:sp>
+      <p:pic>
+        <p:nvPicPr>
+          <p:cNvPr id="10" name="Image 1" descr="preencoded.png">    </p:cNvPr>
+          <p:cNvPicPr>
+            <a:picLocks noChangeAspect="1"/>
+          </p:cNvPicPr>
+          <p:nvPr/>
+        </p:nvPicPr>
+        <p:blipFill>
+          <a:blip r:embed="rId2"/>
+          <a:stretch>
+            <a:fillRect/>
+          </a:stretch>
+        </p:blipFill>
+        <p:spPr>
+          <a:xfrm>
+            <a:off x="1280160" y="1993392"/>
+            <a:ext cx="329184" cy="329184"/>
+          </a:xfrm>
+          <a:prstGeom prst="rect">
+            <a:avLst/>
+          </a:prstGeom>
+        </p:spPr>
+      </p:pic>
+      <p:sp>
+        <p:nvSpPr>
+          <p:cNvPr id="11" name="Text 7"/>
+          <p:cNvSpPr txBox="1"/>
+          <p:nvPr/>
+        </p:nvSpPr>
+        <p:spPr>
+          <a:xfrm>
+            <a:off x="1737360" y="1920240"/>
+            <a:ext cx="6492240" cy="475488"/>
+          </a:xfrm>
+          <a:prstGeom prst="rect">
+            <a:avLst/>
+          </a:prstGeom>
+          <a:noFill/>
+          <a:ln/>
+        </p:spPr>
+        <p:txBody>
+          <a:bodyPr wrap="square" lIns="0" tIns="0" rIns="0" bIns="0" rtlCol="0" anchor="ctr"/>
+          <a:lstStyle/>
           <a:p>
             <a:pPr indent="0" marL="0">
-              <a:spcAft>
-                <a:spcPts val="1000"/>
-              </a:spcAft>
               <a:buNone/>
             </a:pPr>
             <a:r>
-              <a:rPr lang="en-US" sz="1500" dirty="0">
+              <a:rPr lang="en-US" sz="1300" dirty="0">
                 <a:solidFill>
                   <a:srgbClr val="FFFFFF"/>
                 </a:solidFill>
@@ -2835,9 +3289,9 @@
                 <a:ea typeface="Calibri" pitchFamily="34" charset="-122"/>
                 <a:cs typeface="Calibri" pitchFamily="34" charset="-120"/>
               </a:rPr>
-              <a:t>2.  L'histoire du Bitcoin</a:t>
-            </a:r>
-            <a:endParaRPr lang="en-US" sz="1500" dirty="0"/>
+              <a:t>L'histoire du Bitcoin</a:t>
+            </a:r>
+            <a:endParaRPr lang="en-US" sz="1300" dirty="0"/>
           </a:p>
         </p:txBody>
       </p:sp>
@@ -2873,35 +3327,105 @@
           <a:chExt cx="0" cy="0"/>
         </a:xfrm>
       </p:grpSpPr>
-      <p:sp>
-        <p:nvSpPr>
-          <p:cNvPr id="2" name="Shape 0"/>
+      <p:pic>
+        <p:nvPicPr>
+          <p:cNvPr id="2" name="Image 0" descr="preencoded.png">    </p:cNvPr>
+          <p:cNvPicPr>
+            <a:picLocks noChangeAspect="1"/>
+          </p:cNvPicPr>
+          <p:nvPr/>
+        </p:nvPicPr>
+        <p:blipFill>
+          <a:blip r:embed="rId1"/>
+          <a:stretch>
+            <a:fillRect/>
+          </a:stretch>
+        </p:blipFill>
+        <p:spPr>
+          <a:xfrm>
+            <a:off x="7315200" y="548640"/>
+            <a:ext cx="1280160" cy="1280160"/>
+          </a:xfrm>
+          <a:prstGeom prst="rect">
+            <a:avLst/>
+          </a:prstGeom>
+        </p:spPr>
+      </p:pic>
+      <p:pic>
+        <p:nvPicPr>
+          <p:cNvPr id="3" name="Image 1" descr="preencoded.png">    </p:cNvPr>
+          <p:cNvPicPr>
+            <a:picLocks noChangeAspect="1"/>
+          </p:cNvPicPr>
+          <p:nvPr/>
+        </p:nvPicPr>
+        <p:blipFill>
+          <a:blip r:embed="rId2"/>
+          <a:stretch>
+            <a:fillRect/>
+          </a:stretch>
+        </p:blipFill>
+        <p:spPr>
+          <a:xfrm>
+            <a:off x="7772400" y="2011680"/>
+            <a:ext cx="822960" cy="822960"/>
+          </a:xfrm>
+          <a:prstGeom prst="rect">
+            <a:avLst/>
+          </a:prstGeom>
+        </p:spPr>
+      </p:pic>
+      <p:sp>
+        <p:nvSpPr>
+          <p:cNvPr id="4" name="Shape 0"/>
           <p:cNvSpPr/>
           <p:nvPr/>
         </p:nvSpPr>
         <p:spPr>
           <a:xfrm>
-            <a:off x="548640" y="914400"/>
-            <a:ext cx="45720" cy="2560320"/>
-          </a:xfrm>
-          <a:prstGeom prst="rect">
+            <a:off x="6583680" y="-274320"/>
+            <a:ext cx="3200400" cy="3200400"/>
+          </a:xfrm>
+          <a:prstGeom prst="ellipse">
             <a:avLst/>
           </a:prstGeom>
           <a:solidFill>
-            <a:srgbClr val="00BFA6"/>
+            <a:srgbClr val="3B82F6">
+              <a:alpha val="6000"/>
+            </a:srgbClr>
           </a:solidFill>
           <a:ln/>
         </p:spPr>
       </p:sp>
       <p:sp>
         <p:nvSpPr>
-          <p:cNvPr id="3" name="Text 1"/>
+          <p:cNvPr id="5" name="Shape 1"/>
+          <p:cNvSpPr/>
+          <p:nvPr/>
+        </p:nvSpPr>
+        <p:spPr>
+          <a:xfrm>
+            <a:off x="731520" y="914400"/>
+            <a:ext cx="45720" cy="2194560"/>
+          </a:xfrm>
+          <a:prstGeom prst="rect">
+            <a:avLst/>
+          </a:prstGeom>
+          <a:solidFill>
+            <a:srgbClr val="3B82F6"/>
+          </a:solidFill>
+          <a:ln/>
+        </p:spPr>
+      </p:sp>
+      <p:sp>
+        <p:nvSpPr>
+          <p:cNvPr id="6" name="Text 2"/>
           <p:cNvSpPr txBox="1"/>
           <p:nvPr/>
         </p:nvSpPr>
         <p:spPr>
           <a:xfrm>
-            <a:off x="822960" y="1097280"/>
+            <a:off x="960120" y="914400"/>
             <a:ext cx="2743200" cy="365760"/>
           </a:xfrm>
           <a:prstGeom prst="rect">
@@ -2920,13 +3444,13 @@
             <a:r>
               <a:rPr lang="en-US" sz="1200" b="1" spc="200" kern="0" dirty="0">
                 <a:solidFill>
-                  <a:srgbClr val="00BFA6"/>
-                </a:solidFill>
-                <a:latin typeface="Calibri" pitchFamily="34" charset="0"/>
-                <a:ea typeface="Calibri" pitchFamily="34" charset="-122"/>
-                <a:cs typeface="Calibri" pitchFamily="34" charset="-120"/>
-              </a:rPr>
-              <a:t>Lecon 1 / 2</a:t>
+                  <a:srgbClr val="3B82F6"/>
+                </a:solidFill>
+                <a:latin typeface="Calibri" pitchFamily="34" charset="0"/>
+                <a:ea typeface="Calibri" pitchFamily="34" charset="-122"/>
+                <a:cs typeface="Calibri" pitchFamily="34" charset="-120"/>
+              </a:rPr>
+              <a:t>Leçon 1 / 2</a:t>
             </a:r>
             <a:endParaRPr lang="en-US" sz="1200" dirty="0"/>
           </a:p>
@@ -2934,14 +3458,14 @@
       </p:sp>
       <p:sp>
         <p:nvSpPr>
-          <p:cNvPr id="4" name="Text 2"/>
+          <p:cNvPr id="7" name="Text 3"/>
           <p:cNvSpPr txBox="1"/>
           <p:nvPr/>
         </p:nvSpPr>
         <p:spPr>
           <a:xfrm>
-            <a:off x="822960" y="1645920"/>
-            <a:ext cx="7498080" cy="1280160"/>
+            <a:off x="960120" y="1371600"/>
+            <a:ext cx="6217920" cy="1463040"/>
           </a:xfrm>
           <a:prstGeom prst="rect">
             <a:avLst/>
@@ -2957,7 +3481,7 @@
               <a:buNone/>
             </a:pPr>
             <a:r>
-              <a:rPr lang="en-US" sz="3000" b="1" dirty="0">
+              <a:rPr lang="en-US" sz="2800" b="1" dirty="0">
                 <a:solidFill>
                   <a:srgbClr val="FFFFFF"/>
                 </a:solidFill>
@@ -2967,19 +3491,19 @@
               </a:rPr>
               <a:t>Qu'est-ce que la blockchain ?</a:t>
             </a:r>
-            <a:endParaRPr lang="en-US" sz="3000" dirty="0"/>
-          </a:p>
-        </p:txBody>
-      </p:sp>
-      <p:sp>
-        <p:nvSpPr>
-          <p:cNvPr id="5" name="Text 3"/>
+            <a:endParaRPr lang="en-US" sz="2800" dirty="0"/>
+          </a:p>
+        </p:txBody>
+      </p:sp>
+      <p:sp>
+        <p:nvSpPr>
+          <p:cNvPr id="8" name="Text 4"/>
           <p:cNvSpPr txBox="1"/>
           <p:nvPr/>
         </p:nvSpPr>
         <p:spPr>
           <a:xfrm>
-            <a:off x="822960" y="4206240"/>
+            <a:off x="960120" y="4114800"/>
             <a:ext cx="5486400" cy="320040"/>
           </a:xfrm>
           <a:prstGeom prst="rect">
@@ -3044,7 +3568,53 @@
       </p:grpSpPr>
       <p:sp>
         <p:nvSpPr>
-          <p:cNvPr id="2" name="Text 0"/>
+          <p:cNvPr id="2" name="Shape 0"/>
+          <p:cNvSpPr/>
+          <p:nvPr/>
+        </p:nvSpPr>
+        <p:spPr>
+          <a:xfrm>
+            <a:off x="7955280" y="182880"/>
+            <a:ext cx="640080" cy="640080"/>
+          </a:xfrm>
+          <a:prstGeom prst="ellipse">
+            <a:avLst/>
+          </a:prstGeom>
+          <a:solidFill>
+            <a:srgbClr val="3B82F6">
+              <a:alpha val="12000"/>
+            </a:srgbClr>
+          </a:solidFill>
+          <a:ln/>
+        </p:spPr>
+      </p:sp>
+      <p:pic>
+        <p:nvPicPr>
+          <p:cNvPr id="3" name="Image 0" descr="preencoded.png">    </p:cNvPr>
+          <p:cNvPicPr>
+            <a:picLocks noChangeAspect="1"/>
+          </p:cNvPicPr>
+          <p:nvPr/>
+        </p:nvPicPr>
+        <p:blipFill>
+          <a:blip r:embed="rId1"/>
+          <a:stretch>
+            <a:fillRect/>
+          </a:stretch>
+        </p:blipFill>
+        <p:spPr>
+          <a:xfrm>
+            <a:off x="8028432" y="256032"/>
+            <a:ext cx="493776" cy="493776"/>
+          </a:xfrm>
+          <a:prstGeom prst="rect">
+            <a:avLst/>
+          </a:prstGeom>
+        </p:spPr>
+      </p:pic>
+      <p:sp>
+        <p:nvSpPr>
+          <p:cNvPr id="4" name="Text 1"/>
           <p:cNvSpPr txBox="1"/>
           <p:nvPr/>
         </p:nvSpPr>
@@ -3213,7 +3783,7 @@
       </p:sp>
       <p:sp>
         <p:nvSpPr>
-          <p:cNvPr id="3" name="Text 1"/>
+          <p:cNvPr id="5" name="Text 2"/>
           <p:cNvSpPr txBox="1"/>
           <p:nvPr/>
         </p:nvSpPr>
@@ -3244,7 +3814,7 @@
                 <a:ea typeface="Calibri" pitchFamily="34" charset="-122"/>
                 <a:cs typeface="Calibri" pitchFamily="34" charset="-120"/>
               </a:rPr>
-              <a:t>Module 1 — Lecon 1</a:t>
+              <a:t>Module 1 — Leçon 1</a:t>
             </a:r>
             <a:endParaRPr lang="en-US" sz="900" dirty="0"/>
           </a:p>
@@ -3284,7 +3854,53 @@
       </p:grpSpPr>
       <p:sp>
         <p:nvSpPr>
-          <p:cNvPr id="2" name="Text 0"/>
+          <p:cNvPr id="2" name="Shape 0"/>
+          <p:cNvSpPr/>
+          <p:nvPr/>
+        </p:nvSpPr>
+        <p:spPr>
+          <a:xfrm>
+            <a:off x="7955280" y="182880"/>
+            <a:ext cx="640080" cy="640080"/>
+          </a:xfrm>
+          <a:prstGeom prst="ellipse">
+            <a:avLst/>
+          </a:prstGeom>
+          <a:solidFill>
+            <a:srgbClr val="3B82F6">
+              <a:alpha val="12000"/>
+            </a:srgbClr>
+          </a:solidFill>
+          <a:ln/>
+        </p:spPr>
+      </p:sp>
+      <p:pic>
+        <p:nvPicPr>
+          <p:cNvPr id="3" name="Image 0" descr="preencoded.png">    </p:cNvPr>
+          <p:cNvPicPr>
+            <a:picLocks noChangeAspect="1"/>
+          </p:cNvPicPr>
+          <p:nvPr/>
+        </p:nvPicPr>
+        <p:blipFill>
+          <a:blip r:embed="rId1"/>
+          <a:stretch>
+            <a:fillRect/>
+          </a:stretch>
+        </p:blipFill>
+        <p:spPr>
+          <a:xfrm>
+            <a:off x="8028432" y="256032"/>
+            <a:ext cx="493776" cy="493776"/>
+          </a:xfrm>
+          <a:prstGeom prst="rect">
+            <a:avLst/>
+          </a:prstGeom>
+        </p:spPr>
+      </p:pic>
+      <p:sp>
+        <p:nvSpPr>
+          <p:cNvPr id="4" name="Text 1"/>
           <p:cNvSpPr txBox="1"/>
           <p:nvPr/>
         </p:nvSpPr>
@@ -3327,7 +3943,7 @@
       </p:sp>
       <p:sp>
         <p:nvSpPr>
-          <p:cNvPr id="3" name="Text 1"/>
+          <p:cNvPr id="5" name="Text 2"/>
           <p:cNvSpPr txBox="1"/>
           <p:nvPr/>
         </p:nvSpPr>
@@ -3358,7 +3974,7 @@
                 <a:ea typeface="Calibri" pitchFamily="34" charset="-122"/>
                 <a:cs typeface="Calibri" pitchFamily="34" charset="-120"/>
               </a:rPr>
-              <a:t>Module 1 — Lecon 1</a:t>
+              <a:t>Module 1 — Leçon 1</a:t>
             </a:r>
             <a:endParaRPr lang="en-US" sz="900" dirty="0"/>
           </a:p>
@@ -3396,16 +4012,40 @@
           <a:chExt cx="0" cy="0"/>
         </a:xfrm>
       </p:grpSpPr>
-      <p:sp>
-        <p:nvSpPr>
-          <p:cNvPr id="2" name="Text 0"/>
+      <p:pic>
+        <p:nvPicPr>
+          <p:cNvPr id="2" name="Image 0" descr="preencoded.png">    </p:cNvPr>
+          <p:cNvPicPr>
+            <a:picLocks noChangeAspect="1"/>
+          </p:cNvPicPr>
+          <p:nvPr/>
+        </p:nvPicPr>
+        <p:blipFill>
+          <a:blip r:embed="rId1"/>
+          <a:stretch>
+            <a:fillRect/>
+          </a:stretch>
+        </p:blipFill>
+        <p:spPr>
+          <a:xfrm>
+            <a:off x="731520" y="320040"/>
+            <a:ext cx="457200" cy="457200"/>
+          </a:xfrm>
+          <a:prstGeom prst="rect">
+            <a:avLst/>
+          </a:prstGeom>
+        </p:spPr>
+      </p:pic>
+      <p:sp>
+        <p:nvSpPr>
+          <p:cNvPr id="3" name="Text 0"/>
           <p:cNvSpPr txBox="1"/>
           <p:nvPr/>
         </p:nvSpPr>
         <p:spPr>
           <a:xfrm>
-            <a:off x="731520" y="457200"/>
-            <a:ext cx="2743200" cy="365760"/>
+            <a:off x="1280160" y="365760"/>
+            <a:ext cx="2743200" cy="320040"/>
           </a:xfrm>
           <a:prstGeom prst="rect">
             <a:avLst/>
@@ -3437,14 +4077,14 @@
       </p:sp>
       <p:sp>
         <p:nvSpPr>
-          <p:cNvPr id="3" name="Text 1"/>
+          <p:cNvPr id="4" name="Text 1"/>
           <p:cNvSpPr txBox="1"/>
           <p:nvPr/>
         </p:nvSpPr>
         <p:spPr>
           <a:xfrm>
-            <a:off x="731520" y="868680"/>
-            <a:ext cx="7680960" cy="502920"/>
+            <a:off x="731520" y="822960"/>
+            <a:ext cx="7680960" cy="457200"/>
           </a:xfrm>
           <a:prstGeom prst="rect">
             <a:avLst/>
@@ -3460,7 +4100,7 @@
               <a:buNone/>
             </a:pPr>
             <a:r>
-              <a:rPr lang="en-US" sz="2200" b="1" dirty="0">
+              <a:rPr lang="en-US" sz="2000" b="1" dirty="0">
                 <a:solidFill>
                   <a:srgbClr val="FFFFFF"/>
                 </a:solidFill>
@@ -3470,28 +4110,50 @@
               </a:rPr>
               <a:t>Qu'est-ce que la blockchain ?</a:t>
             </a:r>
-            <a:endParaRPr lang="en-US" sz="2200" dirty="0"/>
-          </a:p>
-        </p:txBody>
-      </p:sp>
-      <p:sp>
-        <p:nvSpPr>
-          <p:cNvPr id="4" name="Text 2"/>
-          <p:cNvSpPr txBox="1"/>
-          <p:nvPr/>
-        </p:nvSpPr>
-        <p:spPr>
-          <a:xfrm>
-            <a:off x="731520" y="1554480"/>
-            <a:ext cx="457200" cy="548640"/>
+            <a:endParaRPr lang="en-US" sz="2000" dirty="0"/>
+          </a:p>
+        </p:txBody>
+      </p:sp>
+      <p:sp>
+        <p:nvSpPr>
+          <p:cNvPr id="5" name="Shape 2"/>
+          <p:cNvSpPr/>
+          <p:nvPr/>
+        </p:nvSpPr>
+        <p:spPr>
+          <a:xfrm>
+            <a:off x="731520" y="1463040"/>
+            <a:ext cx="7680960" cy="548640"/>
           </a:xfrm>
           <a:prstGeom prst="roundRect">
             <a:avLst>
-              <a:gd name="adj" fmla="val 50000"/>
+              <a:gd name="adj" fmla="val 13333"/>
             </a:avLst>
           </a:prstGeom>
           <a:solidFill>
-            <a:srgbClr val="00BFA6"/>
+            <a:srgbClr val="0F1419"/>
+          </a:solidFill>
+          <a:ln/>
+        </p:spPr>
+      </p:sp>
+      <p:sp>
+        <p:nvSpPr>
+          <p:cNvPr id="6" name="Text 3"/>
+          <p:cNvSpPr txBox="1"/>
+          <p:nvPr/>
+        </p:nvSpPr>
+        <p:spPr>
+          <a:xfrm>
+            <a:off x="914400" y="1463040"/>
+            <a:ext cx="411480" cy="548640"/>
+          </a:xfrm>
+          <a:prstGeom prst="roundRect">
+            <a:avLst>
+              <a:gd name="adj" fmla="val 48889"/>
+            </a:avLst>
+          </a:prstGeom>
+          <a:solidFill>
+            <a:srgbClr val="3B82F6"/>
           </a:solidFill>
           <a:ln/>
         </p:spPr>
@@ -3503,7 +4165,7 @@
               <a:buNone/>
             </a:pPr>
             <a:r>
-              <a:rPr lang="en-US" sz="1600" b="1" dirty="0">
+              <a:rPr lang="en-US" sz="1500" b="1" dirty="0">
                 <a:solidFill>
                   <a:srgbClr val="0F1419"/>
                 </a:solidFill>
@@ -3513,20 +4175,20 @@
               </a:rPr>
               <a:t>1</a:t>
             </a:r>
-            <a:endParaRPr lang="en-US" sz="1600" dirty="0"/>
-          </a:p>
-        </p:txBody>
-      </p:sp>
-      <p:sp>
-        <p:nvSpPr>
-          <p:cNvPr id="5" name="Text 3"/>
+            <a:endParaRPr lang="en-US" sz="1500" dirty="0"/>
+          </a:p>
+        </p:txBody>
+      </p:sp>
+      <p:sp>
+        <p:nvSpPr>
+          <p:cNvPr id="7" name="Text 4"/>
           <p:cNvSpPr txBox="1"/>
           <p:nvPr/>
         </p:nvSpPr>
         <p:spPr>
           <a:xfrm>
-            <a:off x="1371600" y="1554480"/>
-            <a:ext cx="7040880" cy="548640"/>
+            <a:off x="1508760" y="1463040"/>
+            <a:ext cx="6766560" cy="548640"/>
           </a:xfrm>
           <a:prstGeom prst="rect">
             <a:avLst/>
@@ -3542,7 +4204,7 @@
               <a:buNone/>
             </a:pPr>
             <a:r>
-              <a:rPr lang="en-US" sz="1400" dirty="0">
+              <a:rPr lang="en-US" sz="1300" dirty="0">
                 <a:solidFill>
                   <a:srgbClr val="FFFFFF"/>
                 </a:solidFill>
@@ -3552,28 +4214,50 @@
               </a:rPr>
               <a:t>DÉCENTRALISATION — Aucune banque, aucun gouvernement ne contrôle la blockchain. Le réseau est maintenu par des milliers d'ordinateurs (nœuds) répar...</a:t>
             </a:r>
-            <a:endParaRPr lang="en-US" sz="1400" dirty="0"/>
-          </a:p>
-        </p:txBody>
-      </p:sp>
-      <p:sp>
-        <p:nvSpPr>
-          <p:cNvPr id="6" name="Text 4"/>
-          <p:cNvSpPr txBox="1"/>
-          <p:nvPr/>
-        </p:nvSpPr>
-        <p:spPr>
-          <a:xfrm>
-            <a:off x="731520" y="2212848"/>
-            <a:ext cx="457200" cy="548640"/>
+            <a:endParaRPr lang="en-US" sz="1300" dirty="0"/>
+          </a:p>
+        </p:txBody>
+      </p:sp>
+      <p:sp>
+        <p:nvSpPr>
+          <p:cNvPr id="8" name="Shape 5"/>
+          <p:cNvSpPr/>
+          <p:nvPr/>
+        </p:nvSpPr>
+        <p:spPr>
+          <a:xfrm>
+            <a:off x="731520" y="2103120"/>
+            <a:ext cx="7680960" cy="548640"/>
           </a:xfrm>
           <a:prstGeom prst="roundRect">
             <a:avLst>
-              <a:gd name="adj" fmla="val 50000"/>
+              <a:gd name="adj" fmla="val 13333"/>
             </a:avLst>
           </a:prstGeom>
           <a:solidFill>
-            <a:srgbClr val="00BFA6"/>
+            <a:srgbClr val="0F1419"/>
+          </a:solidFill>
+          <a:ln/>
+        </p:spPr>
+      </p:sp>
+      <p:sp>
+        <p:nvSpPr>
+          <p:cNvPr id="9" name="Text 6"/>
+          <p:cNvSpPr txBox="1"/>
+          <p:nvPr/>
+        </p:nvSpPr>
+        <p:spPr>
+          <a:xfrm>
+            <a:off x="914400" y="2103120"/>
+            <a:ext cx="411480" cy="548640"/>
+          </a:xfrm>
+          <a:prstGeom prst="roundRect">
+            <a:avLst>
+              <a:gd name="adj" fmla="val 48889"/>
+            </a:avLst>
+          </a:prstGeom>
+          <a:solidFill>
+            <a:srgbClr val="3B82F6"/>
           </a:solidFill>
           <a:ln/>
         </p:spPr>
@@ -3585,7 +4269,7 @@
               <a:buNone/>
             </a:pPr>
             <a:r>
-              <a:rPr lang="en-US" sz="1600" b="1" dirty="0">
+              <a:rPr lang="en-US" sz="1500" b="1" dirty="0">
                 <a:solidFill>
                   <a:srgbClr val="0F1419"/>
                 </a:solidFill>
@@ -3595,20 +4279,20 @@
               </a:rPr>
               <a:t>2</a:t>
             </a:r>
-            <a:endParaRPr lang="en-US" sz="1600" dirty="0"/>
-          </a:p>
-        </p:txBody>
-      </p:sp>
-      <p:sp>
-        <p:nvSpPr>
-          <p:cNvPr id="7" name="Text 5"/>
+            <a:endParaRPr lang="en-US" sz="1500" dirty="0"/>
+          </a:p>
+        </p:txBody>
+      </p:sp>
+      <p:sp>
+        <p:nvSpPr>
+          <p:cNvPr id="10" name="Text 7"/>
           <p:cNvSpPr txBox="1"/>
           <p:nvPr/>
         </p:nvSpPr>
         <p:spPr>
           <a:xfrm>
-            <a:off x="1371600" y="2212848"/>
-            <a:ext cx="7040880" cy="548640"/>
+            <a:off x="1508760" y="2103120"/>
+            <a:ext cx="6766560" cy="548640"/>
           </a:xfrm>
           <a:prstGeom prst="rect">
             <a:avLst/>
@@ -3624,7 +4308,7 @@
               <a:buNone/>
             </a:pPr>
             <a:r>
-              <a:rPr lang="en-US" sz="1400" dirty="0">
+              <a:rPr lang="en-US" sz="1300" dirty="0">
                 <a:solidFill>
                   <a:srgbClr val="FFFFFF"/>
                 </a:solidFill>
@@ -3634,28 +4318,50 @@
               </a:rPr>
               <a:t>TRANSPARENCE — Toutes les transactions sont visibles par tous les participants. Chaque personne peut vérifier l'historique complet.</a:t>
             </a:r>
-            <a:endParaRPr lang="en-US" sz="1400" dirty="0"/>
-          </a:p>
-        </p:txBody>
-      </p:sp>
-      <p:sp>
-        <p:nvSpPr>
-          <p:cNvPr id="8" name="Text 6"/>
-          <p:cNvSpPr txBox="1"/>
-          <p:nvPr/>
-        </p:nvSpPr>
-        <p:spPr>
-          <a:xfrm>
-            <a:off x="731520" y="2871216"/>
-            <a:ext cx="457200" cy="548640"/>
+            <a:endParaRPr lang="en-US" sz="1300" dirty="0"/>
+          </a:p>
+        </p:txBody>
+      </p:sp>
+      <p:sp>
+        <p:nvSpPr>
+          <p:cNvPr id="11" name="Shape 8"/>
+          <p:cNvSpPr/>
+          <p:nvPr/>
+        </p:nvSpPr>
+        <p:spPr>
+          <a:xfrm>
+            <a:off x="731520" y="2743200"/>
+            <a:ext cx="7680960" cy="548640"/>
           </a:xfrm>
           <a:prstGeom prst="roundRect">
             <a:avLst>
-              <a:gd name="adj" fmla="val 50000"/>
+              <a:gd name="adj" fmla="val 13333"/>
             </a:avLst>
           </a:prstGeom>
           <a:solidFill>
-            <a:srgbClr val="00BFA6"/>
+            <a:srgbClr val="0F1419"/>
+          </a:solidFill>
+          <a:ln/>
+        </p:spPr>
+      </p:sp>
+      <p:sp>
+        <p:nvSpPr>
+          <p:cNvPr id="12" name="Text 9"/>
+          <p:cNvSpPr txBox="1"/>
+          <p:nvPr/>
+        </p:nvSpPr>
+        <p:spPr>
+          <a:xfrm>
+            <a:off x="914400" y="2743200"/>
+            <a:ext cx="411480" cy="548640"/>
+          </a:xfrm>
+          <a:prstGeom prst="roundRect">
+            <a:avLst>
+              <a:gd name="adj" fmla="val 48889"/>
+            </a:avLst>
+          </a:prstGeom>
+          <a:solidFill>
+            <a:srgbClr val="3B82F6"/>
           </a:solidFill>
           <a:ln/>
         </p:spPr>
@@ -3667,7 +4373,7 @@
               <a:buNone/>
             </a:pPr>
             <a:r>
-              <a:rPr lang="en-US" sz="1600" b="1" dirty="0">
+              <a:rPr lang="en-US" sz="1500" b="1" dirty="0">
                 <a:solidFill>
                   <a:srgbClr val="0F1419"/>
                 </a:solidFill>
@@ -3677,20 +4383,20 @@
               </a:rPr>
               <a:t>3</a:t>
             </a:r>
-            <a:endParaRPr lang="en-US" sz="1600" dirty="0"/>
-          </a:p>
-        </p:txBody>
-      </p:sp>
-      <p:sp>
-        <p:nvSpPr>
-          <p:cNvPr id="9" name="Text 7"/>
+            <a:endParaRPr lang="en-US" sz="1500" dirty="0"/>
+          </a:p>
+        </p:txBody>
+      </p:sp>
+      <p:sp>
+        <p:nvSpPr>
+          <p:cNvPr id="13" name="Text 10"/>
           <p:cNvSpPr txBox="1"/>
           <p:nvPr/>
         </p:nvSpPr>
         <p:spPr>
           <a:xfrm>
-            <a:off x="1371600" y="2871216"/>
-            <a:ext cx="7040880" cy="548640"/>
+            <a:off x="1508760" y="2743200"/>
+            <a:ext cx="6766560" cy="548640"/>
           </a:xfrm>
           <a:prstGeom prst="rect">
             <a:avLst/>
@@ -3706,7 +4412,7 @@
               <a:buNone/>
             </a:pPr>
             <a:r>
-              <a:rPr lang="en-US" sz="1400" dirty="0">
+              <a:rPr lang="en-US" sz="1300" dirty="0">
                 <a:solidFill>
                   <a:srgbClr val="FFFFFF"/>
                 </a:solidFill>
@@ -3716,28 +4422,50 @@
               </a:rPr>
               <a:t>IMMUTABILITÉ — Une fois qu'une transaction est confirmée et ajoutée à la blockchain, il est pratiquement impossible de la modifier.</a:t>
             </a:r>
-            <a:endParaRPr lang="en-US" sz="1400" dirty="0"/>
-          </a:p>
-        </p:txBody>
-      </p:sp>
-      <p:sp>
-        <p:nvSpPr>
-          <p:cNvPr id="10" name="Text 8"/>
-          <p:cNvSpPr txBox="1"/>
-          <p:nvPr/>
-        </p:nvSpPr>
-        <p:spPr>
-          <a:xfrm>
-            <a:off x="731520" y="3529584"/>
-            <a:ext cx="457200" cy="548640"/>
+            <a:endParaRPr lang="en-US" sz="1300" dirty="0"/>
+          </a:p>
+        </p:txBody>
+      </p:sp>
+      <p:sp>
+        <p:nvSpPr>
+          <p:cNvPr id="14" name="Shape 11"/>
+          <p:cNvSpPr/>
+          <p:nvPr/>
+        </p:nvSpPr>
+        <p:spPr>
+          <a:xfrm>
+            <a:off x="731520" y="3383280"/>
+            <a:ext cx="7680960" cy="548640"/>
           </a:xfrm>
           <a:prstGeom prst="roundRect">
             <a:avLst>
-              <a:gd name="adj" fmla="val 50000"/>
+              <a:gd name="adj" fmla="val 13333"/>
             </a:avLst>
           </a:prstGeom>
           <a:solidFill>
-            <a:srgbClr val="00BFA6"/>
+            <a:srgbClr val="0F1419"/>
+          </a:solidFill>
+          <a:ln/>
+        </p:spPr>
+      </p:sp>
+      <p:sp>
+        <p:nvSpPr>
+          <p:cNvPr id="15" name="Text 12"/>
+          <p:cNvSpPr txBox="1"/>
+          <p:nvPr/>
+        </p:nvSpPr>
+        <p:spPr>
+          <a:xfrm>
+            <a:off x="914400" y="3383280"/>
+            <a:ext cx="411480" cy="548640"/>
+          </a:xfrm>
+          <a:prstGeom prst="roundRect">
+            <a:avLst>
+              <a:gd name="adj" fmla="val 48889"/>
+            </a:avLst>
+          </a:prstGeom>
+          <a:solidFill>
+            <a:srgbClr val="3B82F6"/>
           </a:solidFill>
           <a:ln/>
         </p:spPr>
@@ -3749,7 +4477,7 @@
               <a:buNone/>
             </a:pPr>
             <a:r>
-              <a:rPr lang="en-US" sz="1600" b="1" dirty="0">
+              <a:rPr lang="en-US" sz="1500" b="1" dirty="0">
                 <a:solidFill>
                   <a:srgbClr val="0F1419"/>
                 </a:solidFill>
@@ -3759,20 +4487,20 @@
               </a:rPr>
               <a:t>4</a:t>
             </a:r>
-            <a:endParaRPr lang="en-US" sz="1600" dirty="0"/>
-          </a:p>
-        </p:txBody>
-      </p:sp>
-      <p:sp>
-        <p:nvSpPr>
-          <p:cNvPr id="11" name="Text 9"/>
+            <a:endParaRPr lang="en-US" sz="1500" dirty="0"/>
+          </a:p>
+        </p:txBody>
+      </p:sp>
+      <p:sp>
+        <p:nvSpPr>
+          <p:cNvPr id="16" name="Text 13"/>
           <p:cNvSpPr txBox="1"/>
           <p:nvPr/>
         </p:nvSpPr>
         <p:spPr>
           <a:xfrm>
-            <a:off x="1371600" y="3529584"/>
-            <a:ext cx="7040880" cy="548640"/>
+            <a:off x="1508760" y="3383280"/>
+            <a:ext cx="6766560" cy="548640"/>
           </a:xfrm>
           <a:prstGeom prst="rect">
             <a:avLst/>
@@ -3788,7 +4516,7 @@
               <a:buNone/>
             </a:pPr>
             <a:r>
-              <a:rPr lang="en-US" sz="1400" dirty="0">
+              <a:rPr lang="en-US" sz="1300" dirty="0">
                 <a:solidFill>
                   <a:srgbClr val="FFFFFF"/>
                 </a:solidFill>
@@ -3798,7 +4526,7 @@
               </a:rPr>
               <a:t>SÉCURITÉ — La blockchain utilise la cryptographie avancée pour sécuriser les données. Chaque bloc est lié au précédent par un hash cryptographique.</a:t>
             </a:r>
-            <a:endParaRPr lang="en-US" sz="1400" dirty="0"/>
+            <a:endParaRPr lang="en-US" sz="1300" dirty="0"/>
           </a:p>
         </p:txBody>
       </p:sp>
@@ -3834,35 +4562,105 @@
           <a:chExt cx="0" cy="0"/>
         </a:xfrm>
       </p:grpSpPr>
-      <p:sp>
-        <p:nvSpPr>
-          <p:cNvPr id="2" name="Shape 0"/>
+      <p:pic>
+        <p:nvPicPr>
+          <p:cNvPr id="2" name="Image 0" descr="preencoded.png">    </p:cNvPr>
+          <p:cNvPicPr>
+            <a:picLocks noChangeAspect="1"/>
+          </p:cNvPicPr>
+          <p:nvPr/>
+        </p:nvPicPr>
+        <p:blipFill>
+          <a:blip r:embed="rId1"/>
+          <a:stretch>
+            <a:fillRect/>
+          </a:stretch>
+        </p:blipFill>
+        <p:spPr>
+          <a:xfrm>
+            <a:off x="7315200" y="548640"/>
+            <a:ext cx="1280160" cy="1280160"/>
+          </a:xfrm>
+          <a:prstGeom prst="rect">
+            <a:avLst/>
+          </a:prstGeom>
+        </p:spPr>
+      </p:pic>
+      <p:pic>
+        <p:nvPicPr>
+          <p:cNvPr id="3" name="Image 1" descr="preencoded.png">    </p:cNvPr>
+          <p:cNvPicPr>
+            <a:picLocks noChangeAspect="1"/>
+          </p:cNvPicPr>
+          <p:nvPr/>
+        </p:nvPicPr>
+        <p:blipFill>
+          <a:blip r:embed="rId2"/>
+          <a:stretch>
+            <a:fillRect/>
+          </a:stretch>
+        </p:blipFill>
+        <p:spPr>
+          <a:xfrm>
+            <a:off x="7772400" y="2011680"/>
+            <a:ext cx="822960" cy="822960"/>
+          </a:xfrm>
+          <a:prstGeom prst="rect">
+            <a:avLst/>
+          </a:prstGeom>
+        </p:spPr>
+      </p:pic>
+      <p:sp>
+        <p:nvSpPr>
+          <p:cNvPr id="4" name="Shape 0"/>
           <p:cNvSpPr/>
           <p:nvPr/>
         </p:nvSpPr>
         <p:spPr>
           <a:xfrm>
-            <a:off x="548640" y="914400"/>
-            <a:ext cx="45720" cy="2560320"/>
-          </a:xfrm>
-          <a:prstGeom prst="rect">
+            <a:off x="6583680" y="-274320"/>
+            <a:ext cx="3200400" cy="3200400"/>
+          </a:xfrm>
+          <a:prstGeom prst="ellipse">
             <a:avLst/>
           </a:prstGeom>
           <a:solidFill>
-            <a:srgbClr val="00BFA6"/>
+            <a:srgbClr val="3B82F6">
+              <a:alpha val="6000"/>
+            </a:srgbClr>
           </a:solidFill>
           <a:ln/>
         </p:spPr>
       </p:sp>
       <p:sp>
         <p:nvSpPr>
-          <p:cNvPr id="3" name="Text 1"/>
+          <p:cNvPr id="5" name="Shape 1"/>
+          <p:cNvSpPr/>
+          <p:nvPr/>
+        </p:nvSpPr>
+        <p:spPr>
+          <a:xfrm>
+            <a:off x="731520" y="914400"/>
+            <a:ext cx="45720" cy="2194560"/>
+          </a:xfrm>
+          <a:prstGeom prst="rect">
+            <a:avLst/>
+          </a:prstGeom>
+          <a:solidFill>
+            <a:srgbClr val="3B82F6"/>
+          </a:solidFill>
+          <a:ln/>
+        </p:spPr>
+      </p:sp>
+      <p:sp>
+        <p:nvSpPr>
+          <p:cNvPr id="6" name="Text 2"/>
           <p:cNvSpPr txBox="1"/>
           <p:nvPr/>
         </p:nvSpPr>
         <p:spPr>
           <a:xfrm>
-            <a:off x="822960" y="1097280"/>
+            <a:off x="960120" y="914400"/>
             <a:ext cx="2743200" cy="365760"/>
           </a:xfrm>
           <a:prstGeom prst="rect">
@@ -3881,13 +4679,13 @@
             <a:r>
               <a:rPr lang="en-US" sz="1200" b="1" spc="200" kern="0" dirty="0">
                 <a:solidFill>
-                  <a:srgbClr val="00BFA6"/>
-                </a:solidFill>
-                <a:latin typeface="Calibri" pitchFamily="34" charset="0"/>
-                <a:ea typeface="Calibri" pitchFamily="34" charset="-122"/>
-                <a:cs typeface="Calibri" pitchFamily="34" charset="-120"/>
-              </a:rPr>
-              <a:t>Lecon 2 / 2</a:t>
+                  <a:srgbClr val="3B82F6"/>
+                </a:solidFill>
+                <a:latin typeface="Calibri" pitchFamily="34" charset="0"/>
+                <a:ea typeface="Calibri" pitchFamily="34" charset="-122"/>
+                <a:cs typeface="Calibri" pitchFamily="34" charset="-120"/>
+              </a:rPr>
+              <a:t>Leçon 2 / 2</a:t>
             </a:r>
             <a:endParaRPr lang="en-US" sz="1200" dirty="0"/>
           </a:p>
@@ -3895,14 +4693,14 @@
       </p:sp>
       <p:sp>
         <p:nvSpPr>
-          <p:cNvPr id="4" name="Text 2"/>
+          <p:cNvPr id="7" name="Text 3"/>
           <p:cNvSpPr txBox="1"/>
           <p:nvPr/>
         </p:nvSpPr>
         <p:spPr>
           <a:xfrm>
-            <a:off x="822960" y="1645920"/>
-            <a:ext cx="7498080" cy="1280160"/>
+            <a:off x="960120" y="1371600"/>
+            <a:ext cx="6217920" cy="1463040"/>
           </a:xfrm>
           <a:prstGeom prst="rect">
             <a:avLst/>
@@ -3918,7 +4716,7 @@
               <a:buNone/>
             </a:pPr>
             <a:r>
-              <a:rPr lang="en-US" sz="3000" b="1" dirty="0">
+              <a:rPr lang="en-US" sz="2800" b="1" dirty="0">
                 <a:solidFill>
                   <a:srgbClr val="FFFFFF"/>
                 </a:solidFill>
@@ -3928,19 +4726,19 @@
               </a:rPr>
               <a:t>L'histoire du Bitcoin</a:t>
             </a:r>
-            <a:endParaRPr lang="en-US" sz="3000" dirty="0"/>
-          </a:p>
-        </p:txBody>
-      </p:sp>
-      <p:sp>
-        <p:nvSpPr>
-          <p:cNvPr id="5" name="Text 3"/>
+            <a:endParaRPr lang="en-US" sz="2800" dirty="0"/>
+          </a:p>
+        </p:txBody>
+      </p:sp>
+      <p:sp>
+        <p:nvSpPr>
+          <p:cNvPr id="8" name="Text 4"/>
           <p:cNvSpPr txBox="1"/>
           <p:nvPr/>
         </p:nvSpPr>
         <p:spPr>
           <a:xfrm>
-            <a:off x="822960" y="4206240"/>
+            <a:off x="960120" y="4114800"/>
             <a:ext cx="5486400" cy="320040"/>
           </a:xfrm>
           <a:prstGeom prst="rect">
@@ -4005,7 +4803,53 @@
       </p:grpSpPr>
       <p:sp>
         <p:nvSpPr>
-          <p:cNvPr id="2" name="Text 0"/>
+          <p:cNvPr id="2" name="Shape 0"/>
+          <p:cNvSpPr/>
+          <p:nvPr/>
+        </p:nvSpPr>
+        <p:spPr>
+          <a:xfrm>
+            <a:off x="7955280" y="182880"/>
+            <a:ext cx="640080" cy="640080"/>
+          </a:xfrm>
+          <a:prstGeom prst="ellipse">
+            <a:avLst/>
+          </a:prstGeom>
+          <a:solidFill>
+            <a:srgbClr val="3B82F6">
+              <a:alpha val="12000"/>
+            </a:srgbClr>
+          </a:solidFill>
+          <a:ln/>
+        </p:spPr>
+      </p:sp>
+      <p:pic>
+        <p:nvPicPr>
+          <p:cNvPr id="3" name="Image 0" descr="preencoded.png">    </p:cNvPr>
+          <p:cNvPicPr>
+            <a:picLocks noChangeAspect="1"/>
+          </p:cNvPicPr>
+          <p:nvPr/>
+        </p:nvPicPr>
+        <p:blipFill>
+          <a:blip r:embed="rId1"/>
+          <a:stretch>
+            <a:fillRect/>
+          </a:stretch>
+        </p:blipFill>
+        <p:spPr>
+          <a:xfrm>
+            <a:off x="8028432" y="256032"/>
+            <a:ext cx="493776" cy="493776"/>
+          </a:xfrm>
+          <a:prstGeom prst="rect">
+            <a:avLst/>
+          </a:prstGeom>
+        </p:spPr>
+      </p:pic>
+      <p:sp>
+        <p:nvSpPr>
+          <p:cNvPr id="4" name="Text 1"/>
           <p:cNvSpPr txBox="1"/>
           <p:nvPr/>
         </p:nvSpPr>
@@ -4174,7 +5018,7 @@
       </p:sp>
       <p:sp>
         <p:nvSpPr>
-          <p:cNvPr id="3" name="Text 1"/>
+          <p:cNvPr id="5" name="Text 2"/>
           <p:cNvSpPr txBox="1"/>
           <p:nvPr/>
         </p:nvSpPr>
@@ -4205,7 +5049,7 @@
                 <a:ea typeface="Calibri" pitchFamily="34" charset="-122"/>
                 <a:cs typeface="Calibri" pitchFamily="34" charset="-120"/>
               </a:rPr>
-              <a:t>Module 1 — Lecon 2</a:t>
+              <a:t>Module 1 — Leçon 2</a:t>
             </a:r>
             <a:endParaRPr lang="en-US" sz="900" dirty="0"/>
           </a:p>
@@ -4245,7 +5089,53 @@
       </p:grpSpPr>
       <p:sp>
         <p:nvSpPr>
-          <p:cNvPr id="2" name="Text 0"/>
+          <p:cNvPr id="2" name="Shape 0"/>
+          <p:cNvSpPr/>
+          <p:nvPr/>
+        </p:nvSpPr>
+        <p:spPr>
+          <a:xfrm>
+            <a:off x="7955280" y="182880"/>
+            <a:ext cx="640080" cy="640080"/>
+          </a:xfrm>
+          <a:prstGeom prst="ellipse">
+            <a:avLst/>
+          </a:prstGeom>
+          <a:solidFill>
+            <a:srgbClr val="3B82F6">
+              <a:alpha val="12000"/>
+            </a:srgbClr>
+          </a:solidFill>
+          <a:ln/>
+        </p:spPr>
+      </p:sp>
+      <p:pic>
+        <p:nvPicPr>
+          <p:cNvPr id="3" name="Image 0" descr="preencoded.png">    </p:cNvPr>
+          <p:cNvPicPr>
+            <a:picLocks noChangeAspect="1"/>
+          </p:cNvPicPr>
+          <p:nvPr/>
+        </p:nvPicPr>
+        <p:blipFill>
+          <a:blip r:embed="rId1"/>
+          <a:stretch>
+            <a:fillRect/>
+          </a:stretch>
+        </p:blipFill>
+        <p:spPr>
+          <a:xfrm>
+            <a:off x="8028432" y="256032"/>
+            <a:ext cx="493776" cy="493776"/>
+          </a:xfrm>
+          <a:prstGeom prst="rect">
+            <a:avLst/>
+          </a:prstGeom>
+        </p:spPr>
+      </p:pic>
+      <p:sp>
+        <p:nvSpPr>
+          <p:cNvPr id="4" name="Text 1"/>
           <p:cNvSpPr txBox="1"/>
           <p:nvPr/>
         </p:nvSpPr>
@@ -4309,7 +5199,7 @@
       </p:sp>
       <p:sp>
         <p:nvSpPr>
-          <p:cNvPr id="3" name="Text 1"/>
+          <p:cNvPr id="5" name="Text 2"/>
           <p:cNvSpPr txBox="1"/>
           <p:nvPr/>
         </p:nvSpPr>
@@ -4340,7 +5230,7 @@
                 <a:ea typeface="Calibri" pitchFamily="34" charset="-122"/>
                 <a:cs typeface="Calibri" pitchFamily="34" charset="-120"/>
               </a:rPr>
-              <a:t>Module 1 — Lecon 2</a:t>
+              <a:t>Module 1 — Leçon 2</a:t>
             </a:r>
             <a:endParaRPr lang="en-US" sz="900" dirty="0"/>
           </a:p>

</xml_diff>

<commit_message>
feat(academy): quiz system, section-based lessons, brand-toned materials (#44)
- Quiz system: DB tables, admin QuizEditor per module, student QuizPlayer with intro/take/result flow
- Section-based LessonViewer replacing infinite scroll (TOC sidebar desktop, pills mobile)
- Polished catalog with course cover images
- Course cover_url + module summary fields
- Regenerated PDFs/PPTX in Terex teal brand palette (monochrome, no rainbow)
</commit_message>
<xml_diff>
--- a/public/course-materials/pptx/Module-01-Les-fondamentaux-de-la-blockchain.pptx
+++ b/public/course-materials/pptx/Module-01-Les-fondamentaux-de-la-blockchain.pptx
@@ -1747,7 +1747,7 @@
     <p:bg>
       <p:bgPr>
         <a:solidFill>
-          <a:srgbClr val="0F1419"/>
+          <a:srgbClr val="0F1214"/>
         </a:solidFill>
       </p:bgPr>
     </p:bg>
@@ -1780,7 +1780,7 @@
             <a:avLst/>
           </a:prstGeom>
           <a:solidFill>
-            <a:srgbClr val="3B82F6">
+            <a:srgbClr val="3B968F">
               <a:alpha val="8000"/>
             </a:srgbClr>
           </a:solidFill>
@@ -1802,7 +1802,7 @@
             <a:avLst/>
           </a:prstGeom>
           <a:solidFill>
-            <a:srgbClr val="3B82F6">
+            <a:srgbClr val="3B968F">
               <a:alpha val="5000"/>
             </a:srgbClr>
           </a:solidFill>
@@ -1824,7 +1824,7 @@
             <a:avLst/>
           </a:prstGeom>
           <a:solidFill>
-            <a:srgbClr val="3B82F6"/>
+            <a:srgbClr val="3B968F"/>
           </a:solidFill>
           <a:ln/>
         </p:spPr>
@@ -1880,7 +1880,7 @@
             <a:r>
               <a:rPr lang="en-US" sz="1300" b="1" spc="400" kern="0" dirty="0">
                 <a:solidFill>
-                  <a:srgbClr val="3B82F6"/>
+                  <a:srgbClr val="3B968F"/>
                 </a:solidFill>
                 <a:latin typeface="Calibri" pitchFamily="34" charset="0"/>
                 <a:ea typeface="Calibri" pitchFamily="34" charset="-122"/>
@@ -1946,7 +1946,7 @@
             <a:avLst/>
           </a:prstGeom>
           <a:solidFill>
-            <a:srgbClr val="3B82F6"/>
+            <a:srgbClr val="3B968F"/>
           </a:solidFill>
           <a:ln/>
         </p:spPr>
@@ -1978,7 +1978,7 @@
             <a:r>
               <a:rPr lang="en-US" sz="1100" spc="300" kern="0" dirty="0">
                 <a:solidFill>
-                  <a:srgbClr val="64748B"/>
+                  <a:srgbClr val="5B6672"/>
                 </a:solidFill>
                 <a:latin typeface="Calibri" pitchFamily="34" charset="0"/>
                 <a:ea typeface="Calibri" pitchFamily="34" charset="-122"/>
@@ -2017,7 +2017,7 @@
             <a:r>
               <a:rPr lang="en-US" sz="1100" dirty="0">
                 <a:solidFill>
-                  <a:srgbClr val="94A3B8"/>
+                  <a:srgbClr val="8994A0"/>
                 </a:solidFill>
                 <a:latin typeface="Calibri" pitchFamily="34" charset="0"/>
                 <a:ea typeface="Calibri" pitchFamily="34" charset="-122"/>
@@ -2043,7 +2043,7 @@
     <p:bg>
       <p:bgPr>
         <a:solidFill>
-          <a:srgbClr val="1A2332"/>
+          <a:srgbClr val="1A2026"/>
         </a:solidFill>
       </p:bgPr>
     </p:bg>
@@ -2112,7 +2112,7 @@
             <a:r>
               <a:rPr lang="en-US" sz="1200" b="1" spc="300" kern="0" dirty="0">
                 <a:solidFill>
-                  <a:srgbClr val="F59E0B"/>
+                  <a:srgbClr val="5BC1B8"/>
                 </a:solidFill>
                 <a:latin typeface="Calibri" pitchFamily="34" charset="0"/>
                 <a:ea typeface="Calibri" pitchFamily="34" charset="-122"/>
@@ -2180,7 +2180,7 @@
             </a:avLst>
           </a:prstGeom>
           <a:solidFill>
-            <a:srgbClr val="0F1419"/>
+            <a:srgbClr val="0F1214"/>
           </a:solidFill>
           <a:ln/>
         </p:spPr>
@@ -2202,7 +2202,7 @@
             </a:avLst>
           </a:prstGeom>
           <a:solidFill>
-            <a:srgbClr val="3B82F6"/>
+            <a:srgbClr val="3B968F"/>
           </a:solidFill>
           <a:ln/>
         </p:spPr>
@@ -2216,7 +2216,7 @@
             <a:r>
               <a:rPr lang="en-US" sz="1500" b="1" dirty="0">
                 <a:solidFill>
-                  <a:srgbClr val="0F1419"/>
+                  <a:srgbClr val="0F1214"/>
                 </a:solidFill>
                 <a:latin typeface="Calibri" pitchFamily="34" charset="0"/>
                 <a:ea typeface="Calibri" pitchFamily="34" charset="-122"/>
@@ -2284,7 +2284,7 @@
             </a:avLst>
           </a:prstGeom>
           <a:solidFill>
-            <a:srgbClr val="0F1419"/>
+            <a:srgbClr val="0F1214"/>
           </a:solidFill>
           <a:ln/>
         </p:spPr>
@@ -2306,7 +2306,7 @@
             </a:avLst>
           </a:prstGeom>
           <a:solidFill>
-            <a:srgbClr val="3B82F6"/>
+            <a:srgbClr val="3B968F"/>
           </a:solidFill>
           <a:ln/>
         </p:spPr>
@@ -2320,7 +2320,7 @@
             <a:r>
               <a:rPr lang="en-US" sz="1500" b="1" dirty="0">
                 <a:solidFill>
-                  <a:srgbClr val="0F1419"/>
+                  <a:srgbClr val="0F1214"/>
                 </a:solidFill>
                 <a:latin typeface="Calibri" pitchFamily="34" charset="0"/>
                 <a:ea typeface="Calibri" pitchFamily="34" charset="-122"/>
@@ -2388,7 +2388,7 @@
             </a:avLst>
           </a:prstGeom>
           <a:solidFill>
-            <a:srgbClr val="0F1419"/>
+            <a:srgbClr val="0F1214"/>
           </a:solidFill>
           <a:ln/>
         </p:spPr>
@@ -2410,7 +2410,7 @@
             </a:avLst>
           </a:prstGeom>
           <a:solidFill>
-            <a:srgbClr val="3B82F6"/>
+            <a:srgbClr val="3B968F"/>
           </a:solidFill>
           <a:ln/>
         </p:spPr>
@@ -2424,7 +2424,7 @@
             <a:r>
               <a:rPr lang="en-US" sz="1500" b="1" dirty="0">
                 <a:solidFill>
-                  <a:srgbClr val="0F1419"/>
+                  <a:srgbClr val="0F1214"/>
                 </a:solidFill>
                 <a:latin typeface="Calibri" pitchFamily="34" charset="0"/>
                 <a:ea typeface="Calibri" pitchFamily="34" charset="-122"/>
@@ -2492,7 +2492,7 @@
             </a:avLst>
           </a:prstGeom>
           <a:solidFill>
-            <a:srgbClr val="0F1419"/>
+            <a:srgbClr val="0F1214"/>
           </a:solidFill>
           <a:ln/>
         </p:spPr>
@@ -2514,7 +2514,7 @@
             </a:avLst>
           </a:prstGeom>
           <a:solidFill>
-            <a:srgbClr val="3B82F6"/>
+            <a:srgbClr val="3B968F"/>
           </a:solidFill>
           <a:ln/>
         </p:spPr>
@@ -2528,7 +2528,7 @@
             <a:r>
               <a:rPr lang="en-US" sz="1500" b="1" dirty="0">
                 <a:solidFill>
-                  <a:srgbClr val="0F1419"/>
+                  <a:srgbClr val="0F1214"/>
                 </a:solidFill>
                 <a:latin typeface="Calibri" pitchFamily="34" charset="0"/>
                 <a:ea typeface="Calibri" pitchFamily="34" charset="-122"/>
@@ -2596,7 +2596,7 @@
             </a:avLst>
           </a:prstGeom>
           <a:solidFill>
-            <a:srgbClr val="0F1419"/>
+            <a:srgbClr val="0F1214"/>
           </a:solidFill>
           <a:ln/>
         </p:spPr>
@@ -2618,7 +2618,7 @@
             </a:avLst>
           </a:prstGeom>
           <a:solidFill>
-            <a:srgbClr val="3B82F6"/>
+            <a:srgbClr val="3B968F"/>
           </a:solidFill>
           <a:ln/>
         </p:spPr>
@@ -2632,7 +2632,7 @@
             <a:r>
               <a:rPr lang="en-US" sz="1500" b="1" dirty="0">
                 <a:solidFill>
-                  <a:srgbClr val="0F1419"/>
+                  <a:srgbClr val="0F1214"/>
                 </a:solidFill>
                 <a:latin typeface="Calibri" pitchFamily="34" charset="0"/>
                 <a:ea typeface="Calibri" pitchFamily="34" charset="-122"/>
@@ -2697,7 +2697,7 @@
     <p:bg>
       <p:bgPr>
         <a:solidFill>
-          <a:srgbClr val="0F1419"/>
+          <a:srgbClr val="0F1214"/>
         </a:solidFill>
       </p:bgPr>
     </p:bg>
@@ -2730,7 +2730,7 @@
             <a:avLst/>
           </a:prstGeom>
           <a:solidFill>
-            <a:srgbClr val="3B82F6">
+            <a:srgbClr val="3B968F">
               <a:alpha val="6000"/>
             </a:srgbClr>
           </a:solidFill>
@@ -2827,7 +2827,7 @@
             <a:r>
               <a:rPr lang="en-US" sz="1300" dirty="0">
                 <a:solidFill>
-                  <a:srgbClr val="94A3B8"/>
+                  <a:srgbClr val="8994A0"/>
                 </a:solidFill>
                 <a:latin typeface="Calibri" pitchFamily="34" charset="0"/>
                 <a:ea typeface="Calibri" pitchFamily="34" charset="-122"/>
@@ -2854,7 +2854,7 @@
             <a:avLst/>
           </a:prstGeom>
           <a:solidFill>
-            <a:srgbClr val="3B82F6"/>
+            <a:srgbClr val="3B968F"/>
           </a:solidFill>
           <a:ln/>
         </p:spPr>
@@ -2886,7 +2886,7 @@
             <a:r>
               <a:rPr lang="en-US" sz="1100" spc="300" kern="0" dirty="0">
                 <a:solidFill>
-                  <a:srgbClr val="64748B"/>
+                  <a:srgbClr val="5B6672"/>
                 </a:solidFill>
                 <a:latin typeface="Calibri" pitchFamily="34" charset="0"/>
                 <a:ea typeface="Calibri" pitchFamily="34" charset="-122"/>
@@ -2925,7 +2925,7 @@
             <a:r>
               <a:rPr lang="en-US" sz="1100" dirty="0">
                 <a:solidFill>
-                  <a:srgbClr val="009E8B"/>
+                  <a:srgbClr val="000000"/>
                 </a:solidFill>
                 <a:latin typeface="Calibri" pitchFamily="34" charset="0"/>
                 <a:ea typeface="Calibri" pitchFamily="34" charset="-122"/>
@@ -2951,7 +2951,7 @@
     <p:bg>
       <p:bgPr>
         <a:solidFill>
-          <a:srgbClr val="0F1419"/>
+          <a:srgbClr val="0F1214"/>
         </a:solidFill>
       </p:bgPr>
     </p:bg>
@@ -2996,7 +2996,7 @@
             <a:r>
               <a:rPr lang="en-US" sz="1200" b="1" spc="300" kern="0" dirty="0">
                 <a:solidFill>
-                  <a:srgbClr val="3B82F6"/>
+                  <a:srgbClr val="3B968F"/>
                 </a:solidFill>
                 <a:latin typeface="Calibri" pitchFamily="34" charset="0"/>
                 <a:ea typeface="Calibri" pitchFamily="34" charset="-122"/>
@@ -3064,7 +3064,7 @@
             </a:avLst>
           </a:prstGeom>
           <a:solidFill>
-            <a:srgbClr val="1A2332"/>
+            <a:srgbClr val="1A2026"/>
           </a:solidFill>
           <a:ln/>
         </p:spPr>
@@ -3096,7 +3096,7 @@
             <a:r>
               <a:rPr lang="en-US" sz="1300" b="1" dirty="0">
                 <a:solidFill>
-                  <a:srgbClr val="3B82F6"/>
+                  <a:srgbClr val="3B968F"/>
                 </a:solidFill>
                 <a:latin typeface="Calibri" pitchFamily="34" charset="0"/>
                 <a:ea typeface="Calibri" pitchFamily="34" charset="-122"/>
@@ -3188,7 +3188,7 @@
             </a:avLst>
           </a:prstGeom>
           <a:solidFill>
-            <a:srgbClr val="1A2332"/>
+            <a:srgbClr val="1A2026"/>
           </a:solidFill>
           <a:ln/>
         </p:spPr>
@@ -3220,7 +3220,7 @@
             <a:r>
               <a:rPr lang="en-US" sz="1300" b="1" dirty="0">
                 <a:solidFill>
-                  <a:srgbClr val="3B82F6"/>
+                  <a:srgbClr val="3B968F"/>
                 </a:solidFill>
                 <a:latin typeface="Calibri" pitchFamily="34" charset="0"/>
                 <a:ea typeface="Calibri" pitchFamily="34" charset="-122"/>
@@ -3309,7 +3309,7 @@
     <p:bg>
       <p:bgPr>
         <a:solidFill>
-          <a:srgbClr val="0D2137"/>
+          <a:srgbClr val="12181D"/>
         </a:solidFill>
       </p:bgPr>
     </p:bg>
@@ -3390,7 +3390,7 @@
             <a:avLst/>
           </a:prstGeom>
           <a:solidFill>
-            <a:srgbClr val="3B82F6">
+            <a:srgbClr val="3B968F">
               <a:alpha val="6000"/>
             </a:srgbClr>
           </a:solidFill>
@@ -3412,7 +3412,7 @@
             <a:avLst/>
           </a:prstGeom>
           <a:solidFill>
-            <a:srgbClr val="3B82F6"/>
+            <a:srgbClr val="3B968F"/>
           </a:solidFill>
           <a:ln/>
         </p:spPr>
@@ -3444,7 +3444,7 @@
             <a:r>
               <a:rPr lang="en-US" sz="1200" b="1" spc="200" kern="0" dirty="0">
                 <a:solidFill>
-                  <a:srgbClr val="3B82F6"/>
+                  <a:srgbClr val="3B968F"/>
                 </a:solidFill>
                 <a:latin typeface="Calibri" pitchFamily="34" charset="0"/>
                 <a:ea typeface="Calibri" pitchFamily="34" charset="-122"/>
@@ -3522,7 +3522,7 @@
             <a:r>
               <a:rPr lang="en-US" sz="1100" dirty="0">
                 <a:solidFill>
-                  <a:srgbClr val="64748B"/>
+                  <a:srgbClr val="5B6672"/>
                 </a:solidFill>
                 <a:latin typeface="Calibri" pitchFamily="34" charset="0"/>
                 <a:ea typeface="Calibri" pitchFamily="34" charset="-122"/>
@@ -3548,7 +3548,7 @@
     <p:bg>
       <p:bgPr>
         <a:solidFill>
-          <a:srgbClr val="0F1419"/>
+          <a:srgbClr val="0F1214"/>
         </a:solidFill>
       </p:bgPr>
     </p:bg>
@@ -3581,7 +3581,7 @@
             <a:avLst/>
           </a:prstGeom>
           <a:solidFill>
-            <a:srgbClr val="3B82F6">
+            <a:srgbClr val="3B968F">
               <a:alpha val="12000"/>
             </a:srgbClr>
           </a:solidFill>
@@ -3808,7 +3808,7 @@
             <a:r>
               <a:rPr lang="en-US" sz="900" dirty="0">
                 <a:solidFill>
-                  <a:srgbClr val="64748B"/>
+                  <a:srgbClr val="5B6672"/>
                 </a:solidFill>
                 <a:latin typeface="Calibri" pitchFamily="34" charset="0"/>
                 <a:ea typeface="Calibri" pitchFamily="34" charset="-122"/>
@@ -3834,7 +3834,7 @@
     <p:bg>
       <p:bgPr>
         <a:solidFill>
-          <a:srgbClr val="0F1419"/>
+          <a:srgbClr val="0F1214"/>
         </a:solidFill>
       </p:bgPr>
     </p:bg>
@@ -3867,7 +3867,7 @@
             <a:avLst/>
           </a:prstGeom>
           <a:solidFill>
-            <a:srgbClr val="3B82F6">
+            <a:srgbClr val="3B968F">
               <a:alpha val="12000"/>
             </a:srgbClr>
           </a:solidFill>
@@ -3968,7 +3968,7 @@
             <a:r>
               <a:rPr lang="en-US" sz="900" dirty="0">
                 <a:solidFill>
-                  <a:srgbClr val="64748B"/>
+                  <a:srgbClr val="5B6672"/>
                 </a:solidFill>
                 <a:latin typeface="Calibri" pitchFamily="34" charset="0"/>
                 <a:ea typeface="Calibri" pitchFamily="34" charset="-122"/>
@@ -3994,7 +3994,7 @@
     <p:bg>
       <p:bgPr>
         <a:solidFill>
-          <a:srgbClr val="1A2332"/>
+          <a:srgbClr val="1A2026"/>
         </a:solidFill>
       </p:bgPr>
     </p:bg>
@@ -4063,7 +4063,7 @@
             <a:r>
               <a:rPr lang="en-US" sz="1200" b="1" spc="300" kern="0" dirty="0">
                 <a:solidFill>
-                  <a:srgbClr val="F59E0B"/>
+                  <a:srgbClr val="5BC1B8"/>
                 </a:solidFill>
                 <a:latin typeface="Calibri" pitchFamily="34" charset="0"/>
                 <a:ea typeface="Calibri" pitchFamily="34" charset="-122"/>
@@ -4131,7 +4131,7 @@
             </a:avLst>
           </a:prstGeom>
           <a:solidFill>
-            <a:srgbClr val="0F1419"/>
+            <a:srgbClr val="0F1214"/>
           </a:solidFill>
           <a:ln/>
         </p:spPr>
@@ -4153,7 +4153,7 @@
             </a:avLst>
           </a:prstGeom>
           <a:solidFill>
-            <a:srgbClr val="3B82F6"/>
+            <a:srgbClr val="3B968F"/>
           </a:solidFill>
           <a:ln/>
         </p:spPr>
@@ -4167,7 +4167,7 @@
             <a:r>
               <a:rPr lang="en-US" sz="1500" b="1" dirty="0">
                 <a:solidFill>
-                  <a:srgbClr val="0F1419"/>
+                  <a:srgbClr val="0F1214"/>
                 </a:solidFill>
                 <a:latin typeface="Calibri" pitchFamily="34" charset="0"/>
                 <a:ea typeface="Calibri" pitchFamily="34" charset="-122"/>
@@ -4235,7 +4235,7 @@
             </a:avLst>
           </a:prstGeom>
           <a:solidFill>
-            <a:srgbClr val="0F1419"/>
+            <a:srgbClr val="0F1214"/>
           </a:solidFill>
           <a:ln/>
         </p:spPr>
@@ -4257,7 +4257,7 @@
             </a:avLst>
           </a:prstGeom>
           <a:solidFill>
-            <a:srgbClr val="3B82F6"/>
+            <a:srgbClr val="3B968F"/>
           </a:solidFill>
           <a:ln/>
         </p:spPr>
@@ -4271,7 +4271,7 @@
             <a:r>
               <a:rPr lang="en-US" sz="1500" b="1" dirty="0">
                 <a:solidFill>
-                  <a:srgbClr val="0F1419"/>
+                  <a:srgbClr val="0F1214"/>
                 </a:solidFill>
                 <a:latin typeface="Calibri" pitchFamily="34" charset="0"/>
                 <a:ea typeface="Calibri" pitchFamily="34" charset="-122"/>
@@ -4339,7 +4339,7 @@
             </a:avLst>
           </a:prstGeom>
           <a:solidFill>
-            <a:srgbClr val="0F1419"/>
+            <a:srgbClr val="0F1214"/>
           </a:solidFill>
           <a:ln/>
         </p:spPr>
@@ -4361,7 +4361,7 @@
             </a:avLst>
           </a:prstGeom>
           <a:solidFill>
-            <a:srgbClr val="3B82F6"/>
+            <a:srgbClr val="3B968F"/>
           </a:solidFill>
           <a:ln/>
         </p:spPr>
@@ -4375,7 +4375,7 @@
             <a:r>
               <a:rPr lang="en-US" sz="1500" b="1" dirty="0">
                 <a:solidFill>
-                  <a:srgbClr val="0F1419"/>
+                  <a:srgbClr val="0F1214"/>
                 </a:solidFill>
                 <a:latin typeface="Calibri" pitchFamily="34" charset="0"/>
                 <a:ea typeface="Calibri" pitchFamily="34" charset="-122"/>
@@ -4443,7 +4443,7 @@
             </a:avLst>
           </a:prstGeom>
           <a:solidFill>
-            <a:srgbClr val="0F1419"/>
+            <a:srgbClr val="0F1214"/>
           </a:solidFill>
           <a:ln/>
         </p:spPr>
@@ -4465,7 +4465,7 @@
             </a:avLst>
           </a:prstGeom>
           <a:solidFill>
-            <a:srgbClr val="3B82F6"/>
+            <a:srgbClr val="3B968F"/>
           </a:solidFill>
           <a:ln/>
         </p:spPr>
@@ -4479,7 +4479,7 @@
             <a:r>
               <a:rPr lang="en-US" sz="1500" b="1" dirty="0">
                 <a:solidFill>
-                  <a:srgbClr val="0F1419"/>
+                  <a:srgbClr val="0F1214"/>
                 </a:solidFill>
                 <a:latin typeface="Calibri" pitchFamily="34" charset="0"/>
                 <a:ea typeface="Calibri" pitchFamily="34" charset="-122"/>
@@ -4544,7 +4544,7 @@
     <p:bg>
       <p:bgPr>
         <a:solidFill>
-          <a:srgbClr val="0D2137"/>
+          <a:srgbClr val="12181D"/>
         </a:solidFill>
       </p:bgPr>
     </p:bg>
@@ -4625,7 +4625,7 @@
             <a:avLst/>
           </a:prstGeom>
           <a:solidFill>
-            <a:srgbClr val="3B82F6">
+            <a:srgbClr val="3B968F">
               <a:alpha val="6000"/>
             </a:srgbClr>
           </a:solidFill>
@@ -4647,7 +4647,7 @@
             <a:avLst/>
           </a:prstGeom>
           <a:solidFill>
-            <a:srgbClr val="3B82F6"/>
+            <a:srgbClr val="3B968F"/>
           </a:solidFill>
           <a:ln/>
         </p:spPr>
@@ -4679,7 +4679,7 @@
             <a:r>
               <a:rPr lang="en-US" sz="1200" b="1" spc="200" kern="0" dirty="0">
                 <a:solidFill>
-                  <a:srgbClr val="3B82F6"/>
+                  <a:srgbClr val="3B968F"/>
                 </a:solidFill>
                 <a:latin typeface="Calibri" pitchFamily="34" charset="0"/>
                 <a:ea typeface="Calibri" pitchFamily="34" charset="-122"/>
@@ -4757,7 +4757,7 @@
             <a:r>
               <a:rPr lang="en-US" sz="1100" dirty="0">
                 <a:solidFill>
-                  <a:srgbClr val="64748B"/>
+                  <a:srgbClr val="5B6672"/>
                 </a:solidFill>
                 <a:latin typeface="Calibri" pitchFamily="34" charset="0"/>
                 <a:ea typeface="Calibri" pitchFamily="34" charset="-122"/>
@@ -4783,7 +4783,7 @@
     <p:bg>
       <p:bgPr>
         <a:solidFill>
-          <a:srgbClr val="0F1419"/>
+          <a:srgbClr val="0F1214"/>
         </a:solidFill>
       </p:bgPr>
     </p:bg>
@@ -4816,7 +4816,7 @@
             <a:avLst/>
           </a:prstGeom>
           <a:solidFill>
-            <a:srgbClr val="3B82F6">
+            <a:srgbClr val="3B968F">
               <a:alpha val="12000"/>
             </a:srgbClr>
           </a:solidFill>
@@ -5043,7 +5043,7 @@
             <a:r>
               <a:rPr lang="en-US" sz="900" dirty="0">
                 <a:solidFill>
-                  <a:srgbClr val="64748B"/>
+                  <a:srgbClr val="5B6672"/>
                 </a:solidFill>
                 <a:latin typeface="Calibri" pitchFamily="34" charset="0"/>
                 <a:ea typeface="Calibri" pitchFamily="34" charset="-122"/>
@@ -5069,7 +5069,7 @@
     <p:bg>
       <p:bgPr>
         <a:solidFill>
-          <a:srgbClr val="0F1419"/>
+          <a:srgbClr val="0F1214"/>
         </a:solidFill>
       </p:bgPr>
     </p:bg>
@@ -5102,7 +5102,7 @@
             <a:avLst/>
           </a:prstGeom>
           <a:solidFill>
-            <a:srgbClr val="3B82F6">
+            <a:srgbClr val="3B968F">
               <a:alpha val="12000"/>
             </a:srgbClr>
           </a:solidFill>
@@ -5224,7 +5224,7 @@
             <a:r>
               <a:rPr lang="en-US" sz="900" dirty="0">
                 <a:solidFill>
-                  <a:srgbClr val="64748B"/>
+                  <a:srgbClr val="5B6672"/>
                 </a:solidFill>
                 <a:latin typeface="Calibri" pitchFamily="34" charset="0"/>
                 <a:ea typeface="Calibri" pitchFamily="34" charset="-122"/>

</xml_diff>